<commit_message>
Remove redundant overview value slide
</commit_message>
<xml_diff>
--- a/evaluation/dashboard/public/decks/uxl-skills-maintainer-overview.pptx
+++ b/evaluation/dashboard/public/decks/uxl-skills-maintainer-overview.pptx
@@ -2,27 +2,26 @@
 <file path=ppt/presentation.xml><?xml version="1.0" encoding="utf-8"?>
 <p:presentation xmlns:p="http://schemas.openxmlformats.org/presentationml/2006/main">
   <p:sldMasterIdLst>
-    <p:sldMasterId xmlns:r="http://schemas.openxmlformats.org/officeDocument/2006/relationships" id="2147483648" r:id="Rb04ab14f6340413d"/>
-    <p:sldMasterId xmlns:r="http://schemas.openxmlformats.org/officeDocument/2006/relationships" id="2147483665" r:id="R9ef28bf0220847af"/>
+    <p:sldMasterId xmlns:r="http://schemas.openxmlformats.org/officeDocument/2006/relationships" id="2147483648" r:id="Rb7987ec1b83443e2"/>
+    <p:sldMasterId xmlns:r="http://schemas.openxmlformats.org/officeDocument/2006/relationships" id="2147483665" r:id="R3f71cc09775c4d41"/>
   </p:sldMasterIdLst>
   <p:notesMasterIdLst>
-    <p:notesMasterId xmlns:r="http://schemas.openxmlformats.org/officeDocument/2006/relationships" r:id="R1045e4d21f9d45cb"/>
+    <p:notesMasterId xmlns:r="http://schemas.openxmlformats.org/officeDocument/2006/relationships" r:id="R006e1c0d7bfc41d0"/>
   </p:notesMasterIdLst>
   <p:sldIdLst>
-    <p:sldId xmlns:r="http://schemas.openxmlformats.org/officeDocument/2006/relationships" id="256" r:id="Rdbf65bf85e3e419a"/>
-    <p:sldId xmlns:r="http://schemas.openxmlformats.org/officeDocument/2006/relationships" id="257" r:id="Ra1cfdfc77c1a4a06"/>
-    <p:sldId xmlns:r="http://schemas.openxmlformats.org/officeDocument/2006/relationships" id="258" r:id="R7849342483df4203"/>
-    <p:sldId xmlns:r="http://schemas.openxmlformats.org/officeDocument/2006/relationships" id="259" r:id="R3ca2e63c9c72454d"/>
-    <p:sldId xmlns:r="http://schemas.openxmlformats.org/officeDocument/2006/relationships" id="260" r:id="R1604e088bc434c66"/>
-    <p:sldId xmlns:r="http://schemas.openxmlformats.org/officeDocument/2006/relationships" id="261" r:id="R808c294f49fc4c7e"/>
-    <p:sldId xmlns:r="http://schemas.openxmlformats.org/officeDocument/2006/relationships" id="262" r:id="R6bb97aaef4964d6b"/>
-    <p:sldId xmlns:r="http://schemas.openxmlformats.org/officeDocument/2006/relationships" id="263" r:id="R64e7ae382900412d"/>
-    <p:sldId xmlns:r="http://schemas.openxmlformats.org/officeDocument/2006/relationships" id="264" r:id="Rf5b8753be56147b2"/>
-    <p:sldId xmlns:r="http://schemas.openxmlformats.org/officeDocument/2006/relationships" id="265" r:id="R561d481371bc4bf5"/>
-    <p:sldId xmlns:r="http://schemas.openxmlformats.org/officeDocument/2006/relationships" id="266" r:id="R78ce0dfbc3dd4cc4"/>
-    <p:sldId xmlns:r="http://schemas.openxmlformats.org/officeDocument/2006/relationships" id="267" r:id="R7ccdf4035d594eb3"/>
-    <p:sldId xmlns:r="http://schemas.openxmlformats.org/officeDocument/2006/relationships" id="268" r:id="R0e6f8d53c52d46fa"/>
-    <p:sldId xmlns:r="http://schemas.openxmlformats.org/officeDocument/2006/relationships" id="269" r:id="R4d62926fd4eb4f05"/>
+    <p:sldId xmlns:r="http://schemas.openxmlformats.org/officeDocument/2006/relationships" id="256" r:id="Rd68fa7d113a44cb7"/>
+    <p:sldId xmlns:r="http://schemas.openxmlformats.org/officeDocument/2006/relationships" id="257" r:id="Rdf728d02f3b34286"/>
+    <p:sldId xmlns:r="http://schemas.openxmlformats.org/officeDocument/2006/relationships" id="258" r:id="R363bc56305524a17"/>
+    <p:sldId xmlns:r="http://schemas.openxmlformats.org/officeDocument/2006/relationships" id="259" r:id="R9e4eaeb703cd489b"/>
+    <p:sldId xmlns:r="http://schemas.openxmlformats.org/officeDocument/2006/relationships" id="260" r:id="R57934278e2154449"/>
+    <p:sldId xmlns:r="http://schemas.openxmlformats.org/officeDocument/2006/relationships" id="261" r:id="R0ae8eede21e3454a"/>
+    <p:sldId xmlns:r="http://schemas.openxmlformats.org/officeDocument/2006/relationships" id="262" r:id="R74045f904dbe4b5a"/>
+    <p:sldId xmlns:r="http://schemas.openxmlformats.org/officeDocument/2006/relationships" id="263" r:id="R713fef35e0af47e9"/>
+    <p:sldId xmlns:r="http://schemas.openxmlformats.org/officeDocument/2006/relationships" id="264" r:id="R318cc05d65ef47f9"/>
+    <p:sldId xmlns:r="http://schemas.openxmlformats.org/officeDocument/2006/relationships" id="265" r:id="R9d786669acaf49f3"/>
+    <p:sldId xmlns:r="http://schemas.openxmlformats.org/officeDocument/2006/relationships" id="266" r:id="Rb6ab8f3aab034b5b"/>
+    <p:sldId xmlns:r="http://schemas.openxmlformats.org/officeDocument/2006/relationships" id="267" r:id="R0838bc8c3d5b40d4"/>
+    <p:sldId xmlns:r="http://schemas.openxmlformats.org/officeDocument/2006/relationships" id="268" r:id="R67704bed905345a0"/>
   </p:sldIdLst>
   <p:sldSz cx="12192000" cy="6858000"/>
   <p:notesSz cx="6858000" cy="9144000"/>
@@ -656,7 +655,7 @@
           </a:p>
           <a:p xmlns:a="http://schemas.openxmlformats.org/drawingml/2006/main">
             <a:r>
-              <a:t>Speaker cue: Maintainer pushback is expected — and the answer is scoped evidence</a:t>
+              <a:t>Speaker cue: Hardware is a pluggable evidence lane — never the product</a:t>
             </a:r>
           </a:p>
         </p:txBody>
@@ -776,7 +775,7 @@
           </a:p>
           <a:p xmlns:a="http://schemas.openxmlformats.org/drawingml/2006/main">
             <a:r>
-              <a:t>Speaker cue: Hardware is a pluggable evidence lane — never the product</a:t>
+              <a:t>Speaker cue: The ongoing maintainer workflow fits normal GitHub practice</a:t>
             </a:r>
           </a:p>
         </p:txBody>
@@ -896,7 +895,7 @@
           </a:p>
           <a:p xmlns:a="http://schemas.openxmlformats.org/drawingml/2006/main">
             <a:r>
-              <a:t>Speaker cue: The ongoing maintainer workflow fits normal GitHub practice</a:t>
+              <a:t>Speaker cue: Ownership is intentionally split</a:t>
             </a:r>
           </a:p>
         </p:txBody>
@@ -1016,126 +1015,6 @@
           </a:p>
           <a:p xmlns:a="http://schemas.openxmlformats.org/drawingml/2006/main">
             <a:r>
-              <a:t>Speaker cue: Ownership is intentionally split</a:t>
-            </a:r>
-          </a:p>
-        </p:txBody>
-      </p:sp>
-      <p:sp>
-        <p:nvSpPr>
-          <p:cNvPr id="4" name="Slide Number Placeholder 3"/>
-          <p:cNvSpPr>
-            <a:spLocks xmlns:a="http://schemas.openxmlformats.org/drawingml/2006/main" noGrp="1"/>
-          </p:cNvSpPr>
-          <p:nvPr>
-            <p:ph type="sldNum" idx="5"/>
-          </p:nvPr>
-        </p:nvSpPr>
-        <p:spPr/>
-        <p:txBody>
-          <a:bodyPr xmlns:a="http://schemas.openxmlformats.org/drawingml/2006/main"/>
-          <a:lstStyle xmlns:a="http://schemas.openxmlformats.org/drawingml/2006/main"/>
-          <a:p xmlns:a="http://schemas.openxmlformats.org/drawingml/2006/main"/>
-        </p:txBody>
-      </p:sp>
-    </p:spTree>
-  </p:cSld>
-  <p:clrMapOvr>
-    <a:masterClrMapping xmlns:a="http://schemas.openxmlformats.org/drawingml/2006/main"/>
-  </p:clrMapOvr>
-</p:notes>
-</file>
-
-<file path=ppt/notesSlides/notesSlide14.xml><?xml version="1.0" encoding="utf-8"?>
-<p:notes xmlns:p="http://schemas.openxmlformats.org/presentationml/2006/main">
-  <p:cSld>
-    <p:spTree>
-      <p:nvGrpSpPr>
-        <p:cNvPr id="1" name=""/>
-        <p:cNvGrpSpPr/>
-        <p:nvPr/>
-      </p:nvGrpSpPr>
-      <p:grpSpPr>
-        <a:xfrm xmlns:a="http://schemas.openxmlformats.org/drawingml/2006/main"/>
-      </p:grpSpPr>
-      <p:sp>
-        <p:nvSpPr>
-          <p:cNvPr id="2" name="Slide Image Placeholder 1"/>
-          <p:cNvSpPr>
-            <a:spLocks xmlns:a="http://schemas.openxmlformats.org/drawingml/2006/main" noGrp="1"/>
-          </p:cNvSpPr>
-          <p:nvPr>
-            <p:ph type="sldImg" idx="0"/>
-          </p:nvPr>
-        </p:nvSpPr>
-        <p:spPr/>
-      </p:sp>
-      <p:sp>
-        <p:nvSpPr>
-          <p:cNvPr id="3" name="Notes Placeholder 2"/>
-          <p:cNvSpPr>
-            <a:spLocks xmlns:a="http://schemas.openxmlformats.org/drawingml/2006/main" noGrp="1"/>
-          </p:cNvSpPr>
-          <p:nvPr>
-            <p:ph type="body" idx="1"/>
-          </p:nvPr>
-        </p:nvSpPr>
-        <p:spPr/>
-        <p:txBody>
-          <a:bodyPr xmlns:a="http://schemas.openxmlformats.org/drawingml/2006/main"/>
-          <a:lstStyle xmlns:a="http://schemas.openxmlformats.org/drawingml/2006/main"/>
-          <a:p xmlns:a="http://schemas.openxmlformats.org/drawingml/2006/main">
-            <a:r>
-              <a:t>[Sources]</a:t>
-            </a:r>
-          </a:p>
-          <a:p xmlns:a="http://schemas.openxmlformats.org/drawingml/2006/main">
-            <a:r>
-              <a:t>- https://github.com/uxlfoundation/skills/blob/main/skills.yaml</a:t>
-            </a:r>
-          </a:p>
-          <a:p xmlns:a="http://schemas.openxmlformats.org/drawingml/2006/main">
-            <a:r>
-              <a:t>- https://github.com/uxlfoundation/skills/blob/main/evaluation/harbor/suites.json</a:t>
-            </a:r>
-          </a:p>
-          <a:p xmlns:a="http://schemas.openxmlformats.org/drawingml/2006/main">
-            <a:r>
-              <a:t>- https://github.com/uxlfoundation/skills/blob/main/evaluation/harbor/EVALUATOR_POLICY.md</a:t>
-            </a:r>
-          </a:p>
-          <a:p xmlns:a="http://schemas.openxmlformats.org/drawingml/2006/main">
-            <a:r>
-              <a:t>- https://uxlfoundation.github.io/skills/</a:t>
-            </a:r>
-          </a:p>
-          <a:p xmlns:a="http://schemas.openxmlformats.org/drawingml/2006/main">
-            <a:r>
-              <a:t>- https://github.com/uxlfoundation/skills/blob/main/docs/evaluator-operator-guide.md</a:t>
-            </a:r>
-          </a:p>
-          <a:p xmlns:a="http://schemas.openxmlformats.org/drawingml/2006/main">
-            <a:r>
-              <a:t>- https://github.com/uxlfoundation/skills/blob/main/docs/forward-testing.md</a:t>
-            </a:r>
-          </a:p>
-          <a:p xmlns:a="http://schemas.openxmlformats.org/drawingml/2006/main">
-            <a:r>
-              <a:t>- https://github.com/uxlfoundation/skills/blob/main/docs/release-and-promotion-policy.md</a:t>
-            </a:r>
-          </a:p>
-          <a:p xmlns:a="http://schemas.openxmlformats.org/drawingml/2006/main">
-            <a:r>
-              <a:t>[/Sources]</a:t>
-            </a:r>
-          </a:p>
-          <a:p xmlns:a="http://schemas.openxmlformats.org/drawingml/2006/main">
-            <a:r>
-              <a:t/>
-            </a:r>
-          </a:p>
-          <a:p xmlns:a="http://schemas.openxmlformats.org/drawingml/2006/main">
-            <a:r>
               <a:t>Speaker cue: The decision we need from each project</a:t>
             </a:r>
           </a:p>
@@ -1256,7 +1135,7 @@
           </a:p>
           <a:p xmlns:a="http://schemas.openxmlformats.org/drawingml/2006/main">
             <a:r>
-              <a:t>Speaker cue: Why project maintainers should care</a:t>
+              <a:t>Speaker cue: What exists today</a:t>
             </a:r>
           </a:p>
         </p:txBody>
@@ -1376,7 +1255,7 @@
           </a:p>
           <a:p xmlns:a="http://schemas.openxmlformats.org/drawingml/2006/main">
             <a:r>
-              <a:t>Speaker cue: What exists today</a:t>
+              <a:t>Speaker cue: The current skill catalog — at a glance</a:t>
             </a:r>
           </a:p>
         </p:txBody>
@@ -1496,7 +1375,7 @@
           </a:p>
           <a:p xmlns:a="http://schemas.openxmlformats.org/drawingml/2006/main">
             <a:r>
-              <a:t>Speaker cue: The current skill catalog — at a glance</a:t>
+              <a:t>Speaker cue: Architecture: project knowledge becomes measured evidence</a:t>
             </a:r>
           </a:p>
         </p:txBody>
@@ -1616,7 +1495,7 @@
           </a:p>
           <a:p xmlns:a="http://schemas.openxmlformats.org/drawingml/2006/main">
             <a:r>
-              <a:t>Speaker cue: Architecture: project knowledge becomes measured evidence</a:t>
+              <a:t>Speaker cue: The public control room answers: are the skills healthy?</a:t>
             </a:r>
           </a:p>
         </p:txBody>
@@ -1736,7 +1615,7 @@
           </a:p>
           <a:p xmlns:a="http://schemas.openxmlformats.org/drawingml/2006/main">
             <a:r>
-              <a:t>Speaker cue: The public control room answers: are the skills healthy?</a:t>
+              <a:t>Speaker cue: Maintainers can drill from portfolio to exact task contracts</a:t>
             </a:r>
           </a:p>
         </p:txBody>
@@ -1856,7 +1735,7 @@
           </a:p>
           <a:p xmlns:a="http://schemas.openxmlformats.org/drawingml/2006/main">
             <a:r>
-              <a:t>Speaker cue: Maintainers can drill from portfolio to exact task contracts</a:t>
+              <a:t>Speaker cue: The methodology is deliberately claim-resistant</a:t>
             </a:r>
           </a:p>
         </p:txBody>
@@ -1976,7 +1855,7 @@
           </a:p>
           <a:p xmlns:a="http://schemas.openxmlformats.org/drawingml/2006/main">
             <a:r>
-              <a:t>Speaker cue: The methodology is deliberately claim-resistant</a:t>
+              <a:t>Speaker cue: Every claim lives inside a matched evaluation cell</a:t>
             </a:r>
           </a:p>
         </p:txBody>
@@ -2096,7 +1975,7 @@
           </a:p>
           <a:p xmlns:a="http://schemas.openxmlformats.org/drawingml/2006/main">
             <a:r>
-              <a:t>Speaker cue: Every claim lives inside a matched evaluation cell</a:t>
+              <a:t>Speaker cue: Maintainer pushback is expected — and the answer is scoped evidence</a:t>
             </a:r>
           </a:p>
         </p:txBody>
@@ -2132,7 +2011,7 @@
     <p:bg>
       <p:bgPr>
         <a:blipFill xmlns:a="http://schemas.openxmlformats.org/drawingml/2006/main">
-          <a:blip xmlns:r="http://schemas.openxmlformats.org/officeDocument/2006/relationships" r:embed="Rcf79fd9e4db742d2">
+          <a:blip xmlns:r="http://schemas.openxmlformats.org/officeDocument/2006/relationships" r:embed="R8bef3cc9f43d4e4a">
             <a:alphaModFix/>
           </a:blip>
           <a:stretch>
@@ -2567,7 +2446,7 @@
           <p:nvPr/>
         </p:nvPicPr>
         <p:blipFill rotWithShape="1">
-          <a:blip xmlns:r="http://schemas.openxmlformats.org/officeDocument/2006/relationships" xmlns:a="http://schemas.openxmlformats.org/drawingml/2006/main" r:embed="R1dd5e10cbe6f411f">
+          <a:blip xmlns:r="http://schemas.openxmlformats.org/officeDocument/2006/relationships" xmlns:a="http://schemas.openxmlformats.org/drawingml/2006/main" r:embed="Rd30caa5cbe1f41de">
             <a:alphaModFix/>
           </a:blip>
           <a:srcRect xmlns:a="http://schemas.openxmlformats.org/drawingml/2006/main" l="0" t="0" r="0" b="0"/>
@@ -2597,7 +2476,7 @@
     <p:bg>
       <p:bgPr>
         <a:blipFill xmlns:a="http://schemas.openxmlformats.org/drawingml/2006/main">
-          <a:blip xmlns:r="http://schemas.openxmlformats.org/officeDocument/2006/relationships" r:embed="R05e5a47907594ebf">
+          <a:blip xmlns:r="http://schemas.openxmlformats.org/officeDocument/2006/relationships" r:embed="Rf4d09a2fc6594a24">
             <a:alphaModFix/>
           </a:blip>
           <a:stretch>
@@ -3631,7 +3510,7 @@
           <p:nvPr/>
         </p:nvPicPr>
         <p:blipFill rotWithShape="1">
-          <a:blip xmlns:r="http://schemas.openxmlformats.org/officeDocument/2006/relationships" xmlns:a="http://schemas.openxmlformats.org/drawingml/2006/main" r:embed="R4b61acefd88c40a8">
+          <a:blip xmlns:r="http://schemas.openxmlformats.org/officeDocument/2006/relationships" xmlns:a="http://schemas.openxmlformats.org/drawingml/2006/main" r:embed="R6ecd06b6a01b4aab">
             <a:alphaModFix/>
           </a:blip>
           <a:srcRect xmlns:a="http://schemas.openxmlformats.org/drawingml/2006/main" l="0" t="0" r="0" b="0"/>
@@ -4655,7 +4534,7 @@
           <p:nvPr/>
         </p:nvPicPr>
         <p:blipFill rotWithShape="1">
-          <a:blip xmlns:r="http://schemas.openxmlformats.org/officeDocument/2006/relationships" xmlns:a="http://schemas.openxmlformats.org/drawingml/2006/main" r:embed="R623a0f55902243c0">
+          <a:blip xmlns:r="http://schemas.openxmlformats.org/officeDocument/2006/relationships" xmlns:a="http://schemas.openxmlformats.org/drawingml/2006/main" r:embed="R74739ae64f814862">
             <a:alphaModFix/>
           </a:blip>
           <a:srcRect xmlns:a="http://schemas.openxmlformats.org/drawingml/2006/main" l="0" t="0" r="0" b="0"/>
@@ -4685,7 +4564,7 @@
     <p:bg>
       <p:bgPr>
         <a:blipFill xmlns:a="http://schemas.openxmlformats.org/drawingml/2006/main">
-          <a:blip xmlns:r="http://schemas.openxmlformats.org/officeDocument/2006/relationships" r:embed="Rf810028b821c4a25">
+          <a:blip xmlns:r="http://schemas.openxmlformats.org/officeDocument/2006/relationships" r:embed="Rcb5d5643b1814a6b">
             <a:alphaModFix/>
           </a:blip>
           <a:stretch>
@@ -5959,7 +5838,7 @@
           <p:nvPr/>
         </p:nvPicPr>
         <p:blipFill rotWithShape="1">
-          <a:blip xmlns:r="http://schemas.openxmlformats.org/officeDocument/2006/relationships" xmlns:a="http://schemas.openxmlformats.org/drawingml/2006/main" r:embed="R277bf6f8d1d64781">
+          <a:blip xmlns:r="http://schemas.openxmlformats.org/officeDocument/2006/relationships" xmlns:a="http://schemas.openxmlformats.org/drawingml/2006/main" r:embed="R52b558c63907415a">
             <a:alphaModFix/>
           </a:blip>
           <a:srcRect xmlns:a="http://schemas.openxmlformats.org/drawingml/2006/main" l="0" t="0" r="0" b="0"/>
@@ -9203,7 +9082,7 @@
           <p:nvPr/>
         </p:nvPicPr>
         <p:blipFill rotWithShape="1">
-          <a:blip xmlns:r="http://schemas.openxmlformats.org/officeDocument/2006/relationships" xmlns:a="http://schemas.openxmlformats.org/drawingml/2006/main" r:embed="R497cff937ccb4401">
+          <a:blip xmlns:r="http://schemas.openxmlformats.org/officeDocument/2006/relationships" xmlns:a="http://schemas.openxmlformats.org/drawingml/2006/main" r:embed="R04de7e73c9fc4767">
             <a:alphaModFix/>
           </a:blip>
           <a:srcRect xmlns:a="http://schemas.openxmlformats.org/drawingml/2006/main" l="0" t="0" r="0" b="0"/>
@@ -10941,7 +10820,7 @@
           <p:nvPr/>
         </p:nvPicPr>
         <p:blipFill rotWithShape="1">
-          <a:blip xmlns:r="http://schemas.openxmlformats.org/officeDocument/2006/relationships" xmlns:a="http://schemas.openxmlformats.org/drawingml/2006/main" r:embed="R5fba98e0394c41e5">
+          <a:blip xmlns:r="http://schemas.openxmlformats.org/officeDocument/2006/relationships" xmlns:a="http://schemas.openxmlformats.org/drawingml/2006/main" r:embed="Rf9640843d37a4ad4">
             <a:alphaModFix/>
           </a:blip>
           <a:srcRect xmlns:a="http://schemas.openxmlformats.org/drawingml/2006/main" l="0" t="0" r="0" b="0"/>
@@ -17770,7 +17649,7 @@
     <p:bg>
       <p:bgPr>
         <a:blipFill xmlns:a="http://schemas.openxmlformats.org/drawingml/2006/main">
-          <a:blip xmlns:r="http://schemas.openxmlformats.org/officeDocument/2006/relationships" r:embed="R959a0c993c664cad">
+          <a:blip xmlns:r="http://schemas.openxmlformats.org/officeDocument/2006/relationships" r:embed="R60a11436b932488b">
             <a:alphaModFix/>
           </a:blip>
           <a:stretch>
@@ -18205,7 +18084,7 @@
           <p:nvPr/>
         </p:nvPicPr>
         <p:blipFill rotWithShape="1">
-          <a:blip xmlns:r="http://schemas.openxmlformats.org/officeDocument/2006/relationships" xmlns:a="http://schemas.openxmlformats.org/drawingml/2006/main" r:embed="R3c9bb615d3e34314">
+          <a:blip xmlns:r="http://schemas.openxmlformats.org/officeDocument/2006/relationships" xmlns:a="http://schemas.openxmlformats.org/drawingml/2006/main" r:embed="R9ac842dc5c25409e">
             <a:alphaModFix/>
           </a:blip>
           <a:srcRect xmlns:a="http://schemas.openxmlformats.org/drawingml/2006/main" l="0" t="0" r="0" b="0"/>
@@ -18235,7 +18114,7 @@
     <p:bg>
       <p:bgPr>
         <a:blipFill xmlns:a="http://schemas.openxmlformats.org/drawingml/2006/main">
-          <a:blip xmlns:r="http://schemas.openxmlformats.org/officeDocument/2006/relationships" r:embed="Rd80936d218db466c">
+          <a:blip xmlns:r="http://schemas.openxmlformats.org/officeDocument/2006/relationships" r:embed="R6a9952010a4d41c9">
             <a:alphaModFix/>
           </a:blip>
           <a:stretch>
@@ -18868,7 +18747,7 @@
           <p:nvPr/>
         </p:nvPicPr>
         <p:blipFill rotWithShape="1">
-          <a:blip xmlns:r="http://schemas.openxmlformats.org/officeDocument/2006/relationships" xmlns:a="http://schemas.openxmlformats.org/drawingml/2006/main" r:embed="R48c9612991b64bc6">
+          <a:blip xmlns:r="http://schemas.openxmlformats.org/officeDocument/2006/relationships" xmlns:a="http://schemas.openxmlformats.org/drawingml/2006/main" r:embed="Rf9e87fbfa6b44e0d">
             <a:alphaModFix/>
           </a:blip>
           <a:srcRect xmlns:a="http://schemas.openxmlformats.org/drawingml/2006/main" l="0" t="0" r="0" b="0"/>
@@ -19328,7 +19207,7 @@
     <p:bg>
       <p:bgPr>
         <a:blipFill xmlns:a="http://schemas.openxmlformats.org/drawingml/2006/main">
-          <a:blip xmlns:r="http://schemas.openxmlformats.org/officeDocument/2006/relationships" r:embed="Rf7db73ce73b149d1">
+          <a:blip xmlns:r="http://schemas.openxmlformats.org/officeDocument/2006/relationships" r:embed="Rdbeffd5e5bb3403d">
             <a:alphaModFix/>
           </a:blip>
           <a:stretch>
@@ -19961,7 +19840,7 @@
           <p:nvPr/>
         </p:nvPicPr>
         <p:blipFill rotWithShape="1">
-          <a:blip xmlns:r="http://schemas.openxmlformats.org/officeDocument/2006/relationships" xmlns:a="http://schemas.openxmlformats.org/drawingml/2006/main" r:embed="Rdb264494cc7e4866">
+          <a:blip xmlns:r="http://schemas.openxmlformats.org/officeDocument/2006/relationships" xmlns:a="http://schemas.openxmlformats.org/drawingml/2006/main" r:embed="Re370fd911c514430">
             <a:alphaModFix/>
           </a:blip>
           <a:srcRect xmlns:a="http://schemas.openxmlformats.org/drawingml/2006/main" l="0" t="0" r="0" b="0"/>
@@ -22617,7 +22496,7 @@
           <p:nvPr/>
         </p:nvPicPr>
         <p:blipFill rotWithShape="1">
-          <a:blip xmlns:r="http://schemas.openxmlformats.org/officeDocument/2006/relationships" xmlns:a="http://schemas.openxmlformats.org/drawingml/2006/main" r:embed="R5b7857b9d0994777">
+          <a:blip xmlns:r="http://schemas.openxmlformats.org/officeDocument/2006/relationships" xmlns:a="http://schemas.openxmlformats.org/drawingml/2006/main" r:embed="R6509b6dc05384064">
             <a:alphaModFix/>
           </a:blip>
           <a:srcRect xmlns:a="http://schemas.openxmlformats.org/drawingml/2006/main" l="0" t="0" r="0" b="0"/>
@@ -22647,7 +22526,7 @@
     <p:bg>
       <p:bgPr>
         <a:blipFill xmlns:a="http://schemas.openxmlformats.org/drawingml/2006/main">
-          <a:blip xmlns:r="http://schemas.openxmlformats.org/officeDocument/2006/relationships" r:embed="Ra03973a3871f4efe">
+          <a:blip xmlns:r="http://schemas.openxmlformats.org/officeDocument/2006/relationships" r:embed="R4d844c342640436e">
             <a:alphaModFix/>
           </a:blip>
           <a:stretch>
@@ -23491,7 +23370,7 @@
           <p:nvPr/>
         </p:nvPicPr>
         <p:blipFill rotWithShape="1">
-          <a:blip xmlns:r="http://schemas.openxmlformats.org/officeDocument/2006/relationships" xmlns:a="http://schemas.openxmlformats.org/drawingml/2006/main" r:embed="R9ec34d5114c64141">
+          <a:blip xmlns:r="http://schemas.openxmlformats.org/officeDocument/2006/relationships" xmlns:a="http://schemas.openxmlformats.org/drawingml/2006/main" r:embed="Raf0d449b0506427b">
             <a:alphaModFix/>
           </a:blip>
           <a:srcRect xmlns:a="http://schemas.openxmlformats.org/drawingml/2006/main" l="0" t="0" r="0" b="0"/>
@@ -23521,7 +23400,7 @@
     <p:bg>
       <p:bgPr>
         <a:blipFill xmlns:a="http://schemas.openxmlformats.org/drawingml/2006/main">
-          <a:blip xmlns:r="http://schemas.openxmlformats.org/officeDocument/2006/relationships" r:embed="R972e9f9cda83435f">
+          <a:blip xmlns:r="http://schemas.openxmlformats.org/officeDocument/2006/relationships" r:embed="Ref1159f7ed594710">
             <a:alphaModFix/>
           </a:blip>
           <a:stretch>
@@ -24469,7 +24348,7 @@
           <p:nvPr/>
         </p:nvPicPr>
         <p:blipFill rotWithShape="1">
-          <a:blip xmlns:r="http://schemas.openxmlformats.org/officeDocument/2006/relationships" xmlns:a="http://schemas.openxmlformats.org/drawingml/2006/main" r:embed="R5c369f93c0f74682">
+          <a:blip xmlns:r="http://schemas.openxmlformats.org/officeDocument/2006/relationships" xmlns:a="http://schemas.openxmlformats.org/drawingml/2006/main" r:embed="R09dda9d4d282470e">
             <a:alphaModFix/>
           </a:blip>
           <a:srcRect xmlns:a="http://schemas.openxmlformats.org/drawingml/2006/main" l="0" t="0" r="0" b="0"/>
@@ -24499,7 +24378,7 @@
     <p:bg>
       <p:bgPr>
         <a:blipFill xmlns:a="http://schemas.openxmlformats.org/drawingml/2006/main">
-          <a:blip xmlns:r="http://schemas.openxmlformats.org/officeDocument/2006/relationships" r:embed="R150d6ec0c8f94c10">
+          <a:blip xmlns:r="http://schemas.openxmlformats.org/officeDocument/2006/relationships" r:embed="R646c25ca04454f95">
             <a:alphaModFix/>
           </a:blip>
           <a:stretch>
@@ -24960,7 +24839,7 @@
           <p:nvPr/>
         </p:nvPicPr>
         <p:blipFill rotWithShape="1">
-          <a:blip xmlns:r="http://schemas.openxmlformats.org/officeDocument/2006/relationships" xmlns:a="http://schemas.openxmlformats.org/drawingml/2006/main" r:embed="R159d6906d17d46f9">
+          <a:blip xmlns:r="http://schemas.openxmlformats.org/officeDocument/2006/relationships" xmlns:a="http://schemas.openxmlformats.org/drawingml/2006/main" r:embed="Rc4b4c52372eb4949">
             <a:alphaModFix/>
           </a:blip>
           <a:srcRect xmlns:a="http://schemas.openxmlformats.org/drawingml/2006/main" l="0" t="0" r="0" b="0"/>
@@ -26672,22 +26551,22 @@
   </p:cSld>
   <p:clrMap bg1="lt1" tx1="dk1" bg2="dk2" tx2="lt2" accent1="accent1" accent2="accent2" accent3="accent3" accent4="accent4" accent5="accent5" accent6="accent6" hlink="hlink" folHlink="folHlink"/>
   <p:sldLayoutIdLst>
-    <p:sldLayoutId xmlns:r="http://schemas.openxmlformats.org/officeDocument/2006/relationships" id="2147483649" r:id="Rb88271aa9f4f4c9c"/>
-    <p:sldLayoutId xmlns:r="http://schemas.openxmlformats.org/officeDocument/2006/relationships" id="2147483650" r:id="R845e83d2ab634436"/>
-    <p:sldLayoutId xmlns:r="http://schemas.openxmlformats.org/officeDocument/2006/relationships" id="2147483651" r:id="Rb9e3dccd60a844c3"/>
-    <p:sldLayoutId xmlns:r="http://schemas.openxmlformats.org/officeDocument/2006/relationships" id="2147483652" r:id="Rc97b515778304562"/>
-    <p:sldLayoutId xmlns:r="http://schemas.openxmlformats.org/officeDocument/2006/relationships" id="2147483653" r:id="R9f9af9905375485b"/>
-    <p:sldLayoutId xmlns:r="http://schemas.openxmlformats.org/officeDocument/2006/relationships" id="2147483654" r:id="Red75149bb2994be7"/>
-    <p:sldLayoutId xmlns:r="http://schemas.openxmlformats.org/officeDocument/2006/relationships" id="2147483655" r:id="Rf0a57444b2f341da"/>
-    <p:sldLayoutId xmlns:r="http://schemas.openxmlformats.org/officeDocument/2006/relationships" id="2147483656" r:id="R63bfc9cc2da14add"/>
-    <p:sldLayoutId xmlns:r="http://schemas.openxmlformats.org/officeDocument/2006/relationships" id="2147483657" r:id="R3a50f2280ed44648"/>
-    <p:sldLayoutId xmlns:r="http://schemas.openxmlformats.org/officeDocument/2006/relationships" id="2147483658" r:id="Ra7ba8037ee974ac7"/>
-    <p:sldLayoutId xmlns:r="http://schemas.openxmlformats.org/officeDocument/2006/relationships" id="2147483659" r:id="R7d13db4d3ef14c8f"/>
-    <p:sldLayoutId xmlns:r="http://schemas.openxmlformats.org/officeDocument/2006/relationships" id="2147483660" r:id="R0d9a9a622fc441c9"/>
-    <p:sldLayoutId xmlns:r="http://schemas.openxmlformats.org/officeDocument/2006/relationships" id="2147483661" r:id="R47f4f16f6994417c"/>
-    <p:sldLayoutId xmlns:r="http://schemas.openxmlformats.org/officeDocument/2006/relationships" id="2147483662" r:id="R1643da8145db4223"/>
-    <p:sldLayoutId xmlns:r="http://schemas.openxmlformats.org/officeDocument/2006/relationships" id="2147483663" r:id="R6d1aecf51e15483b"/>
-    <p:sldLayoutId xmlns:r="http://schemas.openxmlformats.org/officeDocument/2006/relationships" id="2147483664" r:id="Rbd32074d12924725"/>
+    <p:sldLayoutId xmlns:r="http://schemas.openxmlformats.org/officeDocument/2006/relationships" id="2147483649" r:id="Rd10ee9849fc4479e"/>
+    <p:sldLayoutId xmlns:r="http://schemas.openxmlformats.org/officeDocument/2006/relationships" id="2147483650" r:id="R77a6cf2775034798"/>
+    <p:sldLayoutId xmlns:r="http://schemas.openxmlformats.org/officeDocument/2006/relationships" id="2147483651" r:id="R096a7d67ee5c498b"/>
+    <p:sldLayoutId xmlns:r="http://schemas.openxmlformats.org/officeDocument/2006/relationships" id="2147483652" r:id="R98fda9fa94314b8a"/>
+    <p:sldLayoutId xmlns:r="http://schemas.openxmlformats.org/officeDocument/2006/relationships" id="2147483653" r:id="R688580b968774fe2"/>
+    <p:sldLayoutId xmlns:r="http://schemas.openxmlformats.org/officeDocument/2006/relationships" id="2147483654" r:id="R01cf9527fe8942af"/>
+    <p:sldLayoutId xmlns:r="http://schemas.openxmlformats.org/officeDocument/2006/relationships" id="2147483655" r:id="R988ce7b473714c83"/>
+    <p:sldLayoutId xmlns:r="http://schemas.openxmlformats.org/officeDocument/2006/relationships" id="2147483656" r:id="R7cac4b40260048c5"/>
+    <p:sldLayoutId xmlns:r="http://schemas.openxmlformats.org/officeDocument/2006/relationships" id="2147483657" r:id="Rf7828bdeb95f4df2"/>
+    <p:sldLayoutId xmlns:r="http://schemas.openxmlformats.org/officeDocument/2006/relationships" id="2147483658" r:id="R62ea9e08b5c945d2"/>
+    <p:sldLayoutId xmlns:r="http://schemas.openxmlformats.org/officeDocument/2006/relationships" id="2147483659" r:id="R144ca351b1c44527"/>
+    <p:sldLayoutId xmlns:r="http://schemas.openxmlformats.org/officeDocument/2006/relationships" id="2147483660" r:id="R0bc091b5287b4d88"/>
+    <p:sldLayoutId xmlns:r="http://schemas.openxmlformats.org/officeDocument/2006/relationships" id="2147483661" r:id="Rbc85b45604c74c6f"/>
+    <p:sldLayoutId xmlns:r="http://schemas.openxmlformats.org/officeDocument/2006/relationships" id="2147483662" r:id="R3ec658b12db44af9"/>
+    <p:sldLayoutId xmlns:r="http://schemas.openxmlformats.org/officeDocument/2006/relationships" id="2147483663" r:id="R335978e3ebda45dc"/>
+    <p:sldLayoutId xmlns:r="http://schemas.openxmlformats.org/officeDocument/2006/relationships" id="2147483664" r:id="Rfb2fb120c99a407b"/>
   </p:sldLayoutIdLst>
   <p:hf hdr="0" ftr="0" dt="0"/>
   <p:txStyles>
@@ -28880,7 +28759,7 @@
           <p:nvPr/>
         </p:nvPicPr>
         <p:blipFill rotWithShape="1">
-          <a:blip xmlns:r="http://schemas.openxmlformats.org/officeDocument/2006/relationships" xmlns:a="http://schemas.openxmlformats.org/drawingml/2006/main" r:embed="R009350a7a68345e8">
+          <a:blip xmlns:r="http://schemas.openxmlformats.org/officeDocument/2006/relationships" xmlns:a="http://schemas.openxmlformats.org/drawingml/2006/main" r:embed="R4df3fe1a35414db2">
             <a:alphaModFix/>
           </a:blip>
           <a:srcRect xmlns:a="http://schemas.openxmlformats.org/drawingml/2006/main" l="0" t="0" r="0" b="0"/>
@@ -28903,19 +28782,19 @@
   </p:cSld>
   <p:clrMap bg1="lt1" tx1="dk1" bg2="dk2" tx2="lt2" accent1="accent1" accent2="accent2" accent3="accent3" accent4="accent4" accent5="accent5" accent6="accent6" hlink="hlink" folHlink="folHlink"/>
   <p:sldLayoutIdLst>
-    <p:sldLayoutId xmlns:r="http://schemas.openxmlformats.org/officeDocument/2006/relationships" id="2147483666" r:id="R0619b8e8abb24748"/>
-    <p:sldLayoutId xmlns:r="http://schemas.openxmlformats.org/officeDocument/2006/relationships" id="2147483667" r:id="Rc1c3ab942d0f459e"/>
-    <p:sldLayoutId xmlns:r="http://schemas.openxmlformats.org/officeDocument/2006/relationships" id="2147483668" r:id="R5981fc41c43848d3"/>
-    <p:sldLayoutId xmlns:r="http://schemas.openxmlformats.org/officeDocument/2006/relationships" id="2147483669" r:id="R5497369958b948f8"/>
-    <p:sldLayoutId xmlns:r="http://schemas.openxmlformats.org/officeDocument/2006/relationships" id="2147483670" r:id="R49170ba884194d71"/>
-    <p:sldLayoutId xmlns:r="http://schemas.openxmlformats.org/officeDocument/2006/relationships" id="2147483671" r:id="Rd8068c3f56834c09"/>
-    <p:sldLayoutId xmlns:r="http://schemas.openxmlformats.org/officeDocument/2006/relationships" id="2147483672" r:id="Rd73115af9edb4ff0"/>
-    <p:sldLayoutId xmlns:r="http://schemas.openxmlformats.org/officeDocument/2006/relationships" id="2147483673" r:id="Ra02902615bf74bf1"/>
-    <p:sldLayoutId xmlns:r="http://schemas.openxmlformats.org/officeDocument/2006/relationships" id="2147483674" r:id="R85132b11f4ed4519"/>
-    <p:sldLayoutId xmlns:r="http://schemas.openxmlformats.org/officeDocument/2006/relationships" id="2147483675" r:id="R1b944c385a2a459e"/>
-    <p:sldLayoutId xmlns:r="http://schemas.openxmlformats.org/officeDocument/2006/relationships" id="2147483676" r:id="R3ec5fd01f9d94a86"/>
-    <p:sldLayoutId xmlns:r="http://schemas.openxmlformats.org/officeDocument/2006/relationships" id="2147483677" r:id="R503d16cdbd564746"/>
-    <p:sldLayoutId xmlns:r="http://schemas.openxmlformats.org/officeDocument/2006/relationships" id="2147483678" r:id="Rd2a884f542424fde"/>
+    <p:sldLayoutId xmlns:r="http://schemas.openxmlformats.org/officeDocument/2006/relationships" id="2147483666" r:id="R9b1eee25ff6d434a"/>
+    <p:sldLayoutId xmlns:r="http://schemas.openxmlformats.org/officeDocument/2006/relationships" id="2147483667" r:id="R46d9f1971a064380"/>
+    <p:sldLayoutId xmlns:r="http://schemas.openxmlformats.org/officeDocument/2006/relationships" id="2147483668" r:id="Re2992fc45e5344e2"/>
+    <p:sldLayoutId xmlns:r="http://schemas.openxmlformats.org/officeDocument/2006/relationships" id="2147483669" r:id="Rcf1b9ee0c9dc4478"/>
+    <p:sldLayoutId xmlns:r="http://schemas.openxmlformats.org/officeDocument/2006/relationships" id="2147483670" r:id="R93708b4e417b48fc"/>
+    <p:sldLayoutId xmlns:r="http://schemas.openxmlformats.org/officeDocument/2006/relationships" id="2147483671" r:id="Rc1e4906cc01549c5"/>
+    <p:sldLayoutId xmlns:r="http://schemas.openxmlformats.org/officeDocument/2006/relationships" id="2147483672" r:id="Rc541e9182b7c45d5"/>
+    <p:sldLayoutId xmlns:r="http://schemas.openxmlformats.org/officeDocument/2006/relationships" id="2147483673" r:id="R636e123a16a743a3"/>
+    <p:sldLayoutId xmlns:r="http://schemas.openxmlformats.org/officeDocument/2006/relationships" id="2147483674" r:id="R567002c9e0414aba"/>
+    <p:sldLayoutId xmlns:r="http://schemas.openxmlformats.org/officeDocument/2006/relationships" id="2147483675" r:id="R0f0e2c730a694fd9"/>
+    <p:sldLayoutId xmlns:r="http://schemas.openxmlformats.org/officeDocument/2006/relationships" id="2147483676" r:id="Ra130e52dc9c94b8a"/>
+    <p:sldLayoutId xmlns:r="http://schemas.openxmlformats.org/officeDocument/2006/relationships" id="2147483677" r:id="R540e9428dfd8491d"/>
+    <p:sldLayoutId xmlns:r="http://schemas.openxmlformats.org/officeDocument/2006/relationships" id="2147483678" r:id="Raec0c8e0a6d74ebc"/>
   </p:sldLayoutIdLst>
   <p:hf hdr="0" ftr="0" dt="0"/>
   <p:txStyles>
@@ -30312,162 +30191,7 @@
           <a:lstStyle xmlns:a="http://schemas.openxmlformats.org/drawingml/2006/main"/>
           <a:p xmlns:a="http://schemas.openxmlformats.org/drawingml/2006/main">
             <a:r>
-              <a:t>Maintainer pushback is expected — and the answer is scoped evidence</a:t>
-            </a:r>
-          </a:p>
-        </p:txBody>
-      </p:sp>
-      <p:sp>
-        <p:nvSpPr>
-          <p:cNvPr id="3" name="Content Placeholder 2">
-            <a:extLst xmlns:a="http://schemas.openxmlformats.org/drawingml/2006/main">
-              <a:ext uri="{FF2B5EF4-FFF2-40B4-BE49-F238E27FC236}">
-                <a16:creationId xmlns:a16="http://schemas.microsoft.com/office/drawing/2014/main" id="{ECF5C9F1-2691-0BC9-F1E1-01CECB857FE3}"/>
-              </a:ext>
-            </a:extLst>
-          </p:cNvPr>
-          <p:cNvSpPr>
-            <a:spLocks xmlns:a="http://schemas.openxmlformats.org/drawingml/2006/main" noGrp="1"/>
-          </p:cNvSpPr>
-          <p:nvPr>
-            <p:ph type="body" idx="1"/>
-          </p:nvPr>
-        </p:nvSpPr>
-        <p:spPr>
-          <a:xfrm xmlns:a="http://schemas.openxmlformats.org/drawingml/2006/main">
-            <a:off x="838200" y="1825625"/>
-            <a:ext cx="10515600" cy="4351200"/>
-          </a:xfrm>
-        </p:spPr>
-        <p:txBody>
-          <a:bodyPr xmlns:a="http://schemas.openxmlformats.org/drawingml/2006/main" wrap="square" anchor="t">
-            <a:normAutofit fontScale="100000"/>
-          </a:bodyPr>
-          <a:lstStyle xmlns:a="http://schemas.openxmlformats.org/drawingml/2006/main"/>
-          <a:p xmlns:a="http://schemas.openxmlformats.org/drawingml/2006/main">
-            <a:pPr marL="30" indent="-18">
-              <a:spcAft>
-                <a:spcPts val="10"/>
-              </a:spcAft>
-              <a:buChar char="•"/>
-              <a:defRPr sz="1913">
-                <a:solidFill>
-                  <a:srgbClr val="000000"/>
-                </a:solidFill>
-              </a:defRPr>
-            </a:pPr>
-            <a:r>
-              <a:rPr sz="1913" b="1">
-                <a:solidFill>
-                  <a:srgbClr val="000000"/>
-                </a:solidFill>
-              </a:rPr>
-              <a:t> Do you test every combination? — No. We publish representative, risk-based cells and the gaps.</a:t>
-            </a:r>
-          </a:p>
-          <a:p xmlns:a="http://schemas.openxmlformats.org/drawingml/2006/main">
-            <a:pPr marL="30" indent="-18">
-              <a:spcAft>
-                <a:spcPts val="10"/>
-              </a:spcAft>
-              <a:buChar char="•"/>
-              <a:defRPr sz="1913">
-                <a:solidFill>
-                  <a:srgbClr val="000000"/>
-                </a:solidFill>
-              </a:defRPr>
-            </a:pPr>
-            <a:r>
-              <a:rPr sz="1913" b="1">
-                <a:solidFill>
-                  <a:srgbClr val="000000"/>
-                </a:solidFill>
-              </a:rPr>
-              <a:t> What changes invalidate evidence? — Re-run affected cells; older results remain history, not current proof.</a:t>
-            </a:r>
-          </a:p>
-          <a:p xmlns:a="http://schemas.openxmlformats.org/drawingml/2006/main">
-            <a:pPr marL="30" indent="-18">
-              <a:spcAft>
-                <a:spcPts val="10"/>
-              </a:spcAft>
-              <a:buChar char="•"/>
-              <a:defRPr sz="1913">
-                <a:solidFill>
-                  <a:srgbClr val="000000"/>
-                </a:solidFill>
-              </a:defRPr>
-            </a:pPr>
-            <a:r>
-              <a:rPr sz="1913" b="1">
-                <a:solidFill>
-                  <a:srgbClr val="000000"/>
-                </a:solidFill>
-              </a:rPr>
-              <a:t> How do you limit overfitting? — Maintainer incidents, hidden checks, negative controls, multiple tasks, and trajectory review.</a:t>
-            </a:r>
-          </a:p>
-          <a:p xmlns:a="http://schemas.openxmlformats.org/drawingml/2006/main">
-            <a:pPr marL="30" indent="-18">
-              <a:spcAft>
-                <a:spcPts val="10"/>
-              </a:spcAft>
-              <a:buChar char="•"/>
-              <a:defRPr sz="1913">
-                <a:solidFill>
-                  <a:srgbClr val="000000"/>
-                </a:solidFill>
-              </a:defRPr>
-            </a:pPr>
-            <a:r>
-              <a:rPr sz="1913" b="1">
-                <a:solidFill>
-                  <a:srgbClr val="000000"/>
-                </a:solidFill>
-              </a:rPr>
-              <a:t> What if every arm passes? — Keep it as smoke coverage; claim no lift and seek a harder task.</a:t>
-            </a:r>
-          </a:p>
-          <a:p xmlns:a="http://schemas.openxmlformats.org/drawingml/2006/main">
-            <a:pPr marL="30" indent="-18">
-              <a:spcAft>
-                <a:spcPts val="10"/>
-              </a:spcAft>
-              <a:buChar char="•"/>
-              <a:defRPr sz="1913">
-                <a:solidFill>
-                  <a:srgbClr val="000000"/>
-                </a:solidFill>
-              </a:defRPr>
-            </a:pPr>
-            <a:r>
-              <a:rPr sz="1913" b="1">
-                <a:solidFill>
-                  <a:srgbClr val="000000"/>
-                </a:solidFill>
-              </a:rPr>
-              <a:t> Does hardware qualification prove skill value? — No. Qualification and matched skill trials are separate gates.</a:t>
-            </a:r>
-          </a:p>
-          <a:p xmlns:a="http://schemas.openxmlformats.org/drawingml/2006/main">
-            <a:pPr marL="30" indent="-18">
-              <a:spcAft>
-                <a:spcPts val="10"/>
-              </a:spcAft>
-              <a:buChar char="•"/>
-              <a:defRPr sz="1913">
-                <a:solidFill>
-                  <a:srgbClr val="000000"/>
-                </a:solidFill>
-              </a:defRPr>
-            </a:pPr>
-            <a:r>
-              <a:rPr sz="1913" b="1">
-                <a:solidFill>
-                  <a:srgbClr val="000000"/>
-                </a:solidFill>
-              </a:rPr>
-              <a:t> Can scores be pooled? — No universal score; report conclusions within each model, harness, software, and environment cell.</a:t>
+              <a:t>Hardware is a pluggable evidence lane — never the product</a:t>
             </a:r>
           </a:p>
         </p:txBody>
@@ -30508,6 +30232,28 @@
           </a:p>
         </p:txBody>
       </p:sp>
+      <p:pic>
+        <p:nvPicPr>
+          <p:cNvPr id="11" name=""/>
+          <p:cNvPicPr>
+            <a:picLocks xmlns:a="http://schemas.openxmlformats.org/drawingml/2006/main" noChangeAspect="1"/>
+          </p:cNvPicPr>
+          <p:nvPr/>
+        </p:nvPicPr>
+        <p:blipFill>
+          <a:blip xmlns:r="http://schemas.openxmlformats.org/officeDocument/2006/relationships" xmlns:a="http://schemas.openxmlformats.org/drawingml/2006/main" r:embed="R72c8fc6b2bff4551"/>
+          <a:stretch xmlns:a="http://schemas.openxmlformats.org/drawingml/2006/main"/>
+        </p:blipFill>
+        <p:spPr>
+          <a:xfrm xmlns:a="http://schemas.openxmlformats.org/drawingml/2006/main" flipH="0" flipV="0">
+            <a:off x="2322187" y="1885950"/>
+            <a:ext cx="7547626" cy="4248150"/>
+          </a:xfrm>
+          <a:prstGeom xmlns:a="http://schemas.openxmlformats.org/drawingml/2006/main" prst="roundRect">
+            <a:avLst/>
+          </a:prstGeom>
+        </p:spPr>
+      </p:pic>
     </p:spTree>
     <p:extLst>
       <p:ext uri="{BB962C8B-B14F-4D97-AF65-F5344CB8AC3E}">
@@ -30559,7 +30305,7 @@
           <a:lstStyle xmlns:a="http://schemas.openxmlformats.org/drawingml/2006/main"/>
           <a:p xmlns:a="http://schemas.openxmlformats.org/drawingml/2006/main">
             <a:r>
-              <a:t>Hardware is a pluggable evidence lane — never the product</a:t>
+              <a:t>The ongoing maintainer workflow fits normal GitHub practice</a:t>
             </a:r>
           </a:p>
         </p:txBody>
@@ -30596,120 +30342,6 @@
           <a:p xmlns:a="http://schemas.openxmlformats.org/drawingml/2006/main">
             <a:r>
               <a:t>11</a:t>
-            </a:r>
-          </a:p>
-        </p:txBody>
-      </p:sp>
-      <p:pic>
-        <p:nvPicPr>
-          <p:cNvPr id="11" name=""/>
-          <p:cNvPicPr>
-            <a:picLocks xmlns:a="http://schemas.openxmlformats.org/drawingml/2006/main" noChangeAspect="1"/>
-          </p:cNvPicPr>
-          <p:nvPr/>
-        </p:nvPicPr>
-        <p:blipFill>
-          <a:blip xmlns:r="http://schemas.openxmlformats.org/officeDocument/2006/relationships" xmlns:a="http://schemas.openxmlformats.org/drawingml/2006/main" r:embed="R32090135bb3b4594"/>
-          <a:stretch xmlns:a="http://schemas.openxmlformats.org/drawingml/2006/main"/>
-        </p:blipFill>
-        <p:spPr>
-          <a:xfrm xmlns:a="http://schemas.openxmlformats.org/drawingml/2006/main" flipH="0" flipV="0">
-            <a:off x="2322187" y="1885950"/>
-            <a:ext cx="7547626" cy="4248150"/>
-          </a:xfrm>
-          <a:prstGeom xmlns:a="http://schemas.openxmlformats.org/drawingml/2006/main" prst="roundRect">
-            <a:avLst/>
-          </a:prstGeom>
-        </p:spPr>
-      </p:pic>
-    </p:spTree>
-    <p:extLst>
-      <p:ext uri="{BB962C8B-B14F-4D97-AF65-F5344CB8AC3E}">
-        <p14:creationId xmlns:p14="http://schemas.microsoft.com/office/powerpoint/2010/main" val="1742728663"/>
-      </p:ext>
-    </p:extLst>
-  </p:cSld>
-</p:sld>
-</file>
-
-<file path=ppt/slides/slide12.xml><?xml version="1.0" encoding="utf-8"?>
-<p:sld xmlns:p="http://schemas.openxmlformats.org/presentationml/2006/main">
-  <p:cSld>
-    <p:spTree>
-      <p:nvGrpSpPr>
-        <p:cNvPr id="1" name=""/>
-        <p:cNvGrpSpPr/>
-        <p:nvPr/>
-      </p:nvGrpSpPr>
-      <p:grpSpPr>
-        <a:xfrm xmlns:a="http://schemas.openxmlformats.org/drawingml/2006/main"/>
-      </p:grpSpPr>
-      <p:sp>
-        <p:nvSpPr>
-          <p:cNvPr id="2" name="Title 1">
-            <a:extLst xmlns:a="http://schemas.openxmlformats.org/drawingml/2006/main">
-              <a:ext uri="{FF2B5EF4-FFF2-40B4-BE49-F238E27FC236}">
-                <a16:creationId xmlns:a16="http://schemas.microsoft.com/office/drawing/2014/main" id="{F64C2A24-546D-C55C-2C52-97A4957F67E0}"/>
-              </a:ext>
-            </a:extLst>
-          </p:cNvPr>
-          <p:cNvSpPr>
-            <a:spLocks xmlns:a="http://schemas.openxmlformats.org/drawingml/2006/main" noGrp="1"/>
-          </p:cNvSpPr>
-          <p:nvPr>
-            <p:ph type="title" idx="0"/>
-          </p:nvPr>
-        </p:nvSpPr>
-        <p:spPr>
-          <a:xfrm xmlns:a="http://schemas.openxmlformats.org/drawingml/2006/main">
-            <a:off x="838200" y="365125"/>
-            <a:ext cx="10515600" cy="1325700"/>
-          </a:xfrm>
-        </p:spPr>
-        <p:txBody>
-          <a:bodyPr xmlns:a="http://schemas.openxmlformats.org/drawingml/2006/main">
-            <a:normAutofit fontScale="100000"/>
-          </a:bodyPr>
-          <a:lstStyle xmlns:a="http://schemas.openxmlformats.org/drawingml/2006/main"/>
-          <a:p xmlns:a="http://schemas.openxmlformats.org/drawingml/2006/main">
-            <a:r>
-              <a:t>The ongoing maintainer workflow fits normal GitHub practice</a:t>
-            </a:r>
-          </a:p>
-        </p:txBody>
-      </p:sp>
-      <p:sp>
-        <p:nvSpPr>
-          <p:cNvPr id="7" name="TextBox 6">
-            <a:extLst xmlns:a="http://schemas.openxmlformats.org/drawingml/2006/main">
-              <a:ext uri="{FF2B5EF4-FFF2-40B4-BE49-F238E27FC236}">
-                <a16:creationId xmlns:a16="http://schemas.microsoft.com/office/drawing/2014/main" id="{E2E6F043-0F84-54F7-A567-6E5851801779}"/>
-              </a:ext>
-            </a:extLst>
-          </p:cNvPr>
-          <p:cNvSpPr>
-            <a:spLocks xmlns:a="http://schemas.openxmlformats.org/drawingml/2006/main" noGrp="1"/>
-          </p:cNvSpPr>
-          <p:nvPr/>
-        </p:nvSpPr>
-        <p:spPr>
-          <a:xfrm xmlns:a="http://schemas.openxmlformats.org/drawingml/2006/main">
-            <a:off x="696174" y="6338986"/>
-            <a:ext cx="284052" cy="307777"/>
-          </a:xfrm>
-          <a:prstGeom xmlns:a="http://schemas.openxmlformats.org/drawingml/2006/main" prst="rect">
-            <a:avLst/>
-          </a:prstGeom>
-          <a:noFill xmlns:a="http://schemas.openxmlformats.org/drawingml/2006/main"/>
-        </p:spPr>
-        <p:txBody>
-          <a:bodyPr xmlns:a="http://schemas.openxmlformats.org/drawingml/2006/main" wrap="none">
-            <a:spAutoFit/>
-          </a:bodyPr>
-          <a:lstStyle xmlns:a="http://schemas.openxmlformats.org/drawingml/2006/main"/>
-          <a:p xmlns:a="http://schemas.openxmlformats.org/drawingml/2006/main">
-            <a:r>
-              <a:t>12</a:t>
             </a:r>
           </a:p>
         </p:txBody>
@@ -31453,6 +31085,243 @@
 </p:sld>
 </file>
 
+<file path=ppt/slides/slide12.xml><?xml version="1.0" encoding="utf-8"?>
+<p:sld xmlns:p="http://schemas.openxmlformats.org/presentationml/2006/main">
+  <p:cSld>
+    <p:spTree>
+      <p:nvGrpSpPr>
+        <p:cNvPr id="1" name=""/>
+        <p:cNvGrpSpPr/>
+        <p:nvPr/>
+      </p:nvGrpSpPr>
+      <p:grpSpPr>
+        <a:xfrm xmlns:a="http://schemas.openxmlformats.org/drawingml/2006/main"/>
+      </p:grpSpPr>
+      <p:sp>
+        <p:nvSpPr>
+          <p:cNvPr id="2" name="Title 1">
+            <a:extLst xmlns:a="http://schemas.openxmlformats.org/drawingml/2006/main">
+              <a:ext uri="{FF2B5EF4-FFF2-40B4-BE49-F238E27FC236}">
+                <a16:creationId xmlns:a16="http://schemas.microsoft.com/office/drawing/2014/main" id="{F64C2A24-546D-C55C-2C52-97A4957F67E0}"/>
+              </a:ext>
+            </a:extLst>
+          </p:cNvPr>
+          <p:cNvSpPr>
+            <a:spLocks xmlns:a="http://schemas.openxmlformats.org/drawingml/2006/main" noGrp="1"/>
+          </p:cNvSpPr>
+          <p:nvPr>
+            <p:ph type="title" idx="0"/>
+          </p:nvPr>
+        </p:nvSpPr>
+        <p:spPr>
+          <a:xfrm xmlns:a="http://schemas.openxmlformats.org/drawingml/2006/main">
+            <a:off x="838200" y="365125"/>
+            <a:ext cx="10515600" cy="1325700"/>
+          </a:xfrm>
+        </p:spPr>
+        <p:txBody>
+          <a:bodyPr xmlns:a="http://schemas.openxmlformats.org/drawingml/2006/main">
+            <a:normAutofit fontScale="100000"/>
+          </a:bodyPr>
+          <a:lstStyle xmlns:a="http://schemas.openxmlformats.org/drawingml/2006/main"/>
+          <a:p xmlns:a="http://schemas.openxmlformats.org/drawingml/2006/main">
+            <a:r>
+              <a:t>Ownership is intentionally split</a:t>
+            </a:r>
+          </a:p>
+        </p:txBody>
+      </p:sp>
+      <p:sp>
+        <p:nvSpPr>
+          <p:cNvPr id="3" name="Content Placeholder 2">
+            <a:extLst xmlns:a="http://schemas.openxmlformats.org/drawingml/2006/main">
+              <a:ext uri="{FF2B5EF4-FFF2-40B4-BE49-F238E27FC236}">
+                <a16:creationId xmlns:a16="http://schemas.microsoft.com/office/drawing/2014/main" id="{ECF5C9F1-2691-0BC9-F1E1-01CECB857FE3}"/>
+              </a:ext>
+            </a:extLst>
+          </p:cNvPr>
+          <p:cNvSpPr>
+            <a:spLocks xmlns:a="http://schemas.openxmlformats.org/drawingml/2006/main" noGrp="1"/>
+          </p:cNvSpPr>
+          <p:nvPr>
+            <p:ph type="body" idx="1"/>
+          </p:nvPr>
+        </p:nvSpPr>
+        <p:spPr>
+          <a:xfrm xmlns:a="http://schemas.openxmlformats.org/drawingml/2006/main">
+            <a:off x="838200" y="1825625"/>
+            <a:ext cx="10515600" cy="4351200"/>
+          </a:xfrm>
+        </p:spPr>
+        <p:txBody>
+          <a:bodyPr xmlns:a="http://schemas.openxmlformats.org/drawingml/2006/main" wrap="square" anchor="t">
+            <a:normAutofit fontScale="100000"/>
+          </a:bodyPr>
+          <a:lstStyle xmlns:a="http://schemas.openxmlformats.org/drawingml/2006/main"/>
+          <a:p xmlns:a="http://schemas.openxmlformats.org/drawingml/2006/main">
+            <a:pPr marL="30" indent="-18">
+              <a:spcAft>
+                <a:spcPts val="10"/>
+              </a:spcAft>
+              <a:buChar char="•"/>
+              <a:defRPr sz="1913">
+                <a:solidFill>
+                  <a:srgbClr val="000000"/>
+                </a:solidFill>
+              </a:defRPr>
+            </a:pPr>
+            <a:r>
+              <a:rPr sz="1913" b="1">
+                <a:solidFill>
+                  <a:srgbClr val="000000"/>
+                </a:solidFill>
+              </a:rPr>
+              <a:t> Project maintainers own</a:t>
+            </a:r>
+            <a:r>
+              <a:rPr sz="1913">
+                <a:solidFill>
+                  <a:srgbClr val="000000"/>
+                </a:solidFill>
+              </a:rPr>
+              <a:t> — Triggers, technical guidance, official sources, limitations, and whether task scenarios are authentic.</a:t>
+            </a:r>
+          </a:p>
+          <a:p xmlns:a="http://schemas.openxmlformats.org/drawingml/2006/main">
+            <a:pPr marL="30" indent="-18">
+              <a:spcAft>
+                <a:spcPts val="10"/>
+              </a:spcAft>
+              <a:buChar char="•"/>
+              <a:defRPr sz="1913">
+                <a:solidFill>
+                  <a:srgbClr val="000000"/>
+                </a:solidFill>
+              </a:defRPr>
+            </a:pPr>
+            <a:r>
+              <a:rPr sz="1913" b="1">
+                <a:solidFill>
+                  <a:srgbClr val="000000"/>
+                </a:solidFill>
+              </a:rPr>
+              <a:t> UXL shared infrastructure owns</a:t>
+            </a:r>
+            <a:r>
+              <a:rPr sz="1913">
+                <a:solidFill>
+                  <a:srgbClr val="000000"/>
+                </a:solidFill>
+              </a:rPr>
+              <a:t> — Catalog validation, Harbor harnesses, comparison policy, dashboards, hosted CI, and runner contracts.</a:t>
+            </a:r>
+          </a:p>
+          <a:p xmlns:a="http://schemas.openxmlformats.org/drawingml/2006/main">
+            <a:pPr marL="30" indent="-18">
+              <a:spcAft>
+                <a:spcPts val="10"/>
+              </a:spcAft>
+              <a:buChar char="•"/>
+              <a:defRPr sz="1913">
+                <a:solidFill>
+                  <a:srgbClr val="000000"/>
+                </a:solidFill>
+              </a:defRPr>
+            </a:pPr>
+            <a:r>
+              <a:rPr sz="1913" b="1">
+                <a:solidFill>
+                  <a:srgbClr val="000000"/>
+                </a:solidFill>
+              </a:rPr>
+              <a:t> Hardware owners opt in</a:t>
+            </a:r>
+            <a:r>
+              <a:rPr sz="1913">
+                <a:solidFill>
+                  <a:srgbClr val="000000"/>
+                </a:solidFill>
+              </a:rPr>
+              <a:t> — They qualify a declared environment, run only reviewed immutable evaluator revisions, and return evidence artifacts.</a:t>
+            </a:r>
+          </a:p>
+          <a:p xmlns:a="http://schemas.openxmlformats.org/drawingml/2006/main">
+            <a:pPr marL="30" indent="-18">
+              <a:spcAft>
+                <a:spcPts val="10"/>
+              </a:spcAft>
+              <a:buChar char="•"/>
+              <a:defRPr sz="1913">
+                <a:solidFill>
+                  <a:srgbClr val="000000"/>
+                </a:solidFill>
+              </a:defRPr>
+            </a:pPr>
+            <a:r>
+              <a:rPr sz="1913" b="1">
+                <a:solidFill>
+                  <a:srgbClr val="000000"/>
+                </a:solidFill>
+              </a:rPr>
+              <a:t> No silent promotion</a:t>
+            </a:r>
+            <a:r>
+              <a:rPr sz="1913">
+                <a:solidFill>
+                  <a:srgbClr val="000000"/>
+                </a:solidFill>
+              </a:rPr>
+              <a:t> — Project approval, source verification, realistic eval prompts, matched trials when feasible, and explicit limitations remain gates.</a:t>
+            </a:r>
+          </a:p>
+        </p:txBody>
+      </p:sp>
+      <p:sp>
+        <p:nvSpPr>
+          <p:cNvPr id="7" name="TextBox 6">
+            <a:extLst xmlns:a="http://schemas.openxmlformats.org/drawingml/2006/main">
+              <a:ext uri="{FF2B5EF4-FFF2-40B4-BE49-F238E27FC236}">
+                <a16:creationId xmlns:a16="http://schemas.microsoft.com/office/drawing/2014/main" id="{E2E6F043-0F84-54F7-A567-6E5851801779}"/>
+              </a:ext>
+            </a:extLst>
+          </p:cNvPr>
+          <p:cNvSpPr>
+            <a:spLocks xmlns:a="http://schemas.openxmlformats.org/drawingml/2006/main" noGrp="1"/>
+          </p:cNvSpPr>
+          <p:nvPr/>
+        </p:nvSpPr>
+        <p:spPr>
+          <a:xfrm xmlns:a="http://schemas.openxmlformats.org/drawingml/2006/main">
+            <a:off x="696174" y="6338986"/>
+            <a:ext cx="284052" cy="307777"/>
+          </a:xfrm>
+          <a:prstGeom xmlns:a="http://schemas.openxmlformats.org/drawingml/2006/main" prst="rect">
+            <a:avLst/>
+          </a:prstGeom>
+          <a:noFill xmlns:a="http://schemas.openxmlformats.org/drawingml/2006/main"/>
+        </p:spPr>
+        <p:txBody>
+          <a:bodyPr xmlns:a="http://schemas.openxmlformats.org/drawingml/2006/main" wrap="none">
+            <a:spAutoFit/>
+          </a:bodyPr>
+          <a:lstStyle xmlns:a="http://schemas.openxmlformats.org/drawingml/2006/main"/>
+          <a:p xmlns:a="http://schemas.openxmlformats.org/drawingml/2006/main">
+            <a:r>
+              <a:t>12</a:t>
+            </a:r>
+          </a:p>
+        </p:txBody>
+      </p:sp>
+    </p:spTree>
+    <p:extLst>
+      <p:ext uri="{BB962C8B-B14F-4D97-AF65-F5344CB8AC3E}">
+        <p14:creationId xmlns:p14="http://schemas.microsoft.com/office/powerpoint/2010/main" val="1742728663"/>
+      </p:ext>
+    </p:extLst>
+  </p:cSld>
+</p:sld>
+</file>
+
 <file path=ppt/slides/slide13.xml><?xml version="1.0" encoding="utf-8"?>
 <p:sld xmlns:p="http://schemas.openxmlformats.org/presentationml/2006/main">
   <p:cSld>
@@ -31494,7 +31363,7 @@
           <a:lstStyle xmlns:a="http://schemas.openxmlformats.org/drawingml/2006/main"/>
           <a:p xmlns:a="http://schemas.openxmlformats.org/drawingml/2006/main">
             <a:r>
-              <a:t>Ownership is intentionally split</a:t>
+              <a:t>The decision we need from each project</a:t>
             </a:r>
           </a:p>
         </p:txBody>
@@ -31544,7 +31413,7 @@
                   <a:srgbClr val="000000"/>
                 </a:solidFill>
               </a:rPr>
-              <a:t> Project maintainers own</a:t>
+              <a:t> Name one owner</a:t>
             </a:r>
             <a:r>
               <a:rPr sz="1913">
@@ -31552,7 +31421,7 @@
                   <a:srgbClr val="000000"/>
                 </a:solidFill>
               </a:rPr>
-              <a:t> — Triggers, technical guidance, official sources, limitations, and whether task scenarios are authentic.</a:t>
+              <a:t> — A maintainer or small reviewer group for scope and source freshness.</a:t>
             </a:r>
           </a:p>
           <a:p xmlns:a="http://schemas.openxmlformats.org/drawingml/2006/main">
@@ -31573,7 +31442,7 @@
                   <a:srgbClr val="000000"/>
                 </a:solidFill>
               </a:rPr>
-              <a:t> UXL shared infrastructure owns</a:t>
+              <a:t> Approve or correct the first-pass guidance</a:t>
             </a:r>
             <a:r>
               <a:rPr sz="1913">
@@ -31581,7 +31450,7 @@
                   <a:srgbClr val="000000"/>
                 </a:solidFill>
               </a:rPr>
-              <a:t> — Catalog validation, Harbor harnesses, comparison policy, dashboards, hosted CI, and runner contracts.</a:t>
+              <a:t> — Especially triggers, gotchas, unsupported paths, and terminology.</a:t>
             </a:r>
           </a:p>
           <a:p xmlns:a="http://schemas.openxmlformats.org/drawingml/2006/main">
@@ -31602,7 +31471,7 @@
                   <a:srgbClr val="000000"/>
                 </a:solidFill>
               </a:rPr>
-              <a:t> Hardware owners opt in</a:t>
+              <a:t> Validate the task inventory</a:t>
             </a:r>
             <a:r>
               <a:rPr sz="1913">
@@ -31610,7 +31479,7 @@
                   <a:srgbClr val="000000"/>
                 </a:solidFill>
               </a:rPr>
-              <a:t> — They qualify a declared environment, run only reviewed immutable evaluator revisions, and return evidence artifacts.</a:t>
+              <a:t> — Keep, rewrite, or delete scenarios; nominate one real support issue or regression.</a:t>
             </a:r>
           </a:p>
           <a:p xmlns:a="http://schemas.openxmlformats.org/drawingml/2006/main">
@@ -31631,7 +31500,7 @@
                   <a:srgbClr val="000000"/>
                 </a:solidFill>
               </a:rPr>
-              <a:t> No silent promotion</a:t>
+              <a:t> Adopt a light cadence</a:t>
             </a:r>
             <a:r>
               <a:rPr sz="1913">
@@ -31639,7 +31508,36 @@
                   <a:srgbClr val="000000"/>
                 </a:solidFill>
               </a:rPr>
-              <a:t> — Project approval, source verification, realistic eval prompts, matched trials when feasible, and explicit limitations remain gates.</a:t>
+              <a:t> — Review skill-affecting PRs and recheck sources at releases or quarterly.</a:t>
+            </a:r>
+          </a:p>
+          <a:p xmlns:a="http://schemas.openxmlformats.org/drawingml/2006/main">
+            <a:pPr marL="30" indent="-18">
+              <a:spcAft>
+                <a:spcPts val="10"/>
+              </a:spcAft>
+              <a:buChar char="•"/>
+              <a:defRPr sz="1913">
+                <a:solidFill>
+                  <a:srgbClr val="000000"/>
+                </a:solidFill>
+              </a:defRPr>
+            </a:pPr>
+            <a:r>
+              <a:rPr sz="1913" b="1">
+                <a:solidFill>
+                  <a:srgbClr val="000000"/>
+                </a:solidFill>
+              </a:rPr>
+              <a:t> Start small</a:t>
+            </a:r>
+            <a:r>
+              <a:rPr sz="1913">
+                <a:solidFill>
+                  <a:srgbClr val="000000"/>
+                </a:solidFill>
+              </a:rPr>
+              <a:t> — A 30-minute review is enough to turn this from UXL-authored draft into project-backed guidance.</a:t>
             </a:r>
           </a:p>
         </p:txBody>
@@ -31676,272 +31574,6 @@
           <a:p xmlns:a="http://schemas.openxmlformats.org/drawingml/2006/main">
             <a:r>
               <a:t>13</a:t>
-            </a:r>
-          </a:p>
-        </p:txBody>
-      </p:sp>
-    </p:spTree>
-    <p:extLst>
-      <p:ext uri="{BB962C8B-B14F-4D97-AF65-F5344CB8AC3E}">
-        <p14:creationId xmlns:p14="http://schemas.microsoft.com/office/powerpoint/2010/main" val="1742728663"/>
-      </p:ext>
-    </p:extLst>
-  </p:cSld>
-</p:sld>
-</file>
-
-<file path=ppt/slides/slide14.xml><?xml version="1.0" encoding="utf-8"?>
-<p:sld xmlns:p="http://schemas.openxmlformats.org/presentationml/2006/main">
-  <p:cSld>
-    <p:spTree>
-      <p:nvGrpSpPr>
-        <p:cNvPr id="1" name=""/>
-        <p:cNvGrpSpPr/>
-        <p:nvPr/>
-      </p:nvGrpSpPr>
-      <p:grpSpPr>
-        <a:xfrm xmlns:a="http://schemas.openxmlformats.org/drawingml/2006/main"/>
-      </p:grpSpPr>
-      <p:sp>
-        <p:nvSpPr>
-          <p:cNvPr id="2" name="Title 1">
-            <a:extLst xmlns:a="http://schemas.openxmlformats.org/drawingml/2006/main">
-              <a:ext uri="{FF2B5EF4-FFF2-40B4-BE49-F238E27FC236}">
-                <a16:creationId xmlns:a16="http://schemas.microsoft.com/office/drawing/2014/main" id="{F64C2A24-546D-C55C-2C52-97A4957F67E0}"/>
-              </a:ext>
-            </a:extLst>
-          </p:cNvPr>
-          <p:cNvSpPr>
-            <a:spLocks xmlns:a="http://schemas.openxmlformats.org/drawingml/2006/main" noGrp="1"/>
-          </p:cNvSpPr>
-          <p:nvPr>
-            <p:ph type="title" idx="0"/>
-          </p:nvPr>
-        </p:nvSpPr>
-        <p:spPr>
-          <a:xfrm xmlns:a="http://schemas.openxmlformats.org/drawingml/2006/main">
-            <a:off x="838200" y="365125"/>
-            <a:ext cx="10515600" cy="1325700"/>
-          </a:xfrm>
-        </p:spPr>
-        <p:txBody>
-          <a:bodyPr xmlns:a="http://schemas.openxmlformats.org/drawingml/2006/main">
-            <a:normAutofit fontScale="100000"/>
-          </a:bodyPr>
-          <a:lstStyle xmlns:a="http://schemas.openxmlformats.org/drawingml/2006/main"/>
-          <a:p xmlns:a="http://schemas.openxmlformats.org/drawingml/2006/main">
-            <a:r>
-              <a:t>The decision we need from each project</a:t>
-            </a:r>
-          </a:p>
-        </p:txBody>
-      </p:sp>
-      <p:sp>
-        <p:nvSpPr>
-          <p:cNvPr id="3" name="Content Placeholder 2">
-            <a:extLst xmlns:a="http://schemas.openxmlformats.org/drawingml/2006/main">
-              <a:ext uri="{FF2B5EF4-FFF2-40B4-BE49-F238E27FC236}">
-                <a16:creationId xmlns:a16="http://schemas.microsoft.com/office/drawing/2014/main" id="{ECF5C9F1-2691-0BC9-F1E1-01CECB857FE3}"/>
-              </a:ext>
-            </a:extLst>
-          </p:cNvPr>
-          <p:cNvSpPr>
-            <a:spLocks xmlns:a="http://schemas.openxmlformats.org/drawingml/2006/main" noGrp="1"/>
-          </p:cNvSpPr>
-          <p:nvPr>
-            <p:ph type="body" idx="1"/>
-          </p:nvPr>
-        </p:nvSpPr>
-        <p:spPr>
-          <a:xfrm xmlns:a="http://schemas.openxmlformats.org/drawingml/2006/main">
-            <a:off x="838200" y="1825625"/>
-            <a:ext cx="10515600" cy="4351200"/>
-          </a:xfrm>
-        </p:spPr>
-        <p:txBody>
-          <a:bodyPr xmlns:a="http://schemas.openxmlformats.org/drawingml/2006/main" wrap="square" anchor="t">
-            <a:normAutofit fontScale="100000"/>
-          </a:bodyPr>
-          <a:lstStyle xmlns:a="http://schemas.openxmlformats.org/drawingml/2006/main"/>
-          <a:p xmlns:a="http://schemas.openxmlformats.org/drawingml/2006/main">
-            <a:pPr marL="30" indent="-18">
-              <a:spcAft>
-                <a:spcPts val="10"/>
-              </a:spcAft>
-              <a:buChar char="•"/>
-              <a:defRPr sz="1913">
-                <a:solidFill>
-                  <a:srgbClr val="000000"/>
-                </a:solidFill>
-              </a:defRPr>
-            </a:pPr>
-            <a:r>
-              <a:rPr sz="1913" b="1">
-                <a:solidFill>
-                  <a:srgbClr val="000000"/>
-                </a:solidFill>
-              </a:rPr>
-              <a:t> Name one owner</a:t>
-            </a:r>
-            <a:r>
-              <a:rPr sz="1913">
-                <a:solidFill>
-                  <a:srgbClr val="000000"/>
-                </a:solidFill>
-              </a:rPr>
-              <a:t> — A maintainer or small reviewer group for scope and source freshness.</a:t>
-            </a:r>
-          </a:p>
-          <a:p xmlns:a="http://schemas.openxmlformats.org/drawingml/2006/main">
-            <a:pPr marL="30" indent="-18">
-              <a:spcAft>
-                <a:spcPts val="10"/>
-              </a:spcAft>
-              <a:buChar char="•"/>
-              <a:defRPr sz="1913">
-                <a:solidFill>
-                  <a:srgbClr val="000000"/>
-                </a:solidFill>
-              </a:defRPr>
-            </a:pPr>
-            <a:r>
-              <a:rPr sz="1913" b="1">
-                <a:solidFill>
-                  <a:srgbClr val="000000"/>
-                </a:solidFill>
-              </a:rPr>
-              <a:t> Approve or correct the first-pass guidance</a:t>
-            </a:r>
-            <a:r>
-              <a:rPr sz="1913">
-                <a:solidFill>
-                  <a:srgbClr val="000000"/>
-                </a:solidFill>
-              </a:rPr>
-              <a:t> — Especially triggers, gotchas, unsupported paths, and terminology.</a:t>
-            </a:r>
-          </a:p>
-          <a:p xmlns:a="http://schemas.openxmlformats.org/drawingml/2006/main">
-            <a:pPr marL="30" indent="-18">
-              <a:spcAft>
-                <a:spcPts val="10"/>
-              </a:spcAft>
-              <a:buChar char="•"/>
-              <a:defRPr sz="1913">
-                <a:solidFill>
-                  <a:srgbClr val="000000"/>
-                </a:solidFill>
-              </a:defRPr>
-            </a:pPr>
-            <a:r>
-              <a:rPr sz="1913" b="1">
-                <a:solidFill>
-                  <a:srgbClr val="000000"/>
-                </a:solidFill>
-              </a:rPr>
-              <a:t> Validate the task inventory</a:t>
-            </a:r>
-            <a:r>
-              <a:rPr sz="1913">
-                <a:solidFill>
-                  <a:srgbClr val="000000"/>
-                </a:solidFill>
-              </a:rPr>
-              <a:t> — Keep, rewrite, or delete scenarios; nominate one real support issue or regression.</a:t>
-            </a:r>
-          </a:p>
-          <a:p xmlns:a="http://schemas.openxmlformats.org/drawingml/2006/main">
-            <a:pPr marL="30" indent="-18">
-              <a:spcAft>
-                <a:spcPts val="10"/>
-              </a:spcAft>
-              <a:buChar char="•"/>
-              <a:defRPr sz="1913">
-                <a:solidFill>
-                  <a:srgbClr val="000000"/>
-                </a:solidFill>
-              </a:defRPr>
-            </a:pPr>
-            <a:r>
-              <a:rPr sz="1913" b="1">
-                <a:solidFill>
-                  <a:srgbClr val="000000"/>
-                </a:solidFill>
-              </a:rPr>
-              <a:t> Adopt a light cadence</a:t>
-            </a:r>
-            <a:r>
-              <a:rPr sz="1913">
-                <a:solidFill>
-                  <a:srgbClr val="000000"/>
-                </a:solidFill>
-              </a:rPr>
-              <a:t> — Review skill-affecting PRs and recheck sources at releases or quarterly.</a:t>
-            </a:r>
-          </a:p>
-          <a:p xmlns:a="http://schemas.openxmlformats.org/drawingml/2006/main">
-            <a:pPr marL="30" indent="-18">
-              <a:spcAft>
-                <a:spcPts val="10"/>
-              </a:spcAft>
-              <a:buChar char="•"/>
-              <a:defRPr sz="1913">
-                <a:solidFill>
-                  <a:srgbClr val="000000"/>
-                </a:solidFill>
-              </a:defRPr>
-            </a:pPr>
-            <a:r>
-              <a:rPr sz="1913" b="1">
-                <a:solidFill>
-                  <a:srgbClr val="000000"/>
-                </a:solidFill>
-              </a:rPr>
-              <a:t> Start small</a:t>
-            </a:r>
-            <a:r>
-              <a:rPr sz="1913">
-                <a:solidFill>
-                  <a:srgbClr val="000000"/>
-                </a:solidFill>
-              </a:rPr>
-              <a:t> — A 30-minute review is enough to turn this from UXL-authored draft into project-backed guidance.</a:t>
-            </a:r>
-          </a:p>
-        </p:txBody>
-      </p:sp>
-      <p:sp>
-        <p:nvSpPr>
-          <p:cNvPr id="7" name="TextBox 6">
-            <a:extLst xmlns:a="http://schemas.openxmlformats.org/drawingml/2006/main">
-              <a:ext uri="{FF2B5EF4-FFF2-40B4-BE49-F238E27FC236}">
-                <a16:creationId xmlns:a16="http://schemas.microsoft.com/office/drawing/2014/main" id="{E2E6F043-0F84-54F7-A567-6E5851801779}"/>
-              </a:ext>
-            </a:extLst>
-          </p:cNvPr>
-          <p:cNvSpPr>
-            <a:spLocks xmlns:a="http://schemas.openxmlformats.org/drawingml/2006/main" noGrp="1"/>
-          </p:cNvSpPr>
-          <p:nvPr/>
-        </p:nvSpPr>
-        <p:spPr>
-          <a:xfrm xmlns:a="http://schemas.openxmlformats.org/drawingml/2006/main">
-            <a:off x="696174" y="6338986"/>
-            <a:ext cx="284052" cy="307777"/>
-          </a:xfrm>
-          <a:prstGeom xmlns:a="http://schemas.openxmlformats.org/drawingml/2006/main" prst="rect">
-            <a:avLst/>
-          </a:prstGeom>
-          <a:noFill xmlns:a="http://schemas.openxmlformats.org/drawingml/2006/main"/>
-        </p:spPr>
-        <p:txBody>
-          <a:bodyPr xmlns:a="http://schemas.openxmlformats.org/drawingml/2006/main" wrap="none">
-            <a:spAutoFit/>
-          </a:bodyPr>
-          <a:lstStyle xmlns:a="http://schemas.openxmlformats.org/drawingml/2006/main"/>
-          <a:p xmlns:a="http://schemas.openxmlformats.org/drawingml/2006/main">
-            <a:r>
-              <a:t>14</a:t>
             </a:r>
           </a:p>
         </p:txBody>
@@ -31997,7 +31629,7 @@
           <a:lstStyle xmlns:a="http://schemas.openxmlformats.org/drawingml/2006/main"/>
           <a:p xmlns:a="http://schemas.openxmlformats.org/drawingml/2006/main">
             <a:r>
-              <a:t>Why project maintainers should care</a:t>
+              <a:t>What exists today</a:t>
             </a:r>
           </a:p>
         </p:txBody>
@@ -32047,7 +31679,7 @@
                   <a:srgbClr val="000000"/>
                 </a:solidFill>
               </a:rPr>
-              <a:t> Fewer repeat explanations</a:t>
+              <a:t> 8 skills</a:t>
             </a:r>
             <a:r>
               <a:rPr sz="1913">
@@ -32055,7 +31687,7 @@
                   <a:srgbClr val="000000"/>
                 </a:solidFill>
               </a:rPr>
-              <a:t> — Capture the review comments, setup choices, and failure triage your team repeats today.</a:t>
+              <a:t> — Six library portfolios plus shared SYCL build/debug and performance-validation guidance.</a:t>
             </a:r>
           </a:p>
           <a:p xmlns:a="http://schemas.openxmlformats.org/drawingml/2006/main">
@@ -32076,7 +31708,7 @@
                   <a:srgbClr val="000000"/>
                 </a:solidFill>
               </a:rPr>
-              <a:t> Safer agent contributions</a:t>
+              <a:t> 52 scoped evaluation tasks</a:t>
             </a:r>
             <a:r>
               <a:rPr sz="1913">
@@ -32084,7 +31716,7 @@
                   <a:srgbClr val="000000"/>
                 </a:solidFill>
               </a:rPr>
-              <a:t> — Guide agents toward project-owned APIs, tests, evidence, and honest limitations before they open a PR.</a:t>
+              <a:t> — 41 implemented and 11 left visible as planned gaps; this is inventory, not a pass-rate claim.</a:t>
             </a:r>
           </a:p>
           <a:p xmlns:a="http://schemas.openxmlformats.org/drawingml/2006/main">
@@ -32105,7 +31737,7 @@
                   <a:srgbClr val="000000"/>
                 </a:solidFill>
               </a:rPr>
-              <a:t> Reviewable change control</a:t>
+              <a:t> A public control room</a:t>
             </a:r>
             <a:r>
               <a:rPr sz="1913">
@@ -32113,7 +31745,7 @@
                   <a:srgbClr val="000000"/>
                 </a:solidFill>
               </a:rPr>
-              <a:t> — Skills are small repository files; guidance changes arrive through normal GitHub review.</a:t>
+              <a:t> — Skills, evaluations, platforms, methodology, maturity, source freshness, and ownership status.</a:t>
             </a:r>
           </a:p>
           <a:p xmlns:a="http://schemas.openxmlformats.org/drawingml/2006/main">
@@ -32134,7 +31766,7 @@
                   <a:srgbClr val="000000"/>
                 </a:solidFill>
               </a:rPr>
-              <a:t> Measured usefulness</a:t>
+              <a:t> A portable execution model</a:t>
             </a:r>
             <a:r>
               <a:rPr sz="1913">
@@ -32142,7 +31774,7 @@
                   <a:srgbClr val="000000"/>
                 </a:solidFill>
               </a:rPr>
-              <a:t> — Executable evaluations check whether the guidance improves verified outcomes — not just whether it sounds plausible.</a:t>
+              <a:t> — GitHub-hosted checks by default; opt-in specialized machines only when a task contract requires them.</a:t>
             </a:r>
           </a:p>
         </p:txBody>
@@ -32234,7 +31866,7 @@
           <a:lstStyle xmlns:a="http://schemas.openxmlformats.org/drawingml/2006/main"/>
           <a:p xmlns:a="http://schemas.openxmlformats.org/drawingml/2006/main">
             <a:r>
-              <a:t>What exists today</a:t>
+              <a:t>The current skill catalog — at a glance</a:t>
             </a:r>
           </a:p>
         </p:txBody>
@@ -32284,7 +31916,7 @@
                   <a:srgbClr val="000000"/>
                 </a:solidFill>
               </a:rPr>
-              <a:t> 8 skills</a:t>
+              <a:t> oneDNN</a:t>
             </a:r>
             <a:r>
               <a:rPr sz="1913">
@@ -32292,7 +31924,7 @@
                   <a:srgbClr val="000000"/>
                 </a:solidFill>
               </a:rPr>
-              <a:t> — Six library portfolios plus shared SYCL build/debug and performance-validation guidance.</a:t>
+              <a:t> — Primitives, layouts/reorders, fusion, numerics, benchdnn.</a:t>
             </a:r>
           </a:p>
           <a:p xmlns:a="http://schemas.openxmlformats.org/drawingml/2006/main">
@@ -32313,7 +31945,7 @@
                   <a:srgbClr val="000000"/>
                 </a:solidFill>
               </a:rPr>
-              <a:t> 52 scoped evaluation tasks</a:t>
+              <a:t> oneMath</a:t>
             </a:r>
             <a:r>
               <a:rPr sz="1913">
@@ -32321,7 +31953,7 @@
                   <a:srgbClr val="000000"/>
                 </a:solidFill>
               </a:rPr>
-              <a:t> — 41 implemented and 11 left visible as planned gaps; this is inventory, not a pass-rate claim.</a:t>
+              <a:t> — Domains, dispatch modes, queues, backends, linking.</a:t>
             </a:r>
           </a:p>
           <a:p xmlns:a="http://schemas.openxmlformats.org/drawingml/2006/main">
@@ -32342,7 +31974,7 @@
                   <a:srgbClr val="000000"/>
                 </a:solidFill>
               </a:rPr>
-              <a:t> A public control room</a:t>
+              <a:t> oneDAL</a:t>
             </a:r>
             <a:r>
               <a:rPr sz="1913">
@@ -32350,7 +31982,7 @@
                   <a:srgbClr val="000000"/>
                 </a:solidFill>
               </a:rPr>
-              <a:t> — Skills, evaluations, platforms, methodology, maturity, source freshness, and ownership status.</a:t>
+              <a:t> — Python/native paths, modes, tables, metric parity, conversion cost.</a:t>
             </a:r>
           </a:p>
           <a:p xmlns:a="http://schemas.openxmlformats.org/drawingml/2006/main">
@@ -32371,7 +32003,7 @@
                   <a:srgbClr val="000000"/>
                 </a:solidFill>
               </a:rPr>
-              <a:t> A portable execution model</a:t>
+              <a:t> oneTBB</a:t>
             </a:r>
             <a:r>
               <a:rPr sz="1913">
@@ -32379,7 +32011,94 @@
                   <a:srgbClr val="000000"/>
                 </a:solidFill>
               </a:rPr>
-              <a:t> — GitHub-hosted checks by default; opt-in specialized machines only when a task contract requires them.</a:t>
+              <a:t> — Patterns, shared state, flow graphs, arenas, grainsize/affinity.</a:t>
+            </a:r>
+          </a:p>
+          <a:p xmlns:a="http://schemas.openxmlformats.org/drawingml/2006/main">
+            <a:pPr marL="30" indent="-18">
+              <a:spcAft>
+                <a:spcPts val="10"/>
+              </a:spcAft>
+              <a:buChar char="•"/>
+              <a:defRPr sz="1913">
+                <a:solidFill>
+                  <a:srgbClr val="000000"/>
+                </a:solidFill>
+              </a:defRPr>
+            </a:pPr>
+            <a:r>
+              <a:rPr sz="1913" b="1">
+                <a:solidFill>
+                  <a:srgbClr val="000000"/>
+                </a:solidFill>
+              </a:rPr>
+              <a:t> oneDPL</a:t>
+            </a:r>
+            <a:r>
+              <a:rPr sz="1913">
+                <a:solidFill>
+                  <a:srgbClr val="000000"/>
+                </a:solidFill>
+              </a:rPr>
+              <a:t> — Host/device policies, iterators, lifetime, synchronization, ordering.</a:t>
+            </a:r>
+          </a:p>
+          <a:p xmlns:a="http://schemas.openxmlformats.org/drawingml/2006/main">
+            <a:pPr marL="30" indent="-18">
+              <a:spcAft>
+                <a:spcPts val="10"/>
+              </a:spcAft>
+              <a:buChar char="•"/>
+              <a:defRPr sz="1913">
+                <a:solidFill>
+                  <a:srgbClr val="000000"/>
+                </a:solidFill>
+              </a:defRPr>
+            </a:pPr>
+            <a:r>
+              <a:rPr sz="1913" b="1">
+                <a:solidFill>
+                  <a:srgbClr val="000000"/>
+                </a:solidFill>
+              </a:rPr>
+              <a:t> oneCCL</a:t>
+            </a:r>
+            <a:r>
+              <a:rPr sz="1913">
+                <a:solidFill>
+                  <a:srgbClr val="000000"/>
+                </a:solidFill>
+              </a:rPr>
+              <a:t> — Collectives, ranks, launch symmetry, waits, plugins, hangs.</a:t>
+            </a:r>
+          </a:p>
+          <a:p xmlns:a="http://schemas.openxmlformats.org/drawingml/2006/main">
+            <a:pPr marL="30" indent="-18">
+              <a:spcAft>
+                <a:spcPts val="10"/>
+              </a:spcAft>
+              <a:buChar char="•"/>
+              <a:defRPr sz="1913">
+                <a:solidFill>
+                  <a:srgbClr val="000000"/>
+                </a:solidFill>
+              </a:defRPr>
+            </a:pPr>
+            <a:r>
+              <a:rPr sz="1913" b="1">
+                <a:solidFill>
+                  <a:srgbClr val="000000"/>
+                </a:solidFill>
+              </a:rPr>
+              <a:t> Cross-project</a:t>
+            </a:r>
+            <a:r>
+              <a:rPr sz="1913">
+                <a:solidFill>
+                  <a:srgbClr val="000000"/>
+                </a:solidFill>
+              </a:rPr>
+              <a:t> — SYCL build/runtime triage and correctness-first performance evidence.</a:t>
             </a:r>
           </a:p>
         </p:txBody>
@@ -32471,239 +32190,7 @@
           <a:lstStyle xmlns:a="http://schemas.openxmlformats.org/drawingml/2006/main"/>
           <a:p xmlns:a="http://schemas.openxmlformats.org/drawingml/2006/main">
             <a:r>
-              <a:t>The current skill catalog — at a glance</a:t>
-            </a:r>
-          </a:p>
-        </p:txBody>
-      </p:sp>
-      <p:sp>
-        <p:nvSpPr>
-          <p:cNvPr id="3" name="Content Placeholder 2">
-            <a:extLst xmlns:a="http://schemas.openxmlformats.org/drawingml/2006/main">
-              <a:ext uri="{FF2B5EF4-FFF2-40B4-BE49-F238E27FC236}">
-                <a16:creationId xmlns:a16="http://schemas.microsoft.com/office/drawing/2014/main" id="{ECF5C9F1-2691-0BC9-F1E1-01CECB857FE3}"/>
-              </a:ext>
-            </a:extLst>
-          </p:cNvPr>
-          <p:cNvSpPr>
-            <a:spLocks xmlns:a="http://schemas.openxmlformats.org/drawingml/2006/main" noGrp="1"/>
-          </p:cNvSpPr>
-          <p:nvPr>
-            <p:ph type="body" idx="1"/>
-          </p:nvPr>
-        </p:nvSpPr>
-        <p:spPr>
-          <a:xfrm xmlns:a="http://schemas.openxmlformats.org/drawingml/2006/main">
-            <a:off x="838200" y="1825625"/>
-            <a:ext cx="10515600" cy="4351200"/>
-          </a:xfrm>
-        </p:spPr>
-        <p:txBody>
-          <a:bodyPr xmlns:a="http://schemas.openxmlformats.org/drawingml/2006/main" wrap="square" anchor="t">
-            <a:normAutofit fontScale="100000"/>
-          </a:bodyPr>
-          <a:lstStyle xmlns:a="http://schemas.openxmlformats.org/drawingml/2006/main"/>
-          <a:p xmlns:a="http://schemas.openxmlformats.org/drawingml/2006/main">
-            <a:pPr marL="30" indent="-18">
-              <a:spcAft>
-                <a:spcPts val="10"/>
-              </a:spcAft>
-              <a:buChar char="•"/>
-              <a:defRPr sz="1913">
-                <a:solidFill>
-                  <a:srgbClr val="000000"/>
-                </a:solidFill>
-              </a:defRPr>
-            </a:pPr>
-            <a:r>
-              <a:rPr sz="1913" b="1">
-                <a:solidFill>
-                  <a:srgbClr val="000000"/>
-                </a:solidFill>
-              </a:rPr>
-              <a:t> oneDNN</a:t>
-            </a:r>
-            <a:r>
-              <a:rPr sz="1913">
-                <a:solidFill>
-                  <a:srgbClr val="000000"/>
-                </a:solidFill>
-              </a:rPr>
-              <a:t> — Primitives, layouts/reorders, fusion, numerics, benchdnn.</a:t>
-            </a:r>
-          </a:p>
-          <a:p xmlns:a="http://schemas.openxmlformats.org/drawingml/2006/main">
-            <a:pPr marL="30" indent="-18">
-              <a:spcAft>
-                <a:spcPts val="10"/>
-              </a:spcAft>
-              <a:buChar char="•"/>
-              <a:defRPr sz="1913">
-                <a:solidFill>
-                  <a:srgbClr val="000000"/>
-                </a:solidFill>
-              </a:defRPr>
-            </a:pPr>
-            <a:r>
-              <a:rPr sz="1913" b="1">
-                <a:solidFill>
-                  <a:srgbClr val="000000"/>
-                </a:solidFill>
-              </a:rPr>
-              <a:t> oneMath</a:t>
-            </a:r>
-            <a:r>
-              <a:rPr sz="1913">
-                <a:solidFill>
-                  <a:srgbClr val="000000"/>
-                </a:solidFill>
-              </a:rPr>
-              <a:t> — Domains, dispatch modes, queues, backends, linking.</a:t>
-            </a:r>
-          </a:p>
-          <a:p xmlns:a="http://schemas.openxmlformats.org/drawingml/2006/main">
-            <a:pPr marL="30" indent="-18">
-              <a:spcAft>
-                <a:spcPts val="10"/>
-              </a:spcAft>
-              <a:buChar char="•"/>
-              <a:defRPr sz="1913">
-                <a:solidFill>
-                  <a:srgbClr val="000000"/>
-                </a:solidFill>
-              </a:defRPr>
-            </a:pPr>
-            <a:r>
-              <a:rPr sz="1913" b="1">
-                <a:solidFill>
-                  <a:srgbClr val="000000"/>
-                </a:solidFill>
-              </a:rPr>
-              <a:t> oneDAL</a:t>
-            </a:r>
-            <a:r>
-              <a:rPr sz="1913">
-                <a:solidFill>
-                  <a:srgbClr val="000000"/>
-                </a:solidFill>
-              </a:rPr>
-              <a:t> — Python/native paths, modes, tables, metric parity, conversion cost.</a:t>
-            </a:r>
-          </a:p>
-          <a:p xmlns:a="http://schemas.openxmlformats.org/drawingml/2006/main">
-            <a:pPr marL="30" indent="-18">
-              <a:spcAft>
-                <a:spcPts val="10"/>
-              </a:spcAft>
-              <a:buChar char="•"/>
-              <a:defRPr sz="1913">
-                <a:solidFill>
-                  <a:srgbClr val="000000"/>
-                </a:solidFill>
-              </a:defRPr>
-            </a:pPr>
-            <a:r>
-              <a:rPr sz="1913" b="1">
-                <a:solidFill>
-                  <a:srgbClr val="000000"/>
-                </a:solidFill>
-              </a:rPr>
-              <a:t> oneTBB</a:t>
-            </a:r>
-            <a:r>
-              <a:rPr sz="1913">
-                <a:solidFill>
-                  <a:srgbClr val="000000"/>
-                </a:solidFill>
-              </a:rPr>
-              <a:t> — Patterns, shared state, flow graphs, arenas, grainsize/affinity.</a:t>
-            </a:r>
-          </a:p>
-          <a:p xmlns:a="http://schemas.openxmlformats.org/drawingml/2006/main">
-            <a:pPr marL="30" indent="-18">
-              <a:spcAft>
-                <a:spcPts val="10"/>
-              </a:spcAft>
-              <a:buChar char="•"/>
-              <a:defRPr sz="1913">
-                <a:solidFill>
-                  <a:srgbClr val="000000"/>
-                </a:solidFill>
-              </a:defRPr>
-            </a:pPr>
-            <a:r>
-              <a:rPr sz="1913" b="1">
-                <a:solidFill>
-                  <a:srgbClr val="000000"/>
-                </a:solidFill>
-              </a:rPr>
-              <a:t> oneDPL</a:t>
-            </a:r>
-            <a:r>
-              <a:rPr sz="1913">
-                <a:solidFill>
-                  <a:srgbClr val="000000"/>
-                </a:solidFill>
-              </a:rPr>
-              <a:t> — Host/device policies, iterators, lifetime, synchronization, ordering.</a:t>
-            </a:r>
-          </a:p>
-          <a:p xmlns:a="http://schemas.openxmlformats.org/drawingml/2006/main">
-            <a:pPr marL="30" indent="-18">
-              <a:spcAft>
-                <a:spcPts val="10"/>
-              </a:spcAft>
-              <a:buChar char="•"/>
-              <a:defRPr sz="1913">
-                <a:solidFill>
-                  <a:srgbClr val="000000"/>
-                </a:solidFill>
-              </a:defRPr>
-            </a:pPr>
-            <a:r>
-              <a:rPr sz="1913" b="1">
-                <a:solidFill>
-                  <a:srgbClr val="000000"/>
-                </a:solidFill>
-              </a:rPr>
-              <a:t> oneCCL</a:t>
-            </a:r>
-            <a:r>
-              <a:rPr sz="1913">
-                <a:solidFill>
-                  <a:srgbClr val="000000"/>
-                </a:solidFill>
-              </a:rPr>
-              <a:t> — Collectives, ranks, launch symmetry, waits, plugins, hangs.</a:t>
-            </a:r>
-          </a:p>
-          <a:p xmlns:a="http://schemas.openxmlformats.org/drawingml/2006/main">
-            <a:pPr marL="30" indent="-18">
-              <a:spcAft>
-                <a:spcPts val="10"/>
-              </a:spcAft>
-              <a:buChar char="•"/>
-              <a:defRPr sz="1913">
-                <a:solidFill>
-                  <a:srgbClr val="000000"/>
-                </a:solidFill>
-              </a:defRPr>
-            </a:pPr>
-            <a:r>
-              <a:rPr sz="1913" b="1">
-                <a:solidFill>
-                  <a:srgbClr val="000000"/>
-                </a:solidFill>
-              </a:rPr>
-              <a:t> Cross-project</a:t>
-            </a:r>
-            <a:r>
-              <a:rPr sz="1913">
-                <a:solidFill>
-                  <a:srgbClr val="000000"/>
-                </a:solidFill>
-              </a:rPr>
-              <a:t> — SYCL build/runtime triage and correctness-first performance evidence.</a:t>
+              <a:t>Architecture: project knowledge becomes measured evidence</a:t>
             </a:r>
           </a:p>
         </p:txBody>
@@ -32740,98 +32227,6 @@
           <a:p xmlns:a="http://schemas.openxmlformats.org/drawingml/2006/main">
             <a:r>
               <a:t>4</a:t>
-            </a:r>
-          </a:p>
-        </p:txBody>
-      </p:sp>
-    </p:spTree>
-    <p:extLst>
-      <p:ext uri="{BB962C8B-B14F-4D97-AF65-F5344CB8AC3E}">
-        <p14:creationId xmlns:p14="http://schemas.microsoft.com/office/powerpoint/2010/main" val="1742728663"/>
-      </p:ext>
-    </p:extLst>
-  </p:cSld>
-</p:sld>
-</file>
-
-<file path=ppt/slides/slide5.xml><?xml version="1.0" encoding="utf-8"?>
-<p:sld xmlns:p="http://schemas.openxmlformats.org/presentationml/2006/main">
-  <p:cSld>
-    <p:spTree>
-      <p:nvGrpSpPr>
-        <p:cNvPr id="1" name=""/>
-        <p:cNvGrpSpPr/>
-        <p:nvPr/>
-      </p:nvGrpSpPr>
-      <p:grpSpPr>
-        <a:xfrm xmlns:a="http://schemas.openxmlformats.org/drawingml/2006/main"/>
-      </p:grpSpPr>
-      <p:sp>
-        <p:nvSpPr>
-          <p:cNvPr id="2" name="Title 1">
-            <a:extLst xmlns:a="http://schemas.openxmlformats.org/drawingml/2006/main">
-              <a:ext uri="{FF2B5EF4-FFF2-40B4-BE49-F238E27FC236}">
-                <a16:creationId xmlns:a16="http://schemas.microsoft.com/office/drawing/2014/main" id="{F64C2A24-546D-C55C-2C52-97A4957F67E0}"/>
-              </a:ext>
-            </a:extLst>
-          </p:cNvPr>
-          <p:cNvSpPr>
-            <a:spLocks xmlns:a="http://schemas.openxmlformats.org/drawingml/2006/main" noGrp="1"/>
-          </p:cNvSpPr>
-          <p:nvPr>
-            <p:ph type="title" idx="0"/>
-          </p:nvPr>
-        </p:nvSpPr>
-        <p:spPr>
-          <a:xfrm xmlns:a="http://schemas.openxmlformats.org/drawingml/2006/main">
-            <a:off x="838200" y="365125"/>
-            <a:ext cx="10515600" cy="1325700"/>
-          </a:xfrm>
-        </p:spPr>
-        <p:txBody>
-          <a:bodyPr xmlns:a="http://schemas.openxmlformats.org/drawingml/2006/main">
-            <a:normAutofit fontScale="100000"/>
-          </a:bodyPr>
-          <a:lstStyle xmlns:a="http://schemas.openxmlformats.org/drawingml/2006/main"/>
-          <a:p xmlns:a="http://schemas.openxmlformats.org/drawingml/2006/main">
-            <a:r>
-              <a:t>Architecture: project knowledge becomes measured evidence</a:t>
-            </a:r>
-          </a:p>
-        </p:txBody>
-      </p:sp>
-      <p:sp>
-        <p:nvSpPr>
-          <p:cNvPr id="7" name="TextBox 6">
-            <a:extLst xmlns:a="http://schemas.openxmlformats.org/drawingml/2006/main">
-              <a:ext uri="{FF2B5EF4-FFF2-40B4-BE49-F238E27FC236}">
-                <a16:creationId xmlns:a16="http://schemas.microsoft.com/office/drawing/2014/main" id="{E2E6F043-0F84-54F7-A567-6E5851801779}"/>
-              </a:ext>
-            </a:extLst>
-          </p:cNvPr>
-          <p:cNvSpPr>
-            <a:spLocks xmlns:a="http://schemas.openxmlformats.org/drawingml/2006/main" noGrp="1"/>
-          </p:cNvSpPr>
-          <p:nvPr/>
-        </p:nvSpPr>
-        <p:spPr>
-          <a:xfrm xmlns:a="http://schemas.openxmlformats.org/drawingml/2006/main">
-            <a:off x="696174" y="6338986"/>
-            <a:ext cx="284052" cy="307777"/>
-          </a:xfrm>
-          <a:prstGeom xmlns:a="http://schemas.openxmlformats.org/drawingml/2006/main" prst="rect">
-            <a:avLst/>
-          </a:prstGeom>
-          <a:noFill xmlns:a="http://schemas.openxmlformats.org/drawingml/2006/main"/>
-        </p:spPr>
-        <p:txBody>
-          <a:bodyPr xmlns:a="http://schemas.openxmlformats.org/drawingml/2006/main" wrap="none">
-            <a:spAutoFit/>
-          </a:bodyPr>
-          <a:lstStyle xmlns:a="http://schemas.openxmlformats.org/drawingml/2006/main"/>
-          <a:p xmlns:a="http://schemas.openxmlformats.org/drawingml/2006/main">
-            <a:r>
-              <a:t>5</a:t>
             </a:r>
           </a:p>
         </p:txBody>
@@ -33575,6 +32970,120 @@
 </p:sld>
 </file>
 
+<file path=ppt/slides/slide5.xml><?xml version="1.0" encoding="utf-8"?>
+<p:sld xmlns:p="http://schemas.openxmlformats.org/presentationml/2006/main">
+  <p:cSld>
+    <p:spTree>
+      <p:nvGrpSpPr>
+        <p:cNvPr id="1" name=""/>
+        <p:cNvGrpSpPr/>
+        <p:nvPr/>
+      </p:nvGrpSpPr>
+      <p:grpSpPr>
+        <a:xfrm xmlns:a="http://schemas.openxmlformats.org/drawingml/2006/main"/>
+      </p:grpSpPr>
+      <p:sp>
+        <p:nvSpPr>
+          <p:cNvPr id="2" name="Title 1">
+            <a:extLst xmlns:a="http://schemas.openxmlformats.org/drawingml/2006/main">
+              <a:ext uri="{FF2B5EF4-FFF2-40B4-BE49-F238E27FC236}">
+                <a16:creationId xmlns:a16="http://schemas.microsoft.com/office/drawing/2014/main" id="{F64C2A24-546D-C55C-2C52-97A4957F67E0}"/>
+              </a:ext>
+            </a:extLst>
+          </p:cNvPr>
+          <p:cNvSpPr>
+            <a:spLocks xmlns:a="http://schemas.openxmlformats.org/drawingml/2006/main" noGrp="1"/>
+          </p:cNvSpPr>
+          <p:nvPr>
+            <p:ph type="title" idx="0"/>
+          </p:nvPr>
+        </p:nvSpPr>
+        <p:spPr>
+          <a:xfrm xmlns:a="http://schemas.openxmlformats.org/drawingml/2006/main">
+            <a:off x="838200" y="365125"/>
+            <a:ext cx="10515600" cy="1325700"/>
+          </a:xfrm>
+        </p:spPr>
+        <p:txBody>
+          <a:bodyPr xmlns:a="http://schemas.openxmlformats.org/drawingml/2006/main">
+            <a:normAutofit fontScale="100000"/>
+          </a:bodyPr>
+          <a:lstStyle xmlns:a="http://schemas.openxmlformats.org/drawingml/2006/main"/>
+          <a:p xmlns:a="http://schemas.openxmlformats.org/drawingml/2006/main">
+            <a:r>
+              <a:t>The public control room answers: are the skills healthy?</a:t>
+            </a:r>
+          </a:p>
+        </p:txBody>
+      </p:sp>
+      <p:sp>
+        <p:nvSpPr>
+          <p:cNvPr id="7" name="TextBox 6">
+            <a:extLst xmlns:a="http://schemas.openxmlformats.org/drawingml/2006/main">
+              <a:ext uri="{FF2B5EF4-FFF2-40B4-BE49-F238E27FC236}">
+                <a16:creationId xmlns:a16="http://schemas.microsoft.com/office/drawing/2014/main" id="{E2E6F043-0F84-54F7-A567-6E5851801779}"/>
+              </a:ext>
+            </a:extLst>
+          </p:cNvPr>
+          <p:cNvSpPr>
+            <a:spLocks xmlns:a="http://schemas.openxmlformats.org/drawingml/2006/main" noGrp="1"/>
+          </p:cNvSpPr>
+          <p:nvPr/>
+        </p:nvSpPr>
+        <p:spPr>
+          <a:xfrm xmlns:a="http://schemas.openxmlformats.org/drawingml/2006/main">
+            <a:off x="696174" y="6338986"/>
+            <a:ext cx="284052" cy="307777"/>
+          </a:xfrm>
+          <a:prstGeom xmlns:a="http://schemas.openxmlformats.org/drawingml/2006/main" prst="rect">
+            <a:avLst/>
+          </a:prstGeom>
+          <a:noFill xmlns:a="http://schemas.openxmlformats.org/drawingml/2006/main"/>
+        </p:spPr>
+        <p:txBody>
+          <a:bodyPr xmlns:a="http://schemas.openxmlformats.org/drawingml/2006/main" wrap="none">
+            <a:spAutoFit/>
+          </a:bodyPr>
+          <a:lstStyle xmlns:a="http://schemas.openxmlformats.org/drawingml/2006/main"/>
+          <a:p xmlns:a="http://schemas.openxmlformats.org/drawingml/2006/main">
+            <a:r>
+              <a:t>5</a:t>
+            </a:r>
+          </a:p>
+        </p:txBody>
+      </p:sp>
+      <p:pic>
+        <p:nvPicPr>
+          <p:cNvPr id="11" name=""/>
+          <p:cNvPicPr>
+            <a:picLocks xmlns:a="http://schemas.openxmlformats.org/drawingml/2006/main" noChangeAspect="1"/>
+          </p:cNvPicPr>
+          <p:nvPr/>
+        </p:nvPicPr>
+        <p:blipFill>
+          <a:blip xmlns:r="http://schemas.openxmlformats.org/officeDocument/2006/relationships" xmlns:a="http://schemas.openxmlformats.org/drawingml/2006/main" r:embed="R568997c70bd74330"/>
+          <a:stretch xmlns:a="http://schemas.openxmlformats.org/drawingml/2006/main"/>
+        </p:blipFill>
+        <p:spPr>
+          <a:xfrm xmlns:a="http://schemas.openxmlformats.org/drawingml/2006/main" flipH="0" flipV="0">
+            <a:off x="2322187" y="1885950"/>
+            <a:ext cx="7547626" cy="4248150"/>
+          </a:xfrm>
+          <a:prstGeom xmlns:a="http://schemas.openxmlformats.org/drawingml/2006/main" prst="roundRect">
+            <a:avLst/>
+          </a:prstGeom>
+        </p:spPr>
+      </p:pic>
+    </p:spTree>
+    <p:extLst>
+      <p:ext uri="{BB962C8B-B14F-4D97-AF65-F5344CB8AC3E}">
+        <p14:creationId xmlns:p14="http://schemas.microsoft.com/office/powerpoint/2010/main" val="1742728663"/>
+      </p:ext>
+    </p:extLst>
+  </p:cSld>
+</p:sld>
+</file>
+
 <file path=ppt/slides/slide6.xml><?xml version="1.0" encoding="utf-8"?>
 <p:sld xmlns:p="http://schemas.openxmlformats.org/presentationml/2006/main">
   <p:cSld>
@@ -33616,7 +33125,7 @@
           <a:lstStyle xmlns:a="http://schemas.openxmlformats.org/drawingml/2006/main"/>
           <a:p xmlns:a="http://schemas.openxmlformats.org/drawingml/2006/main">
             <a:r>
-              <a:t>The public control room answers: are the skills healthy?</a:t>
+              <a:t>Maintainers can drill from portfolio to exact task contracts</a:t>
             </a:r>
           </a:p>
         </p:txBody>
@@ -33659,120 +33168,6 @@
       </p:sp>
       <p:pic>
         <p:nvPicPr>
-          <p:cNvPr id="11" name=""/>
-          <p:cNvPicPr>
-            <a:picLocks xmlns:a="http://schemas.openxmlformats.org/drawingml/2006/main" noChangeAspect="1"/>
-          </p:cNvPicPr>
-          <p:nvPr/>
-        </p:nvPicPr>
-        <p:blipFill>
-          <a:blip xmlns:r="http://schemas.openxmlformats.org/officeDocument/2006/relationships" xmlns:a="http://schemas.openxmlformats.org/drawingml/2006/main" r:embed="R775010cb1fee4e0e"/>
-          <a:stretch xmlns:a="http://schemas.openxmlformats.org/drawingml/2006/main"/>
-        </p:blipFill>
-        <p:spPr>
-          <a:xfrm xmlns:a="http://schemas.openxmlformats.org/drawingml/2006/main" flipH="0" flipV="0">
-            <a:off x="2322187" y="1885950"/>
-            <a:ext cx="7547626" cy="4248150"/>
-          </a:xfrm>
-          <a:prstGeom xmlns:a="http://schemas.openxmlformats.org/drawingml/2006/main" prst="roundRect">
-            <a:avLst/>
-          </a:prstGeom>
-        </p:spPr>
-      </p:pic>
-    </p:spTree>
-    <p:extLst>
-      <p:ext uri="{BB962C8B-B14F-4D97-AF65-F5344CB8AC3E}">
-        <p14:creationId xmlns:p14="http://schemas.microsoft.com/office/powerpoint/2010/main" val="1742728663"/>
-      </p:ext>
-    </p:extLst>
-  </p:cSld>
-</p:sld>
-</file>
-
-<file path=ppt/slides/slide7.xml><?xml version="1.0" encoding="utf-8"?>
-<p:sld xmlns:p="http://schemas.openxmlformats.org/presentationml/2006/main">
-  <p:cSld>
-    <p:spTree>
-      <p:nvGrpSpPr>
-        <p:cNvPr id="1" name=""/>
-        <p:cNvGrpSpPr/>
-        <p:nvPr/>
-      </p:nvGrpSpPr>
-      <p:grpSpPr>
-        <a:xfrm xmlns:a="http://schemas.openxmlformats.org/drawingml/2006/main"/>
-      </p:grpSpPr>
-      <p:sp>
-        <p:nvSpPr>
-          <p:cNvPr id="2" name="Title 1">
-            <a:extLst xmlns:a="http://schemas.openxmlformats.org/drawingml/2006/main">
-              <a:ext uri="{FF2B5EF4-FFF2-40B4-BE49-F238E27FC236}">
-                <a16:creationId xmlns:a16="http://schemas.microsoft.com/office/drawing/2014/main" id="{F64C2A24-546D-C55C-2C52-97A4957F67E0}"/>
-              </a:ext>
-            </a:extLst>
-          </p:cNvPr>
-          <p:cNvSpPr>
-            <a:spLocks xmlns:a="http://schemas.openxmlformats.org/drawingml/2006/main" noGrp="1"/>
-          </p:cNvSpPr>
-          <p:nvPr>
-            <p:ph type="title" idx="0"/>
-          </p:nvPr>
-        </p:nvSpPr>
-        <p:spPr>
-          <a:xfrm xmlns:a="http://schemas.openxmlformats.org/drawingml/2006/main">
-            <a:off x="838200" y="365125"/>
-            <a:ext cx="10515600" cy="1325700"/>
-          </a:xfrm>
-        </p:spPr>
-        <p:txBody>
-          <a:bodyPr xmlns:a="http://schemas.openxmlformats.org/drawingml/2006/main">
-            <a:normAutofit fontScale="100000"/>
-          </a:bodyPr>
-          <a:lstStyle xmlns:a="http://schemas.openxmlformats.org/drawingml/2006/main"/>
-          <a:p xmlns:a="http://schemas.openxmlformats.org/drawingml/2006/main">
-            <a:r>
-              <a:t>Maintainers can drill from portfolio to exact task contracts</a:t>
-            </a:r>
-          </a:p>
-        </p:txBody>
-      </p:sp>
-      <p:sp>
-        <p:nvSpPr>
-          <p:cNvPr id="7" name="TextBox 6">
-            <a:extLst xmlns:a="http://schemas.openxmlformats.org/drawingml/2006/main">
-              <a:ext uri="{FF2B5EF4-FFF2-40B4-BE49-F238E27FC236}">
-                <a16:creationId xmlns:a16="http://schemas.microsoft.com/office/drawing/2014/main" id="{E2E6F043-0F84-54F7-A567-6E5851801779}"/>
-              </a:ext>
-            </a:extLst>
-          </p:cNvPr>
-          <p:cNvSpPr>
-            <a:spLocks xmlns:a="http://schemas.openxmlformats.org/drawingml/2006/main" noGrp="1"/>
-          </p:cNvSpPr>
-          <p:nvPr/>
-        </p:nvSpPr>
-        <p:spPr>
-          <a:xfrm xmlns:a="http://schemas.openxmlformats.org/drawingml/2006/main">
-            <a:off x="696174" y="6338986"/>
-            <a:ext cx="284052" cy="307777"/>
-          </a:xfrm>
-          <a:prstGeom xmlns:a="http://schemas.openxmlformats.org/drawingml/2006/main" prst="rect">
-            <a:avLst/>
-          </a:prstGeom>
-          <a:noFill xmlns:a="http://schemas.openxmlformats.org/drawingml/2006/main"/>
-        </p:spPr>
-        <p:txBody>
-          <a:bodyPr xmlns:a="http://schemas.openxmlformats.org/drawingml/2006/main" wrap="none">
-            <a:spAutoFit/>
-          </a:bodyPr>
-          <a:lstStyle xmlns:a="http://schemas.openxmlformats.org/drawingml/2006/main"/>
-          <a:p xmlns:a="http://schemas.openxmlformats.org/drawingml/2006/main">
-            <a:r>
-              <a:t>7</a:t>
-            </a:r>
-          </a:p>
-        </p:txBody>
-      </p:sp>
-      <p:pic>
-        <p:nvPicPr>
           <p:cNvPr id="16" name=""/>
           <p:cNvPicPr>
             <a:picLocks xmlns:a="http://schemas.openxmlformats.org/drawingml/2006/main" noChangeAspect="1"/>
@@ -33780,7 +33175,7 @@
           <p:nvPr/>
         </p:nvPicPr>
         <p:blipFill>
-          <a:blip xmlns:r="http://schemas.openxmlformats.org/officeDocument/2006/relationships" xmlns:a="http://schemas.openxmlformats.org/drawingml/2006/main" r:embed="R36104cc265634f38"/>
+          <a:blip xmlns:r="http://schemas.openxmlformats.org/officeDocument/2006/relationships" xmlns:a="http://schemas.openxmlformats.org/drawingml/2006/main" r:embed="Re9971616fcb647c2"/>
           <a:stretch xmlns:a="http://schemas.openxmlformats.org/drawingml/2006/main"/>
         </p:blipFill>
         <p:spPr>
@@ -33802,7 +33197,7 @@
           <p:nvPr/>
         </p:nvPicPr>
         <p:blipFill>
-          <a:blip xmlns:r="http://schemas.openxmlformats.org/officeDocument/2006/relationships" xmlns:a="http://schemas.openxmlformats.org/drawingml/2006/main" r:embed="Rb73ee2a552ee4990"/>
+          <a:blip xmlns:r="http://schemas.openxmlformats.org/officeDocument/2006/relationships" xmlns:a="http://schemas.openxmlformats.org/drawingml/2006/main" r:embed="R1ee3559e1c064f44"/>
           <a:stretch xmlns:a="http://schemas.openxmlformats.org/drawingml/2006/main"/>
         </p:blipFill>
         <p:spPr>
@@ -33947,6 +33342,120 @@
 </p:sld>
 </file>
 
+<file path=ppt/slides/slide7.xml><?xml version="1.0" encoding="utf-8"?>
+<p:sld xmlns:p="http://schemas.openxmlformats.org/presentationml/2006/main">
+  <p:cSld>
+    <p:spTree>
+      <p:nvGrpSpPr>
+        <p:cNvPr id="1" name=""/>
+        <p:cNvGrpSpPr/>
+        <p:nvPr/>
+      </p:nvGrpSpPr>
+      <p:grpSpPr>
+        <a:xfrm xmlns:a="http://schemas.openxmlformats.org/drawingml/2006/main"/>
+      </p:grpSpPr>
+      <p:sp>
+        <p:nvSpPr>
+          <p:cNvPr id="2" name="Title 1">
+            <a:extLst xmlns:a="http://schemas.openxmlformats.org/drawingml/2006/main">
+              <a:ext uri="{FF2B5EF4-FFF2-40B4-BE49-F238E27FC236}">
+                <a16:creationId xmlns:a16="http://schemas.microsoft.com/office/drawing/2014/main" id="{F64C2A24-546D-C55C-2C52-97A4957F67E0}"/>
+              </a:ext>
+            </a:extLst>
+          </p:cNvPr>
+          <p:cNvSpPr>
+            <a:spLocks xmlns:a="http://schemas.openxmlformats.org/drawingml/2006/main" noGrp="1"/>
+          </p:cNvSpPr>
+          <p:nvPr>
+            <p:ph type="title" idx="0"/>
+          </p:nvPr>
+        </p:nvSpPr>
+        <p:spPr>
+          <a:xfrm xmlns:a="http://schemas.openxmlformats.org/drawingml/2006/main">
+            <a:off x="838200" y="365125"/>
+            <a:ext cx="10515600" cy="1325700"/>
+          </a:xfrm>
+        </p:spPr>
+        <p:txBody>
+          <a:bodyPr xmlns:a="http://schemas.openxmlformats.org/drawingml/2006/main">
+            <a:normAutofit fontScale="100000"/>
+          </a:bodyPr>
+          <a:lstStyle xmlns:a="http://schemas.openxmlformats.org/drawingml/2006/main"/>
+          <a:p xmlns:a="http://schemas.openxmlformats.org/drawingml/2006/main">
+            <a:r>
+              <a:t>The methodology is deliberately claim-resistant</a:t>
+            </a:r>
+          </a:p>
+        </p:txBody>
+      </p:sp>
+      <p:sp>
+        <p:nvSpPr>
+          <p:cNvPr id="7" name="TextBox 6">
+            <a:extLst xmlns:a="http://schemas.openxmlformats.org/drawingml/2006/main">
+              <a:ext uri="{FF2B5EF4-FFF2-40B4-BE49-F238E27FC236}">
+                <a16:creationId xmlns:a16="http://schemas.microsoft.com/office/drawing/2014/main" id="{E2E6F043-0F84-54F7-A567-6E5851801779}"/>
+              </a:ext>
+            </a:extLst>
+          </p:cNvPr>
+          <p:cNvSpPr>
+            <a:spLocks xmlns:a="http://schemas.openxmlformats.org/drawingml/2006/main" noGrp="1"/>
+          </p:cNvSpPr>
+          <p:nvPr/>
+        </p:nvSpPr>
+        <p:spPr>
+          <a:xfrm xmlns:a="http://schemas.openxmlformats.org/drawingml/2006/main">
+            <a:off x="696174" y="6338986"/>
+            <a:ext cx="284052" cy="307777"/>
+          </a:xfrm>
+          <a:prstGeom xmlns:a="http://schemas.openxmlformats.org/drawingml/2006/main" prst="rect">
+            <a:avLst/>
+          </a:prstGeom>
+          <a:noFill xmlns:a="http://schemas.openxmlformats.org/drawingml/2006/main"/>
+        </p:spPr>
+        <p:txBody>
+          <a:bodyPr xmlns:a="http://schemas.openxmlformats.org/drawingml/2006/main" wrap="none">
+            <a:spAutoFit/>
+          </a:bodyPr>
+          <a:lstStyle xmlns:a="http://schemas.openxmlformats.org/drawingml/2006/main"/>
+          <a:p xmlns:a="http://schemas.openxmlformats.org/drawingml/2006/main">
+            <a:r>
+              <a:t>7</a:t>
+            </a:r>
+          </a:p>
+        </p:txBody>
+      </p:sp>
+      <p:pic>
+        <p:nvPicPr>
+          <p:cNvPr id="11" name=""/>
+          <p:cNvPicPr>
+            <a:picLocks xmlns:a="http://schemas.openxmlformats.org/drawingml/2006/main" noChangeAspect="1"/>
+          </p:cNvPicPr>
+          <p:nvPr/>
+        </p:nvPicPr>
+        <p:blipFill>
+          <a:blip xmlns:r="http://schemas.openxmlformats.org/officeDocument/2006/relationships" xmlns:a="http://schemas.openxmlformats.org/drawingml/2006/main" r:embed="R5281d3996e034655"/>
+          <a:stretch xmlns:a="http://schemas.openxmlformats.org/drawingml/2006/main"/>
+        </p:blipFill>
+        <p:spPr>
+          <a:xfrm xmlns:a="http://schemas.openxmlformats.org/drawingml/2006/main" flipH="0" flipV="0">
+            <a:off x="2322187" y="1885950"/>
+            <a:ext cx="7547626" cy="4248150"/>
+          </a:xfrm>
+          <a:prstGeom xmlns:a="http://schemas.openxmlformats.org/drawingml/2006/main" prst="roundRect">
+            <a:avLst/>
+          </a:prstGeom>
+        </p:spPr>
+      </p:pic>
+    </p:spTree>
+    <p:extLst>
+      <p:ext uri="{BB962C8B-B14F-4D97-AF65-F5344CB8AC3E}">
+        <p14:creationId xmlns:p14="http://schemas.microsoft.com/office/powerpoint/2010/main" val="1742728663"/>
+      </p:ext>
+    </p:extLst>
+  </p:cSld>
+</p:sld>
+</file>
+
 <file path=ppt/slides/slide8.xml><?xml version="1.0" encoding="utf-8"?>
 <p:sld xmlns:p="http://schemas.openxmlformats.org/presentationml/2006/main">
   <p:cSld>
@@ -33988,7 +33497,7 @@
           <a:lstStyle xmlns:a="http://schemas.openxmlformats.org/drawingml/2006/main"/>
           <a:p xmlns:a="http://schemas.openxmlformats.org/drawingml/2006/main">
             <a:r>
-              <a:t>The methodology is deliberately claim-resistant</a:t>
+              <a:t>Every claim lives inside a matched evaluation cell</a:t>
             </a:r>
           </a:p>
         </p:txBody>
@@ -34025,120 +33534,6 @@
           <a:p xmlns:a="http://schemas.openxmlformats.org/drawingml/2006/main">
             <a:r>
               <a:t>8</a:t>
-            </a:r>
-          </a:p>
-        </p:txBody>
-      </p:sp>
-      <p:pic>
-        <p:nvPicPr>
-          <p:cNvPr id="11" name=""/>
-          <p:cNvPicPr>
-            <a:picLocks xmlns:a="http://schemas.openxmlformats.org/drawingml/2006/main" noChangeAspect="1"/>
-          </p:cNvPicPr>
-          <p:nvPr/>
-        </p:nvPicPr>
-        <p:blipFill>
-          <a:blip xmlns:r="http://schemas.openxmlformats.org/officeDocument/2006/relationships" xmlns:a="http://schemas.openxmlformats.org/drawingml/2006/main" r:embed="R60df57cf7cc444a8"/>
-          <a:stretch xmlns:a="http://schemas.openxmlformats.org/drawingml/2006/main"/>
-        </p:blipFill>
-        <p:spPr>
-          <a:xfrm xmlns:a="http://schemas.openxmlformats.org/drawingml/2006/main" flipH="0" flipV="0">
-            <a:off x="2322187" y="1885950"/>
-            <a:ext cx="7547626" cy="4248150"/>
-          </a:xfrm>
-          <a:prstGeom xmlns:a="http://schemas.openxmlformats.org/drawingml/2006/main" prst="roundRect">
-            <a:avLst/>
-          </a:prstGeom>
-        </p:spPr>
-      </p:pic>
-    </p:spTree>
-    <p:extLst>
-      <p:ext uri="{BB962C8B-B14F-4D97-AF65-F5344CB8AC3E}">
-        <p14:creationId xmlns:p14="http://schemas.microsoft.com/office/powerpoint/2010/main" val="1742728663"/>
-      </p:ext>
-    </p:extLst>
-  </p:cSld>
-</p:sld>
-</file>
-
-<file path=ppt/slides/slide9.xml><?xml version="1.0" encoding="utf-8"?>
-<p:sld xmlns:p="http://schemas.openxmlformats.org/presentationml/2006/main">
-  <p:cSld>
-    <p:spTree>
-      <p:nvGrpSpPr>
-        <p:cNvPr id="1" name=""/>
-        <p:cNvGrpSpPr/>
-        <p:nvPr/>
-      </p:nvGrpSpPr>
-      <p:grpSpPr>
-        <a:xfrm xmlns:a="http://schemas.openxmlformats.org/drawingml/2006/main"/>
-      </p:grpSpPr>
-      <p:sp>
-        <p:nvSpPr>
-          <p:cNvPr id="2" name="Title 1">
-            <a:extLst xmlns:a="http://schemas.openxmlformats.org/drawingml/2006/main">
-              <a:ext uri="{FF2B5EF4-FFF2-40B4-BE49-F238E27FC236}">
-                <a16:creationId xmlns:a16="http://schemas.microsoft.com/office/drawing/2014/main" id="{F64C2A24-546D-C55C-2C52-97A4957F67E0}"/>
-              </a:ext>
-            </a:extLst>
-          </p:cNvPr>
-          <p:cNvSpPr>
-            <a:spLocks xmlns:a="http://schemas.openxmlformats.org/drawingml/2006/main" noGrp="1"/>
-          </p:cNvSpPr>
-          <p:nvPr>
-            <p:ph type="title" idx="0"/>
-          </p:nvPr>
-        </p:nvSpPr>
-        <p:spPr>
-          <a:xfrm xmlns:a="http://schemas.openxmlformats.org/drawingml/2006/main">
-            <a:off x="838200" y="365125"/>
-            <a:ext cx="10515600" cy="1325700"/>
-          </a:xfrm>
-        </p:spPr>
-        <p:txBody>
-          <a:bodyPr xmlns:a="http://schemas.openxmlformats.org/drawingml/2006/main">
-            <a:normAutofit fontScale="100000"/>
-          </a:bodyPr>
-          <a:lstStyle xmlns:a="http://schemas.openxmlformats.org/drawingml/2006/main"/>
-          <a:p xmlns:a="http://schemas.openxmlformats.org/drawingml/2006/main">
-            <a:r>
-              <a:t>Every claim lives inside a matched evaluation cell</a:t>
-            </a:r>
-          </a:p>
-        </p:txBody>
-      </p:sp>
-      <p:sp>
-        <p:nvSpPr>
-          <p:cNvPr id="7" name="TextBox 6">
-            <a:extLst xmlns:a="http://schemas.openxmlformats.org/drawingml/2006/main">
-              <a:ext uri="{FF2B5EF4-FFF2-40B4-BE49-F238E27FC236}">
-                <a16:creationId xmlns:a16="http://schemas.microsoft.com/office/drawing/2014/main" id="{E2E6F043-0F84-54F7-A567-6E5851801779}"/>
-              </a:ext>
-            </a:extLst>
-          </p:cNvPr>
-          <p:cNvSpPr>
-            <a:spLocks xmlns:a="http://schemas.openxmlformats.org/drawingml/2006/main" noGrp="1"/>
-          </p:cNvSpPr>
-          <p:nvPr/>
-        </p:nvSpPr>
-        <p:spPr>
-          <a:xfrm xmlns:a="http://schemas.openxmlformats.org/drawingml/2006/main">
-            <a:off x="696174" y="6338986"/>
-            <a:ext cx="284052" cy="307777"/>
-          </a:xfrm>
-          <a:prstGeom xmlns:a="http://schemas.openxmlformats.org/drawingml/2006/main" prst="rect">
-            <a:avLst/>
-          </a:prstGeom>
-          <a:noFill xmlns:a="http://schemas.openxmlformats.org/drawingml/2006/main"/>
-        </p:spPr>
-        <p:txBody>
-          <a:bodyPr xmlns:a="http://schemas.openxmlformats.org/drawingml/2006/main" wrap="none">
-            <a:spAutoFit/>
-          </a:bodyPr>
-          <a:lstStyle xmlns:a="http://schemas.openxmlformats.org/drawingml/2006/main"/>
-          <a:p xmlns:a="http://schemas.openxmlformats.org/drawingml/2006/main">
-            <a:r>
-              <a:t>9</a:t>
             </a:r>
           </a:p>
         </p:txBody>
@@ -34796,6 +34191,253 @@
                 </a:solidFill>
               </a:rPr>
               <a:t>Repeat across representative cells; report differences. Never average incompatible contexts into a universal score.</a:t>
+            </a:r>
+          </a:p>
+        </p:txBody>
+      </p:sp>
+    </p:spTree>
+    <p:extLst>
+      <p:ext uri="{BB962C8B-B14F-4D97-AF65-F5344CB8AC3E}">
+        <p14:creationId xmlns:p14="http://schemas.microsoft.com/office/powerpoint/2010/main" val="1742728663"/>
+      </p:ext>
+    </p:extLst>
+  </p:cSld>
+</p:sld>
+</file>
+
+<file path=ppt/slides/slide9.xml><?xml version="1.0" encoding="utf-8"?>
+<p:sld xmlns:p="http://schemas.openxmlformats.org/presentationml/2006/main">
+  <p:cSld>
+    <p:spTree>
+      <p:nvGrpSpPr>
+        <p:cNvPr id="1" name=""/>
+        <p:cNvGrpSpPr/>
+        <p:nvPr/>
+      </p:nvGrpSpPr>
+      <p:grpSpPr>
+        <a:xfrm xmlns:a="http://schemas.openxmlformats.org/drawingml/2006/main"/>
+      </p:grpSpPr>
+      <p:sp>
+        <p:nvSpPr>
+          <p:cNvPr id="2" name="Title 1">
+            <a:extLst xmlns:a="http://schemas.openxmlformats.org/drawingml/2006/main">
+              <a:ext uri="{FF2B5EF4-FFF2-40B4-BE49-F238E27FC236}">
+                <a16:creationId xmlns:a16="http://schemas.microsoft.com/office/drawing/2014/main" id="{F64C2A24-546D-C55C-2C52-97A4957F67E0}"/>
+              </a:ext>
+            </a:extLst>
+          </p:cNvPr>
+          <p:cNvSpPr>
+            <a:spLocks xmlns:a="http://schemas.openxmlformats.org/drawingml/2006/main" noGrp="1"/>
+          </p:cNvSpPr>
+          <p:nvPr>
+            <p:ph type="title" idx="0"/>
+          </p:nvPr>
+        </p:nvSpPr>
+        <p:spPr>
+          <a:xfrm xmlns:a="http://schemas.openxmlformats.org/drawingml/2006/main">
+            <a:off x="838200" y="365125"/>
+            <a:ext cx="10515600" cy="1325700"/>
+          </a:xfrm>
+        </p:spPr>
+        <p:txBody>
+          <a:bodyPr xmlns:a="http://schemas.openxmlformats.org/drawingml/2006/main">
+            <a:normAutofit fontScale="100000"/>
+          </a:bodyPr>
+          <a:lstStyle xmlns:a="http://schemas.openxmlformats.org/drawingml/2006/main"/>
+          <a:p xmlns:a="http://schemas.openxmlformats.org/drawingml/2006/main">
+            <a:r>
+              <a:t>Maintainer pushback is expected — and the answer is scoped evidence</a:t>
+            </a:r>
+          </a:p>
+        </p:txBody>
+      </p:sp>
+      <p:sp>
+        <p:nvSpPr>
+          <p:cNvPr id="3" name="Content Placeholder 2">
+            <a:extLst xmlns:a="http://schemas.openxmlformats.org/drawingml/2006/main">
+              <a:ext uri="{FF2B5EF4-FFF2-40B4-BE49-F238E27FC236}">
+                <a16:creationId xmlns:a16="http://schemas.microsoft.com/office/drawing/2014/main" id="{ECF5C9F1-2691-0BC9-F1E1-01CECB857FE3}"/>
+              </a:ext>
+            </a:extLst>
+          </p:cNvPr>
+          <p:cNvSpPr>
+            <a:spLocks xmlns:a="http://schemas.openxmlformats.org/drawingml/2006/main" noGrp="1"/>
+          </p:cNvSpPr>
+          <p:nvPr>
+            <p:ph type="body" idx="1"/>
+          </p:nvPr>
+        </p:nvSpPr>
+        <p:spPr>
+          <a:xfrm xmlns:a="http://schemas.openxmlformats.org/drawingml/2006/main">
+            <a:off x="838200" y="1825625"/>
+            <a:ext cx="10515600" cy="4351200"/>
+          </a:xfrm>
+        </p:spPr>
+        <p:txBody>
+          <a:bodyPr xmlns:a="http://schemas.openxmlformats.org/drawingml/2006/main" wrap="square" anchor="t">
+            <a:normAutofit fontScale="100000"/>
+          </a:bodyPr>
+          <a:lstStyle xmlns:a="http://schemas.openxmlformats.org/drawingml/2006/main"/>
+          <a:p xmlns:a="http://schemas.openxmlformats.org/drawingml/2006/main">
+            <a:pPr marL="30" indent="-18">
+              <a:spcAft>
+                <a:spcPts val="10"/>
+              </a:spcAft>
+              <a:buChar char="•"/>
+              <a:defRPr sz="1913">
+                <a:solidFill>
+                  <a:srgbClr val="000000"/>
+                </a:solidFill>
+              </a:defRPr>
+            </a:pPr>
+            <a:r>
+              <a:rPr sz="1913" b="1">
+                <a:solidFill>
+                  <a:srgbClr val="000000"/>
+                </a:solidFill>
+              </a:rPr>
+              <a:t> Do you test every combination? — No. We publish representative, risk-based cells and the gaps.</a:t>
+            </a:r>
+          </a:p>
+          <a:p xmlns:a="http://schemas.openxmlformats.org/drawingml/2006/main">
+            <a:pPr marL="30" indent="-18">
+              <a:spcAft>
+                <a:spcPts val="10"/>
+              </a:spcAft>
+              <a:buChar char="•"/>
+              <a:defRPr sz="1913">
+                <a:solidFill>
+                  <a:srgbClr val="000000"/>
+                </a:solidFill>
+              </a:defRPr>
+            </a:pPr>
+            <a:r>
+              <a:rPr sz="1913" b="1">
+                <a:solidFill>
+                  <a:srgbClr val="000000"/>
+                </a:solidFill>
+              </a:rPr>
+              <a:t> What changes invalidate evidence? — Re-run affected cells; older results remain history, not current proof.</a:t>
+            </a:r>
+          </a:p>
+          <a:p xmlns:a="http://schemas.openxmlformats.org/drawingml/2006/main">
+            <a:pPr marL="30" indent="-18">
+              <a:spcAft>
+                <a:spcPts val="10"/>
+              </a:spcAft>
+              <a:buChar char="•"/>
+              <a:defRPr sz="1913">
+                <a:solidFill>
+                  <a:srgbClr val="000000"/>
+                </a:solidFill>
+              </a:defRPr>
+            </a:pPr>
+            <a:r>
+              <a:rPr sz="1913" b="1">
+                <a:solidFill>
+                  <a:srgbClr val="000000"/>
+                </a:solidFill>
+              </a:rPr>
+              <a:t> How do you limit overfitting? — Maintainer incidents, hidden checks, negative controls, multiple tasks, and trajectory review.</a:t>
+            </a:r>
+          </a:p>
+          <a:p xmlns:a="http://schemas.openxmlformats.org/drawingml/2006/main">
+            <a:pPr marL="30" indent="-18">
+              <a:spcAft>
+                <a:spcPts val="10"/>
+              </a:spcAft>
+              <a:buChar char="•"/>
+              <a:defRPr sz="1913">
+                <a:solidFill>
+                  <a:srgbClr val="000000"/>
+                </a:solidFill>
+              </a:defRPr>
+            </a:pPr>
+            <a:r>
+              <a:rPr sz="1913" b="1">
+                <a:solidFill>
+                  <a:srgbClr val="000000"/>
+                </a:solidFill>
+              </a:rPr>
+              <a:t> What if every arm passes? — Keep it as smoke coverage; claim no lift and seek a harder task.</a:t>
+            </a:r>
+          </a:p>
+          <a:p xmlns:a="http://schemas.openxmlformats.org/drawingml/2006/main">
+            <a:pPr marL="30" indent="-18">
+              <a:spcAft>
+                <a:spcPts val="10"/>
+              </a:spcAft>
+              <a:buChar char="•"/>
+              <a:defRPr sz="1913">
+                <a:solidFill>
+                  <a:srgbClr val="000000"/>
+                </a:solidFill>
+              </a:defRPr>
+            </a:pPr>
+            <a:r>
+              <a:rPr sz="1913" b="1">
+                <a:solidFill>
+                  <a:srgbClr val="000000"/>
+                </a:solidFill>
+              </a:rPr>
+              <a:t> Does hardware qualification prove skill value? — No. Qualification and matched skill trials are separate gates.</a:t>
+            </a:r>
+          </a:p>
+          <a:p xmlns:a="http://schemas.openxmlformats.org/drawingml/2006/main">
+            <a:pPr marL="30" indent="-18">
+              <a:spcAft>
+                <a:spcPts val="10"/>
+              </a:spcAft>
+              <a:buChar char="•"/>
+              <a:defRPr sz="1913">
+                <a:solidFill>
+                  <a:srgbClr val="000000"/>
+                </a:solidFill>
+              </a:defRPr>
+            </a:pPr>
+            <a:r>
+              <a:rPr sz="1913" b="1">
+                <a:solidFill>
+                  <a:srgbClr val="000000"/>
+                </a:solidFill>
+              </a:rPr>
+              <a:t> Can scores be pooled? — No universal score; report conclusions within each model, harness, software, and environment cell.</a:t>
+            </a:r>
+          </a:p>
+        </p:txBody>
+      </p:sp>
+      <p:sp>
+        <p:nvSpPr>
+          <p:cNvPr id="7" name="TextBox 6">
+            <a:extLst xmlns:a="http://schemas.openxmlformats.org/drawingml/2006/main">
+              <a:ext uri="{FF2B5EF4-FFF2-40B4-BE49-F238E27FC236}">
+                <a16:creationId xmlns:a16="http://schemas.microsoft.com/office/drawing/2014/main" id="{E2E6F043-0F84-54F7-A567-6E5851801779}"/>
+              </a:ext>
+            </a:extLst>
+          </p:cNvPr>
+          <p:cNvSpPr>
+            <a:spLocks xmlns:a="http://schemas.openxmlformats.org/drawingml/2006/main" noGrp="1"/>
+          </p:cNvSpPr>
+          <p:nvPr/>
+        </p:nvSpPr>
+        <p:spPr>
+          <a:xfrm xmlns:a="http://schemas.openxmlformats.org/drawingml/2006/main">
+            <a:off x="696174" y="6338986"/>
+            <a:ext cx="284052" cy="307777"/>
+          </a:xfrm>
+          <a:prstGeom xmlns:a="http://schemas.openxmlformats.org/drawingml/2006/main" prst="rect">
+            <a:avLst/>
+          </a:prstGeom>
+          <a:noFill xmlns:a="http://schemas.openxmlformats.org/drawingml/2006/main"/>
+        </p:spPr>
+        <p:txBody>
+          <a:bodyPr xmlns:a="http://schemas.openxmlformats.org/drawingml/2006/main" wrap="none">
+            <a:spAutoFit/>
+          </a:bodyPr>
+          <a:lstStyle xmlns:a="http://schemas.openxmlformats.org/drawingml/2006/main"/>
+          <a:p xmlns:a="http://schemas.openxmlformats.org/drawingml/2006/main">
+            <a:r>
+              <a:t>9</a:t>
             </a:r>
           </a:p>
         </p:txBody>

</xml_diff>

<commit_message>
Remove redundant overview value slide (#21)
</commit_message>
<xml_diff>
--- a/evaluation/dashboard/public/decks/uxl-skills-maintainer-overview.pptx
+++ b/evaluation/dashboard/public/decks/uxl-skills-maintainer-overview.pptx
@@ -2,27 +2,26 @@
 <file path=ppt/presentation.xml><?xml version="1.0" encoding="utf-8"?>
 <p:presentation xmlns:p="http://schemas.openxmlformats.org/presentationml/2006/main">
   <p:sldMasterIdLst>
-    <p:sldMasterId xmlns:r="http://schemas.openxmlformats.org/officeDocument/2006/relationships" id="2147483648" r:id="Rb04ab14f6340413d"/>
-    <p:sldMasterId xmlns:r="http://schemas.openxmlformats.org/officeDocument/2006/relationships" id="2147483665" r:id="R9ef28bf0220847af"/>
+    <p:sldMasterId xmlns:r="http://schemas.openxmlformats.org/officeDocument/2006/relationships" id="2147483648" r:id="Rb7987ec1b83443e2"/>
+    <p:sldMasterId xmlns:r="http://schemas.openxmlformats.org/officeDocument/2006/relationships" id="2147483665" r:id="R3f71cc09775c4d41"/>
   </p:sldMasterIdLst>
   <p:notesMasterIdLst>
-    <p:notesMasterId xmlns:r="http://schemas.openxmlformats.org/officeDocument/2006/relationships" r:id="R1045e4d21f9d45cb"/>
+    <p:notesMasterId xmlns:r="http://schemas.openxmlformats.org/officeDocument/2006/relationships" r:id="R006e1c0d7bfc41d0"/>
   </p:notesMasterIdLst>
   <p:sldIdLst>
-    <p:sldId xmlns:r="http://schemas.openxmlformats.org/officeDocument/2006/relationships" id="256" r:id="Rdbf65bf85e3e419a"/>
-    <p:sldId xmlns:r="http://schemas.openxmlformats.org/officeDocument/2006/relationships" id="257" r:id="Ra1cfdfc77c1a4a06"/>
-    <p:sldId xmlns:r="http://schemas.openxmlformats.org/officeDocument/2006/relationships" id="258" r:id="R7849342483df4203"/>
-    <p:sldId xmlns:r="http://schemas.openxmlformats.org/officeDocument/2006/relationships" id="259" r:id="R3ca2e63c9c72454d"/>
-    <p:sldId xmlns:r="http://schemas.openxmlformats.org/officeDocument/2006/relationships" id="260" r:id="R1604e088bc434c66"/>
-    <p:sldId xmlns:r="http://schemas.openxmlformats.org/officeDocument/2006/relationships" id="261" r:id="R808c294f49fc4c7e"/>
-    <p:sldId xmlns:r="http://schemas.openxmlformats.org/officeDocument/2006/relationships" id="262" r:id="R6bb97aaef4964d6b"/>
-    <p:sldId xmlns:r="http://schemas.openxmlformats.org/officeDocument/2006/relationships" id="263" r:id="R64e7ae382900412d"/>
-    <p:sldId xmlns:r="http://schemas.openxmlformats.org/officeDocument/2006/relationships" id="264" r:id="Rf5b8753be56147b2"/>
-    <p:sldId xmlns:r="http://schemas.openxmlformats.org/officeDocument/2006/relationships" id="265" r:id="R561d481371bc4bf5"/>
-    <p:sldId xmlns:r="http://schemas.openxmlformats.org/officeDocument/2006/relationships" id="266" r:id="R78ce0dfbc3dd4cc4"/>
-    <p:sldId xmlns:r="http://schemas.openxmlformats.org/officeDocument/2006/relationships" id="267" r:id="R7ccdf4035d594eb3"/>
-    <p:sldId xmlns:r="http://schemas.openxmlformats.org/officeDocument/2006/relationships" id="268" r:id="R0e6f8d53c52d46fa"/>
-    <p:sldId xmlns:r="http://schemas.openxmlformats.org/officeDocument/2006/relationships" id="269" r:id="R4d62926fd4eb4f05"/>
+    <p:sldId xmlns:r="http://schemas.openxmlformats.org/officeDocument/2006/relationships" id="256" r:id="Rd68fa7d113a44cb7"/>
+    <p:sldId xmlns:r="http://schemas.openxmlformats.org/officeDocument/2006/relationships" id="257" r:id="Rdf728d02f3b34286"/>
+    <p:sldId xmlns:r="http://schemas.openxmlformats.org/officeDocument/2006/relationships" id="258" r:id="R363bc56305524a17"/>
+    <p:sldId xmlns:r="http://schemas.openxmlformats.org/officeDocument/2006/relationships" id="259" r:id="R9e4eaeb703cd489b"/>
+    <p:sldId xmlns:r="http://schemas.openxmlformats.org/officeDocument/2006/relationships" id="260" r:id="R57934278e2154449"/>
+    <p:sldId xmlns:r="http://schemas.openxmlformats.org/officeDocument/2006/relationships" id="261" r:id="R0ae8eede21e3454a"/>
+    <p:sldId xmlns:r="http://schemas.openxmlformats.org/officeDocument/2006/relationships" id="262" r:id="R74045f904dbe4b5a"/>
+    <p:sldId xmlns:r="http://schemas.openxmlformats.org/officeDocument/2006/relationships" id="263" r:id="R713fef35e0af47e9"/>
+    <p:sldId xmlns:r="http://schemas.openxmlformats.org/officeDocument/2006/relationships" id="264" r:id="R318cc05d65ef47f9"/>
+    <p:sldId xmlns:r="http://schemas.openxmlformats.org/officeDocument/2006/relationships" id="265" r:id="R9d786669acaf49f3"/>
+    <p:sldId xmlns:r="http://schemas.openxmlformats.org/officeDocument/2006/relationships" id="266" r:id="Rb6ab8f3aab034b5b"/>
+    <p:sldId xmlns:r="http://schemas.openxmlformats.org/officeDocument/2006/relationships" id="267" r:id="R0838bc8c3d5b40d4"/>
+    <p:sldId xmlns:r="http://schemas.openxmlformats.org/officeDocument/2006/relationships" id="268" r:id="R67704bed905345a0"/>
   </p:sldIdLst>
   <p:sldSz cx="12192000" cy="6858000"/>
   <p:notesSz cx="6858000" cy="9144000"/>
@@ -656,7 +655,7 @@
           </a:p>
           <a:p xmlns:a="http://schemas.openxmlformats.org/drawingml/2006/main">
             <a:r>
-              <a:t>Speaker cue: Maintainer pushback is expected — and the answer is scoped evidence</a:t>
+              <a:t>Speaker cue: Hardware is a pluggable evidence lane — never the product</a:t>
             </a:r>
           </a:p>
         </p:txBody>
@@ -776,7 +775,7 @@
           </a:p>
           <a:p xmlns:a="http://schemas.openxmlformats.org/drawingml/2006/main">
             <a:r>
-              <a:t>Speaker cue: Hardware is a pluggable evidence lane — never the product</a:t>
+              <a:t>Speaker cue: The ongoing maintainer workflow fits normal GitHub practice</a:t>
             </a:r>
           </a:p>
         </p:txBody>
@@ -896,7 +895,7 @@
           </a:p>
           <a:p xmlns:a="http://schemas.openxmlformats.org/drawingml/2006/main">
             <a:r>
-              <a:t>Speaker cue: The ongoing maintainer workflow fits normal GitHub practice</a:t>
+              <a:t>Speaker cue: Ownership is intentionally split</a:t>
             </a:r>
           </a:p>
         </p:txBody>
@@ -1016,126 +1015,6 @@
           </a:p>
           <a:p xmlns:a="http://schemas.openxmlformats.org/drawingml/2006/main">
             <a:r>
-              <a:t>Speaker cue: Ownership is intentionally split</a:t>
-            </a:r>
-          </a:p>
-        </p:txBody>
-      </p:sp>
-      <p:sp>
-        <p:nvSpPr>
-          <p:cNvPr id="4" name="Slide Number Placeholder 3"/>
-          <p:cNvSpPr>
-            <a:spLocks xmlns:a="http://schemas.openxmlformats.org/drawingml/2006/main" noGrp="1"/>
-          </p:cNvSpPr>
-          <p:nvPr>
-            <p:ph type="sldNum" idx="5"/>
-          </p:nvPr>
-        </p:nvSpPr>
-        <p:spPr/>
-        <p:txBody>
-          <a:bodyPr xmlns:a="http://schemas.openxmlformats.org/drawingml/2006/main"/>
-          <a:lstStyle xmlns:a="http://schemas.openxmlformats.org/drawingml/2006/main"/>
-          <a:p xmlns:a="http://schemas.openxmlformats.org/drawingml/2006/main"/>
-        </p:txBody>
-      </p:sp>
-    </p:spTree>
-  </p:cSld>
-  <p:clrMapOvr>
-    <a:masterClrMapping xmlns:a="http://schemas.openxmlformats.org/drawingml/2006/main"/>
-  </p:clrMapOvr>
-</p:notes>
-</file>
-
-<file path=ppt/notesSlides/notesSlide14.xml><?xml version="1.0" encoding="utf-8"?>
-<p:notes xmlns:p="http://schemas.openxmlformats.org/presentationml/2006/main">
-  <p:cSld>
-    <p:spTree>
-      <p:nvGrpSpPr>
-        <p:cNvPr id="1" name=""/>
-        <p:cNvGrpSpPr/>
-        <p:nvPr/>
-      </p:nvGrpSpPr>
-      <p:grpSpPr>
-        <a:xfrm xmlns:a="http://schemas.openxmlformats.org/drawingml/2006/main"/>
-      </p:grpSpPr>
-      <p:sp>
-        <p:nvSpPr>
-          <p:cNvPr id="2" name="Slide Image Placeholder 1"/>
-          <p:cNvSpPr>
-            <a:spLocks xmlns:a="http://schemas.openxmlformats.org/drawingml/2006/main" noGrp="1"/>
-          </p:cNvSpPr>
-          <p:nvPr>
-            <p:ph type="sldImg" idx="0"/>
-          </p:nvPr>
-        </p:nvSpPr>
-        <p:spPr/>
-      </p:sp>
-      <p:sp>
-        <p:nvSpPr>
-          <p:cNvPr id="3" name="Notes Placeholder 2"/>
-          <p:cNvSpPr>
-            <a:spLocks xmlns:a="http://schemas.openxmlformats.org/drawingml/2006/main" noGrp="1"/>
-          </p:cNvSpPr>
-          <p:nvPr>
-            <p:ph type="body" idx="1"/>
-          </p:nvPr>
-        </p:nvSpPr>
-        <p:spPr/>
-        <p:txBody>
-          <a:bodyPr xmlns:a="http://schemas.openxmlformats.org/drawingml/2006/main"/>
-          <a:lstStyle xmlns:a="http://schemas.openxmlformats.org/drawingml/2006/main"/>
-          <a:p xmlns:a="http://schemas.openxmlformats.org/drawingml/2006/main">
-            <a:r>
-              <a:t>[Sources]</a:t>
-            </a:r>
-          </a:p>
-          <a:p xmlns:a="http://schemas.openxmlformats.org/drawingml/2006/main">
-            <a:r>
-              <a:t>- https://github.com/uxlfoundation/skills/blob/main/skills.yaml</a:t>
-            </a:r>
-          </a:p>
-          <a:p xmlns:a="http://schemas.openxmlformats.org/drawingml/2006/main">
-            <a:r>
-              <a:t>- https://github.com/uxlfoundation/skills/blob/main/evaluation/harbor/suites.json</a:t>
-            </a:r>
-          </a:p>
-          <a:p xmlns:a="http://schemas.openxmlformats.org/drawingml/2006/main">
-            <a:r>
-              <a:t>- https://github.com/uxlfoundation/skills/blob/main/evaluation/harbor/EVALUATOR_POLICY.md</a:t>
-            </a:r>
-          </a:p>
-          <a:p xmlns:a="http://schemas.openxmlformats.org/drawingml/2006/main">
-            <a:r>
-              <a:t>- https://uxlfoundation.github.io/skills/</a:t>
-            </a:r>
-          </a:p>
-          <a:p xmlns:a="http://schemas.openxmlformats.org/drawingml/2006/main">
-            <a:r>
-              <a:t>- https://github.com/uxlfoundation/skills/blob/main/docs/evaluator-operator-guide.md</a:t>
-            </a:r>
-          </a:p>
-          <a:p xmlns:a="http://schemas.openxmlformats.org/drawingml/2006/main">
-            <a:r>
-              <a:t>- https://github.com/uxlfoundation/skills/blob/main/docs/forward-testing.md</a:t>
-            </a:r>
-          </a:p>
-          <a:p xmlns:a="http://schemas.openxmlformats.org/drawingml/2006/main">
-            <a:r>
-              <a:t>- https://github.com/uxlfoundation/skills/blob/main/docs/release-and-promotion-policy.md</a:t>
-            </a:r>
-          </a:p>
-          <a:p xmlns:a="http://schemas.openxmlformats.org/drawingml/2006/main">
-            <a:r>
-              <a:t>[/Sources]</a:t>
-            </a:r>
-          </a:p>
-          <a:p xmlns:a="http://schemas.openxmlformats.org/drawingml/2006/main">
-            <a:r>
-              <a:t/>
-            </a:r>
-          </a:p>
-          <a:p xmlns:a="http://schemas.openxmlformats.org/drawingml/2006/main">
-            <a:r>
               <a:t>Speaker cue: The decision we need from each project</a:t>
             </a:r>
           </a:p>
@@ -1256,7 +1135,7 @@
           </a:p>
           <a:p xmlns:a="http://schemas.openxmlformats.org/drawingml/2006/main">
             <a:r>
-              <a:t>Speaker cue: Why project maintainers should care</a:t>
+              <a:t>Speaker cue: What exists today</a:t>
             </a:r>
           </a:p>
         </p:txBody>
@@ -1376,7 +1255,7 @@
           </a:p>
           <a:p xmlns:a="http://schemas.openxmlformats.org/drawingml/2006/main">
             <a:r>
-              <a:t>Speaker cue: What exists today</a:t>
+              <a:t>Speaker cue: The current skill catalog — at a glance</a:t>
             </a:r>
           </a:p>
         </p:txBody>
@@ -1496,7 +1375,7 @@
           </a:p>
           <a:p xmlns:a="http://schemas.openxmlformats.org/drawingml/2006/main">
             <a:r>
-              <a:t>Speaker cue: The current skill catalog — at a glance</a:t>
+              <a:t>Speaker cue: Architecture: project knowledge becomes measured evidence</a:t>
             </a:r>
           </a:p>
         </p:txBody>
@@ -1616,7 +1495,7 @@
           </a:p>
           <a:p xmlns:a="http://schemas.openxmlformats.org/drawingml/2006/main">
             <a:r>
-              <a:t>Speaker cue: Architecture: project knowledge becomes measured evidence</a:t>
+              <a:t>Speaker cue: The public control room answers: are the skills healthy?</a:t>
             </a:r>
           </a:p>
         </p:txBody>
@@ -1736,7 +1615,7 @@
           </a:p>
           <a:p xmlns:a="http://schemas.openxmlformats.org/drawingml/2006/main">
             <a:r>
-              <a:t>Speaker cue: The public control room answers: are the skills healthy?</a:t>
+              <a:t>Speaker cue: Maintainers can drill from portfolio to exact task contracts</a:t>
             </a:r>
           </a:p>
         </p:txBody>
@@ -1856,7 +1735,7 @@
           </a:p>
           <a:p xmlns:a="http://schemas.openxmlformats.org/drawingml/2006/main">
             <a:r>
-              <a:t>Speaker cue: Maintainers can drill from portfolio to exact task contracts</a:t>
+              <a:t>Speaker cue: The methodology is deliberately claim-resistant</a:t>
             </a:r>
           </a:p>
         </p:txBody>
@@ -1976,7 +1855,7 @@
           </a:p>
           <a:p xmlns:a="http://schemas.openxmlformats.org/drawingml/2006/main">
             <a:r>
-              <a:t>Speaker cue: The methodology is deliberately claim-resistant</a:t>
+              <a:t>Speaker cue: Every claim lives inside a matched evaluation cell</a:t>
             </a:r>
           </a:p>
         </p:txBody>
@@ -2096,7 +1975,7 @@
           </a:p>
           <a:p xmlns:a="http://schemas.openxmlformats.org/drawingml/2006/main">
             <a:r>
-              <a:t>Speaker cue: Every claim lives inside a matched evaluation cell</a:t>
+              <a:t>Speaker cue: Maintainer pushback is expected — and the answer is scoped evidence</a:t>
             </a:r>
           </a:p>
         </p:txBody>
@@ -2132,7 +2011,7 @@
     <p:bg>
       <p:bgPr>
         <a:blipFill xmlns:a="http://schemas.openxmlformats.org/drawingml/2006/main">
-          <a:blip xmlns:r="http://schemas.openxmlformats.org/officeDocument/2006/relationships" r:embed="Rcf79fd9e4db742d2">
+          <a:blip xmlns:r="http://schemas.openxmlformats.org/officeDocument/2006/relationships" r:embed="R8bef3cc9f43d4e4a">
             <a:alphaModFix/>
           </a:blip>
           <a:stretch>
@@ -2567,7 +2446,7 @@
           <p:nvPr/>
         </p:nvPicPr>
         <p:blipFill rotWithShape="1">
-          <a:blip xmlns:r="http://schemas.openxmlformats.org/officeDocument/2006/relationships" xmlns:a="http://schemas.openxmlformats.org/drawingml/2006/main" r:embed="R1dd5e10cbe6f411f">
+          <a:blip xmlns:r="http://schemas.openxmlformats.org/officeDocument/2006/relationships" xmlns:a="http://schemas.openxmlformats.org/drawingml/2006/main" r:embed="Rd30caa5cbe1f41de">
             <a:alphaModFix/>
           </a:blip>
           <a:srcRect xmlns:a="http://schemas.openxmlformats.org/drawingml/2006/main" l="0" t="0" r="0" b="0"/>
@@ -2597,7 +2476,7 @@
     <p:bg>
       <p:bgPr>
         <a:blipFill xmlns:a="http://schemas.openxmlformats.org/drawingml/2006/main">
-          <a:blip xmlns:r="http://schemas.openxmlformats.org/officeDocument/2006/relationships" r:embed="R05e5a47907594ebf">
+          <a:blip xmlns:r="http://schemas.openxmlformats.org/officeDocument/2006/relationships" r:embed="Rf4d09a2fc6594a24">
             <a:alphaModFix/>
           </a:blip>
           <a:stretch>
@@ -3631,7 +3510,7 @@
           <p:nvPr/>
         </p:nvPicPr>
         <p:blipFill rotWithShape="1">
-          <a:blip xmlns:r="http://schemas.openxmlformats.org/officeDocument/2006/relationships" xmlns:a="http://schemas.openxmlformats.org/drawingml/2006/main" r:embed="R4b61acefd88c40a8">
+          <a:blip xmlns:r="http://schemas.openxmlformats.org/officeDocument/2006/relationships" xmlns:a="http://schemas.openxmlformats.org/drawingml/2006/main" r:embed="R6ecd06b6a01b4aab">
             <a:alphaModFix/>
           </a:blip>
           <a:srcRect xmlns:a="http://schemas.openxmlformats.org/drawingml/2006/main" l="0" t="0" r="0" b="0"/>
@@ -4655,7 +4534,7 @@
           <p:nvPr/>
         </p:nvPicPr>
         <p:blipFill rotWithShape="1">
-          <a:blip xmlns:r="http://schemas.openxmlformats.org/officeDocument/2006/relationships" xmlns:a="http://schemas.openxmlformats.org/drawingml/2006/main" r:embed="R623a0f55902243c0">
+          <a:blip xmlns:r="http://schemas.openxmlformats.org/officeDocument/2006/relationships" xmlns:a="http://schemas.openxmlformats.org/drawingml/2006/main" r:embed="R74739ae64f814862">
             <a:alphaModFix/>
           </a:blip>
           <a:srcRect xmlns:a="http://schemas.openxmlformats.org/drawingml/2006/main" l="0" t="0" r="0" b="0"/>
@@ -4685,7 +4564,7 @@
     <p:bg>
       <p:bgPr>
         <a:blipFill xmlns:a="http://schemas.openxmlformats.org/drawingml/2006/main">
-          <a:blip xmlns:r="http://schemas.openxmlformats.org/officeDocument/2006/relationships" r:embed="Rf810028b821c4a25">
+          <a:blip xmlns:r="http://schemas.openxmlformats.org/officeDocument/2006/relationships" r:embed="Rcb5d5643b1814a6b">
             <a:alphaModFix/>
           </a:blip>
           <a:stretch>
@@ -5959,7 +5838,7 @@
           <p:nvPr/>
         </p:nvPicPr>
         <p:blipFill rotWithShape="1">
-          <a:blip xmlns:r="http://schemas.openxmlformats.org/officeDocument/2006/relationships" xmlns:a="http://schemas.openxmlformats.org/drawingml/2006/main" r:embed="R277bf6f8d1d64781">
+          <a:blip xmlns:r="http://schemas.openxmlformats.org/officeDocument/2006/relationships" xmlns:a="http://schemas.openxmlformats.org/drawingml/2006/main" r:embed="R52b558c63907415a">
             <a:alphaModFix/>
           </a:blip>
           <a:srcRect xmlns:a="http://schemas.openxmlformats.org/drawingml/2006/main" l="0" t="0" r="0" b="0"/>
@@ -9203,7 +9082,7 @@
           <p:nvPr/>
         </p:nvPicPr>
         <p:blipFill rotWithShape="1">
-          <a:blip xmlns:r="http://schemas.openxmlformats.org/officeDocument/2006/relationships" xmlns:a="http://schemas.openxmlformats.org/drawingml/2006/main" r:embed="R497cff937ccb4401">
+          <a:blip xmlns:r="http://schemas.openxmlformats.org/officeDocument/2006/relationships" xmlns:a="http://schemas.openxmlformats.org/drawingml/2006/main" r:embed="R04de7e73c9fc4767">
             <a:alphaModFix/>
           </a:blip>
           <a:srcRect xmlns:a="http://schemas.openxmlformats.org/drawingml/2006/main" l="0" t="0" r="0" b="0"/>
@@ -10941,7 +10820,7 @@
           <p:nvPr/>
         </p:nvPicPr>
         <p:blipFill rotWithShape="1">
-          <a:blip xmlns:r="http://schemas.openxmlformats.org/officeDocument/2006/relationships" xmlns:a="http://schemas.openxmlformats.org/drawingml/2006/main" r:embed="R5fba98e0394c41e5">
+          <a:blip xmlns:r="http://schemas.openxmlformats.org/officeDocument/2006/relationships" xmlns:a="http://schemas.openxmlformats.org/drawingml/2006/main" r:embed="Rf9640843d37a4ad4">
             <a:alphaModFix/>
           </a:blip>
           <a:srcRect xmlns:a="http://schemas.openxmlformats.org/drawingml/2006/main" l="0" t="0" r="0" b="0"/>
@@ -17770,7 +17649,7 @@
     <p:bg>
       <p:bgPr>
         <a:blipFill xmlns:a="http://schemas.openxmlformats.org/drawingml/2006/main">
-          <a:blip xmlns:r="http://schemas.openxmlformats.org/officeDocument/2006/relationships" r:embed="R959a0c993c664cad">
+          <a:blip xmlns:r="http://schemas.openxmlformats.org/officeDocument/2006/relationships" r:embed="R60a11436b932488b">
             <a:alphaModFix/>
           </a:blip>
           <a:stretch>
@@ -18205,7 +18084,7 @@
           <p:nvPr/>
         </p:nvPicPr>
         <p:blipFill rotWithShape="1">
-          <a:blip xmlns:r="http://schemas.openxmlformats.org/officeDocument/2006/relationships" xmlns:a="http://schemas.openxmlformats.org/drawingml/2006/main" r:embed="R3c9bb615d3e34314">
+          <a:blip xmlns:r="http://schemas.openxmlformats.org/officeDocument/2006/relationships" xmlns:a="http://schemas.openxmlformats.org/drawingml/2006/main" r:embed="R9ac842dc5c25409e">
             <a:alphaModFix/>
           </a:blip>
           <a:srcRect xmlns:a="http://schemas.openxmlformats.org/drawingml/2006/main" l="0" t="0" r="0" b="0"/>
@@ -18235,7 +18114,7 @@
     <p:bg>
       <p:bgPr>
         <a:blipFill xmlns:a="http://schemas.openxmlformats.org/drawingml/2006/main">
-          <a:blip xmlns:r="http://schemas.openxmlformats.org/officeDocument/2006/relationships" r:embed="Rd80936d218db466c">
+          <a:blip xmlns:r="http://schemas.openxmlformats.org/officeDocument/2006/relationships" r:embed="R6a9952010a4d41c9">
             <a:alphaModFix/>
           </a:blip>
           <a:stretch>
@@ -18868,7 +18747,7 @@
           <p:nvPr/>
         </p:nvPicPr>
         <p:blipFill rotWithShape="1">
-          <a:blip xmlns:r="http://schemas.openxmlformats.org/officeDocument/2006/relationships" xmlns:a="http://schemas.openxmlformats.org/drawingml/2006/main" r:embed="R48c9612991b64bc6">
+          <a:blip xmlns:r="http://schemas.openxmlformats.org/officeDocument/2006/relationships" xmlns:a="http://schemas.openxmlformats.org/drawingml/2006/main" r:embed="Rf9e87fbfa6b44e0d">
             <a:alphaModFix/>
           </a:blip>
           <a:srcRect xmlns:a="http://schemas.openxmlformats.org/drawingml/2006/main" l="0" t="0" r="0" b="0"/>
@@ -19328,7 +19207,7 @@
     <p:bg>
       <p:bgPr>
         <a:blipFill xmlns:a="http://schemas.openxmlformats.org/drawingml/2006/main">
-          <a:blip xmlns:r="http://schemas.openxmlformats.org/officeDocument/2006/relationships" r:embed="Rf7db73ce73b149d1">
+          <a:blip xmlns:r="http://schemas.openxmlformats.org/officeDocument/2006/relationships" r:embed="Rdbeffd5e5bb3403d">
             <a:alphaModFix/>
           </a:blip>
           <a:stretch>
@@ -19961,7 +19840,7 @@
           <p:nvPr/>
         </p:nvPicPr>
         <p:blipFill rotWithShape="1">
-          <a:blip xmlns:r="http://schemas.openxmlformats.org/officeDocument/2006/relationships" xmlns:a="http://schemas.openxmlformats.org/drawingml/2006/main" r:embed="Rdb264494cc7e4866">
+          <a:blip xmlns:r="http://schemas.openxmlformats.org/officeDocument/2006/relationships" xmlns:a="http://schemas.openxmlformats.org/drawingml/2006/main" r:embed="Re370fd911c514430">
             <a:alphaModFix/>
           </a:blip>
           <a:srcRect xmlns:a="http://schemas.openxmlformats.org/drawingml/2006/main" l="0" t="0" r="0" b="0"/>
@@ -22617,7 +22496,7 @@
           <p:nvPr/>
         </p:nvPicPr>
         <p:blipFill rotWithShape="1">
-          <a:blip xmlns:r="http://schemas.openxmlformats.org/officeDocument/2006/relationships" xmlns:a="http://schemas.openxmlformats.org/drawingml/2006/main" r:embed="R5b7857b9d0994777">
+          <a:blip xmlns:r="http://schemas.openxmlformats.org/officeDocument/2006/relationships" xmlns:a="http://schemas.openxmlformats.org/drawingml/2006/main" r:embed="R6509b6dc05384064">
             <a:alphaModFix/>
           </a:blip>
           <a:srcRect xmlns:a="http://schemas.openxmlformats.org/drawingml/2006/main" l="0" t="0" r="0" b="0"/>
@@ -22647,7 +22526,7 @@
     <p:bg>
       <p:bgPr>
         <a:blipFill xmlns:a="http://schemas.openxmlformats.org/drawingml/2006/main">
-          <a:blip xmlns:r="http://schemas.openxmlformats.org/officeDocument/2006/relationships" r:embed="Ra03973a3871f4efe">
+          <a:blip xmlns:r="http://schemas.openxmlformats.org/officeDocument/2006/relationships" r:embed="R4d844c342640436e">
             <a:alphaModFix/>
           </a:blip>
           <a:stretch>
@@ -23491,7 +23370,7 @@
           <p:nvPr/>
         </p:nvPicPr>
         <p:blipFill rotWithShape="1">
-          <a:blip xmlns:r="http://schemas.openxmlformats.org/officeDocument/2006/relationships" xmlns:a="http://schemas.openxmlformats.org/drawingml/2006/main" r:embed="R9ec34d5114c64141">
+          <a:blip xmlns:r="http://schemas.openxmlformats.org/officeDocument/2006/relationships" xmlns:a="http://schemas.openxmlformats.org/drawingml/2006/main" r:embed="Raf0d449b0506427b">
             <a:alphaModFix/>
           </a:blip>
           <a:srcRect xmlns:a="http://schemas.openxmlformats.org/drawingml/2006/main" l="0" t="0" r="0" b="0"/>
@@ -23521,7 +23400,7 @@
     <p:bg>
       <p:bgPr>
         <a:blipFill xmlns:a="http://schemas.openxmlformats.org/drawingml/2006/main">
-          <a:blip xmlns:r="http://schemas.openxmlformats.org/officeDocument/2006/relationships" r:embed="R972e9f9cda83435f">
+          <a:blip xmlns:r="http://schemas.openxmlformats.org/officeDocument/2006/relationships" r:embed="Ref1159f7ed594710">
             <a:alphaModFix/>
           </a:blip>
           <a:stretch>
@@ -24469,7 +24348,7 @@
           <p:nvPr/>
         </p:nvPicPr>
         <p:blipFill rotWithShape="1">
-          <a:blip xmlns:r="http://schemas.openxmlformats.org/officeDocument/2006/relationships" xmlns:a="http://schemas.openxmlformats.org/drawingml/2006/main" r:embed="R5c369f93c0f74682">
+          <a:blip xmlns:r="http://schemas.openxmlformats.org/officeDocument/2006/relationships" xmlns:a="http://schemas.openxmlformats.org/drawingml/2006/main" r:embed="R09dda9d4d282470e">
             <a:alphaModFix/>
           </a:blip>
           <a:srcRect xmlns:a="http://schemas.openxmlformats.org/drawingml/2006/main" l="0" t="0" r="0" b="0"/>
@@ -24499,7 +24378,7 @@
     <p:bg>
       <p:bgPr>
         <a:blipFill xmlns:a="http://schemas.openxmlformats.org/drawingml/2006/main">
-          <a:blip xmlns:r="http://schemas.openxmlformats.org/officeDocument/2006/relationships" r:embed="R150d6ec0c8f94c10">
+          <a:blip xmlns:r="http://schemas.openxmlformats.org/officeDocument/2006/relationships" r:embed="R646c25ca04454f95">
             <a:alphaModFix/>
           </a:blip>
           <a:stretch>
@@ -24960,7 +24839,7 @@
           <p:nvPr/>
         </p:nvPicPr>
         <p:blipFill rotWithShape="1">
-          <a:blip xmlns:r="http://schemas.openxmlformats.org/officeDocument/2006/relationships" xmlns:a="http://schemas.openxmlformats.org/drawingml/2006/main" r:embed="R159d6906d17d46f9">
+          <a:blip xmlns:r="http://schemas.openxmlformats.org/officeDocument/2006/relationships" xmlns:a="http://schemas.openxmlformats.org/drawingml/2006/main" r:embed="Rc4b4c52372eb4949">
             <a:alphaModFix/>
           </a:blip>
           <a:srcRect xmlns:a="http://schemas.openxmlformats.org/drawingml/2006/main" l="0" t="0" r="0" b="0"/>
@@ -26672,22 +26551,22 @@
   </p:cSld>
   <p:clrMap bg1="lt1" tx1="dk1" bg2="dk2" tx2="lt2" accent1="accent1" accent2="accent2" accent3="accent3" accent4="accent4" accent5="accent5" accent6="accent6" hlink="hlink" folHlink="folHlink"/>
   <p:sldLayoutIdLst>
-    <p:sldLayoutId xmlns:r="http://schemas.openxmlformats.org/officeDocument/2006/relationships" id="2147483649" r:id="Rb88271aa9f4f4c9c"/>
-    <p:sldLayoutId xmlns:r="http://schemas.openxmlformats.org/officeDocument/2006/relationships" id="2147483650" r:id="R845e83d2ab634436"/>
-    <p:sldLayoutId xmlns:r="http://schemas.openxmlformats.org/officeDocument/2006/relationships" id="2147483651" r:id="Rb9e3dccd60a844c3"/>
-    <p:sldLayoutId xmlns:r="http://schemas.openxmlformats.org/officeDocument/2006/relationships" id="2147483652" r:id="Rc97b515778304562"/>
-    <p:sldLayoutId xmlns:r="http://schemas.openxmlformats.org/officeDocument/2006/relationships" id="2147483653" r:id="R9f9af9905375485b"/>
-    <p:sldLayoutId xmlns:r="http://schemas.openxmlformats.org/officeDocument/2006/relationships" id="2147483654" r:id="Red75149bb2994be7"/>
-    <p:sldLayoutId xmlns:r="http://schemas.openxmlformats.org/officeDocument/2006/relationships" id="2147483655" r:id="Rf0a57444b2f341da"/>
-    <p:sldLayoutId xmlns:r="http://schemas.openxmlformats.org/officeDocument/2006/relationships" id="2147483656" r:id="R63bfc9cc2da14add"/>
-    <p:sldLayoutId xmlns:r="http://schemas.openxmlformats.org/officeDocument/2006/relationships" id="2147483657" r:id="R3a50f2280ed44648"/>
-    <p:sldLayoutId xmlns:r="http://schemas.openxmlformats.org/officeDocument/2006/relationships" id="2147483658" r:id="Ra7ba8037ee974ac7"/>
-    <p:sldLayoutId xmlns:r="http://schemas.openxmlformats.org/officeDocument/2006/relationships" id="2147483659" r:id="R7d13db4d3ef14c8f"/>
-    <p:sldLayoutId xmlns:r="http://schemas.openxmlformats.org/officeDocument/2006/relationships" id="2147483660" r:id="R0d9a9a622fc441c9"/>
-    <p:sldLayoutId xmlns:r="http://schemas.openxmlformats.org/officeDocument/2006/relationships" id="2147483661" r:id="R47f4f16f6994417c"/>
-    <p:sldLayoutId xmlns:r="http://schemas.openxmlformats.org/officeDocument/2006/relationships" id="2147483662" r:id="R1643da8145db4223"/>
-    <p:sldLayoutId xmlns:r="http://schemas.openxmlformats.org/officeDocument/2006/relationships" id="2147483663" r:id="R6d1aecf51e15483b"/>
-    <p:sldLayoutId xmlns:r="http://schemas.openxmlformats.org/officeDocument/2006/relationships" id="2147483664" r:id="Rbd32074d12924725"/>
+    <p:sldLayoutId xmlns:r="http://schemas.openxmlformats.org/officeDocument/2006/relationships" id="2147483649" r:id="Rd10ee9849fc4479e"/>
+    <p:sldLayoutId xmlns:r="http://schemas.openxmlformats.org/officeDocument/2006/relationships" id="2147483650" r:id="R77a6cf2775034798"/>
+    <p:sldLayoutId xmlns:r="http://schemas.openxmlformats.org/officeDocument/2006/relationships" id="2147483651" r:id="R096a7d67ee5c498b"/>
+    <p:sldLayoutId xmlns:r="http://schemas.openxmlformats.org/officeDocument/2006/relationships" id="2147483652" r:id="R98fda9fa94314b8a"/>
+    <p:sldLayoutId xmlns:r="http://schemas.openxmlformats.org/officeDocument/2006/relationships" id="2147483653" r:id="R688580b968774fe2"/>
+    <p:sldLayoutId xmlns:r="http://schemas.openxmlformats.org/officeDocument/2006/relationships" id="2147483654" r:id="R01cf9527fe8942af"/>
+    <p:sldLayoutId xmlns:r="http://schemas.openxmlformats.org/officeDocument/2006/relationships" id="2147483655" r:id="R988ce7b473714c83"/>
+    <p:sldLayoutId xmlns:r="http://schemas.openxmlformats.org/officeDocument/2006/relationships" id="2147483656" r:id="R7cac4b40260048c5"/>
+    <p:sldLayoutId xmlns:r="http://schemas.openxmlformats.org/officeDocument/2006/relationships" id="2147483657" r:id="Rf7828bdeb95f4df2"/>
+    <p:sldLayoutId xmlns:r="http://schemas.openxmlformats.org/officeDocument/2006/relationships" id="2147483658" r:id="R62ea9e08b5c945d2"/>
+    <p:sldLayoutId xmlns:r="http://schemas.openxmlformats.org/officeDocument/2006/relationships" id="2147483659" r:id="R144ca351b1c44527"/>
+    <p:sldLayoutId xmlns:r="http://schemas.openxmlformats.org/officeDocument/2006/relationships" id="2147483660" r:id="R0bc091b5287b4d88"/>
+    <p:sldLayoutId xmlns:r="http://schemas.openxmlformats.org/officeDocument/2006/relationships" id="2147483661" r:id="Rbc85b45604c74c6f"/>
+    <p:sldLayoutId xmlns:r="http://schemas.openxmlformats.org/officeDocument/2006/relationships" id="2147483662" r:id="R3ec658b12db44af9"/>
+    <p:sldLayoutId xmlns:r="http://schemas.openxmlformats.org/officeDocument/2006/relationships" id="2147483663" r:id="R335978e3ebda45dc"/>
+    <p:sldLayoutId xmlns:r="http://schemas.openxmlformats.org/officeDocument/2006/relationships" id="2147483664" r:id="Rfb2fb120c99a407b"/>
   </p:sldLayoutIdLst>
   <p:hf hdr="0" ftr="0" dt="0"/>
   <p:txStyles>
@@ -28880,7 +28759,7 @@
           <p:nvPr/>
         </p:nvPicPr>
         <p:blipFill rotWithShape="1">
-          <a:blip xmlns:r="http://schemas.openxmlformats.org/officeDocument/2006/relationships" xmlns:a="http://schemas.openxmlformats.org/drawingml/2006/main" r:embed="R009350a7a68345e8">
+          <a:blip xmlns:r="http://schemas.openxmlformats.org/officeDocument/2006/relationships" xmlns:a="http://schemas.openxmlformats.org/drawingml/2006/main" r:embed="R4df3fe1a35414db2">
             <a:alphaModFix/>
           </a:blip>
           <a:srcRect xmlns:a="http://schemas.openxmlformats.org/drawingml/2006/main" l="0" t="0" r="0" b="0"/>
@@ -28903,19 +28782,19 @@
   </p:cSld>
   <p:clrMap bg1="lt1" tx1="dk1" bg2="dk2" tx2="lt2" accent1="accent1" accent2="accent2" accent3="accent3" accent4="accent4" accent5="accent5" accent6="accent6" hlink="hlink" folHlink="folHlink"/>
   <p:sldLayoutIdLst>
-    <p:sldLayoutId xmlns:r="http://schemas.openxmlformats.org/officeDocument/2006/relationships" id="2147483666" r:id="R0619b8e8abb24748"/>
-    <p:sldLayoutId xmlns:r="http://schemas.openxmlformats.org/officeDocument/2006/relationships" id="2147483667" r:id="Rc1c3ab942d0f459e"/>
-    <p:sldLayoutId xmlns:r="http://schemas.openxmlformats.org/officeDocument/2006/relationships" id="2147483668" r:id="R5981fc41c43848d3"/>
-    <p:sldLayoutId xmlns:r="http://schemas.openxmlformats.org/officeDocument/2006/relationships" id="2147483669" r:id="R5497369958b948f8"/>
-    <p:sldLayoutId xmlns:r="http://schemas.openxmlformats.org/officeDocument/2006/relationships" id="2147483670" r:id="R49170ba884194d71"/>
-    <p:sldLayoutId xmlns:r="http://schemas.openxmlformats.org/officeDocument/2006/relationships" id="2147483671" r:id="Rd8068c3f56834c09"/>
-    <p:sldLayoutId xmlns:r="http://schemas.openxmlformats.org/officeDocument/2006/relationships" id="2147483672" r:id="Rd73115af9edb4ff0"/>
-    <p:sldLayoutId xmlns:r="http://schemas.openxmlformats.org/officeDocument/2006/relationships" id="2147483673" r:id="Ra02902615bf74bf1"/>
-    <p:sldLayoutId xmlns:r="http://schemas.openxmlformats.org/officeDocument/2006/relationships" id="2147483674" r:id="R85132b11f4ed4519"/>
-    <p:sldLayoutId xmlns:r="http://schemas.openxmlformats.org/officeDocument/2006/relationships" id="2147483675" r:id="R1b944c385a2a459e"/>
-    <p:sldLayoutId xmlns:r="http://schemas.openxmlformats.org/officeDocument/2006/relationships" id="2147483676" r:id="R3ec5fd01f9d94a86"/>
-    <p:sldLayoutId xmlns:r="http://schemas.openxmlformats.org/officeDocument/2006/relationships" id="2147483677" r:id="R503d16cdbd564746"/>
-    <p:sldLayoutId xmlns:r="http://schemas.openxmlformats.org/officeDocument/2006/relationships" id="2147483678" r:id="Rd2a884f542424fde"/>
+    <p:sldLayoutId xmlns:r="http://schemas.openxmlformats.org/officeDocument/2006/relationships" id="2147483666" r:id="R9b1eee25ff6d434a"/>
+    <p:sldLayoutId xmlns:r="http://schemas.openxmlformats.org/officeDocument/2006/relationships" id="2147483667" r:id="R46d9f1971a064380"/>
+    <p:sldLayoutId xmlns:r="http://schemas.openxmlformats.org/officeDocument/2006/relationships" id="2147483668" r:id="Re2992fc45e5344e2"/>
+    <p:sldLayoutId xmlns:r="http://schemas.openxmlformats.org/officeDocument/2006/relationships" id="2147483669" r:id="Rcf1b9ee0c9dc4478"/>
+    <p:sldLayoutId xmlns:r="http://schemas.openxmlformats.org/officeDocument/2006/relationships" id="2147483670" r:id="R93708b4e417b48fc"/>
+    <p:sldLayoutId xmlns:r="http://schemas.openxmlformats.org/officeDocument/2006/relationships" id="2147483671" r:id="Rc1e4906cc01549c5"/>
+    <p:sldLayoutId xmlns:r="http://schemas.openxmlformats.org/officeDocument/2006/relationships" id="2147483672" r:id="Rc541e9182b7c45d5"/>
+    <p:sldLayoutId xmlns:r="http://schemas.openxmlformats.org/officeDocument/2006/relationships" id="2147483673" r:id="R636e123a16a743a3"/>
+    <p:sldLayoutId xmlns:r="http://schemas.openxmlformats.org/officeDocument/2006/relationships" id="2147483674" r:id="R567002c9e0414aba"/>
+    <p:sldLayoutId xmlns:r="http://schemas.openxmlformats.org/officeDocument/2006/relationships" id="2147483675" r:id="R0f0e2c730a694fd9"/>
+    <p:sldLayoutId xmlns:r="http://schemas.openxmlformats.org/officeDocument/2006/relationships" id="2147483676" r:id="Ra130e52dc9c94b8a"/>
+    <p:sldLayoutId xmlns:r="http://schemas.openxmlformats.org/officeDocument/2006/relationships" id="2147483677" r:id="R540e9428dfd8491d"/>
+    <p:sldLayoutId xmlns:r="http://schemas.openxmlformats.org/officeDocument/2006/relationships" id="2147483678" r:id="Raec0c8e0a6d74ebc"/>
   </p:sldLayoutIdLst>
   <p:hf hdr="0" ftr="0" dt="0"/>
   <p:txStyles>
@@ -30312,162 +30191,7 @@
           <a:lstStyle xmlns:a="http://schemas.openxmlformats.org/drawingml/2006/main"/>
           <a:p xmlns:a="http://schemas.openxmlformats.org/drawingml/2006/main">
             <a:r>
-              <a:t>Maintainer pushback is expected — and the answer is scoped evidence</a:t>
-            </a:r>
-          </a:p>
-        </p:txBody>
-      </p:sp>
-      <p:sp>
-        <p:nvSpPr>
-          <p:cNvPr id="3" name="Content Placeholder 2">
-            <a:extLst xmlns:a="http://schemas.openxmlformats.org/drawingml/2006/main">
-              <a:ext uri="{FF2B5EF4-FFF2-40B4-BE49-F238E27FC236}">
-                <a16:creationId xmlns:a16="http://schemas.microsoft.com/office/drawing/2014/main" id="{ECF5C9F1-2691-0BC9-F1E1-01CECB857FE3}"/>
-              </a:ext>
-            </a:extLst>
-          </p:cNvPr>
-          <p:cNvSpPr>
-            <a:spLocks xmlns:a="http://schemas.openxmlformats.org/drawingml/2006/main" noGrp="1"/>
-          </p:cNvSpPr>
-          <p:nvPr>
-            <p:ph type="body" idx="1"/>
-          </p:nvPr>
-        </p:nvSpPr>
-        <p:spPr>
-          <a:xfrm xmlns:a="http://schemas.openxmlformats.org/drawingml/2006/main">
-            <a:off x="838200" y="1825625"/>
-            <a:ext cx="10515600" cy="4351200"/>
-          </a:xfrm>
-        </p:spPr>
-        <p:txBody>
-          <a:bodyPr xmlns:a="http://schemas.openxmlformats.org/drawingml/2006/main" wrap="square" anchor="t">
-            <a:normAutofit fontScale="100000"/>
-          </a:bodyPr>
-          <a:lstStyle xmlns:a="http://schemas.openxmlformats.org/drawingml/2006/main"/>
-          <a:p xmlns:a="http://schemas.openxmlformats.org/drawingml/2006/main">
-            <a:pPr marL="30" indent="-18">
-              <a:spcAft>
-                <a:spcPts val="10"/>
-              </a:spcAft>
-              <a:buChar char="•"/>
-              <a:defRPr sz="1913">
-                <a:solidFill>
-                  <a:srgbClr val="000000"/>
-                </a:solidFill>
-              </a:defRPr>
-            </a:pPr>
-            <a:r>
-              <a:rPr sz="1913" b="1">
-                <a:solidFill>
-                  <a:srgbClr val="000000"/>
-                </a:solidFill>
-              </a:rPr>
-              <a:t> Do you test every combination? — No. We publish representative, risk-based cells and the gaps.</a:t>
-            </a:r>
-          </a:p>
-          <a:p xmlns:a="http://schemas.openxmlformats.org/drawingml/2006/main">
-            <a:pPr marL="30" indent="-18">
-              <a:spcAft>
-                <a:spcPts val="10"/>
-              </a:spcAft>
-              <a:buChar char="•"/>
-              <a:defRPr sz="1913">
-                <a:solidFill>
-                  <a:srgbClr val="000000"/>
-                </a:solidFill>
-              </a:defRPr>
-            </a:pPr>
-            <a:r>
-              <a:rPr sz="1913" b="1">
-                <a:solidFill>
-                  <a:srgbClr val="000000"/>
-                </a:solidFill>
-              </a:rPr>
-              <a:t> What changes invalidate evidence? — Re-run affected cells; older results remain history, not current proof.</a:t>
-            </a:r>
-          </a:p>
-          <a:p xmlns:a="http://schemas.openxmlformats.org/drawingml/2006/main">
-            <a:pPr marL="30" indent="-18">
-              <a:spcAft>
-                <a:spcPts val="10"/>
-              </a:spcAft>
-              <a:buChar char="•"/>
-              <a:defRPr sz="1913">
-                <a:solidFill>
-                  <a:srgbClr val="000000"/>
-                </a:solidFill>
-              </a:defRPr>
-            </a:pPr>
-            <a:r>
-              <a:rPr sz="1913" b="1">
-                <a:solidFill>
-                  <a:srgbClr val="000000"/>
-                </a:solidFill>
-              </a:rPr>
-              <a:t> How do you limit overfitting? — Maintainer incidents, hidden checks, negative controls, multiple tasks, and trajectory review.</a:t>
-            </a:r>
-          </a:p>
-          <a:p xmlns:a="http://schemas.openxmlformats.org/drawingml/2006/main">
-            <a:pPr marL="30" indent="-18">
-              <a:spcAft>
-                <a:spcPts val="10"/>
-              </a:spcAft>
-              <a:buChar char="•"/>
-              <a:defRPr sz="1913">
-                <a:solidFill>
-                  <a:srgbClr val="000000"/>
-                </a:solidFill>
-              </a:defRPr>
-            </a:pPr>
-            <a:r>
-              <a:rPr sz="1913" b="1">
-                <a:solidFill>
-                  <a:srgbClr val="000000"/>
-                </a:solidFill>
-              </a:rPr>
-              <a:t> What if every arm passes? — Keep it as smoke coverage; claim no lift and seek a harder task.</a:t>
-            </a:r>
-          </a:p>
-          <a:p xmlns:a="http://schemas.openxmlformats.org/drawingml/2006/main">
-            <a:pPr marL="30" indent="-18">
-              <a:spcAft>
-                <a:spcPts val="10"/>
-              </a:spcAft>
-              <a:buChar char="•"/>
-              <a:defRPr sz="1913">
-                <a:solidFill>
-                  <a:srgbClr val="000000"/>
-                </a:solidFill>
-              </a:defRPr>
-            </a:pPr>
-            <a:r>
-              <a:rPr sz="1913" b="1">
-                <a:solidFill>
-                  <a:srgbClr val="000000"/>
-                </a:solidFill>
-              </a:rPr>
-              <a:t> Does hardware qualification prove skill value? — No. Qualification and matched skill trials are separate gates.</a:t>
-            </a:r>
-          </a:p>
-          <a:p xmlns:a="http://schemas.openxmlformats.org/drawingml/2006/main">
-            <a:pPr marL="30" indent="-18">
-              <a:spcAft>
-                <a:spcPts val="10"/>
-              </a:spcAft>
-              <a:buChar char="•"/>
-              <a:defRPr sz="1913">
-                <a:solidFill>
-                  <a:srgbClr val="000000"/>
-                </a:solidFill>
-              </a:defRPr>
-            </a:pPr>
-            <a:r>
-              <a:rPr sz="1913" b="1">
-                <a:solidFill>
-                  <a:srgbClr val="000000"/>
-                </a:solidFill>
-              </a:rPr>
-              <a:t> Can scores be pooled? — No universal score; report conclusions within each model, harness, software, and environment cell.</a:t>
+              <a:t>Hardware is a pluggable evidence lane — never the product</a:t>
             </a:r>
           </a:p>
         </p:txBody>
@@ -30508,6 +30232,28 @@
           </a:p>
         </p:txBody>
       </p:sp>
+      <p:pic>
+        <p:nvPicPr>
+          <p:cNvPr id="11" name=""/>
+          <p:cNvPicPr>
+            <a:picLocks xmlns:a="http://schemas.openxmlformats.org/drawingml/2006/main" noChangeAspect="1"/>
+          </p:cNvPicPr>
+          <p:nvPr/>
+        </p:nvPicPr>
+        <p:blipFill>
+          <a:blip xmlns:r="http://schemas.openxmlformats.org/officeDocument/2006/relationships" xmlns:a="http://schemas.openxmlformats.org/drawingml/2006/main" r:embed="R72c8fc6b2bff4551"/>
+          <a:stretch xmlns:a="http://schemas.openxmlformats.org/drawingml/2006/main"/>
+        </p:blipFill>
+        <p:spPr>
+          <a:xfrm xmlns:a="http://schemas.openxmlformats.org/drawingml/2006/main" flipH="0" flipV="0">
+            <a:off x="2322187" y="1885950"/>
+            <a:ext cx="7547626" cy="4248150"/>
+          </a:xfrm>
+          <a:prstGeom xmlns:a="http://schemas.openxmlformats.org/drawingml/2006/main" prst="roundRect">
+            <a:avLst/>
+          </a:prstGeom>
+        </p:spPr>
+      </p:pic>
     </p:spTree>
     <p:extLst>
       <p:ext uri="{BB962C8B-B14F-4D97-AF65-F5344CB8AC3E}">
@@ -30559,7 +30305,7 @@
           <a:lstStyle xmlns:a="http://schemas.openxmlformats.org/drawingml/2006/main"/>
           <a:p xmlns:a="http://schemas.openxmlformats.org/drawingml/2006/main">
             <a:r>
-              <a:t>Hardware is a pluggable evidence lane — never the product</a:t>
+              <a:t>The ongoing maintainer workflow fits normal GitHub practice</a:t>
             </a:r>
           </a:p>
         </p:txBody>
@@ -30596,120 +30342,6 @@
           <a:p xmlns:a="http://schemas.openxmlformats.org/drawingml/2006/main">
             <a:r>
               <a:t>11</a:t>
-            </a:r>
-          </a:p>
-        </p:txBody>
-      </p:sp>
-      <p:pic>
-        <p:nvPicPr>
-          <p:cNvPr id="11" name=""/>
-          <p:cNvPicPr>
-            <a:picLocks xmlns:a="http://schemas.openxmlformats.org/drawingml/2006/main" noChangeAspect="1"/>
-          </p:cNvPicPr>
-          <p:nvPr/>
-        </p:nvPicPr>
-        <p:blipFill>
-          <a:blip xmlns:r="http://schemas.openxmlformats.org/officeDocument/2006/relationships" xmlns:a="http://schemas.openxmlformats.org/drawingml/2006/main" r:embed="R32090135bb3b4594"/>
-          <a:stretch xmlns:a="http://schemas.openxmlformats.org/drawingml/2006/main"/>
-        </p:blipFill>
-        <p:spPr>
-          <a:xfrm xmlns:a="http://schemas.openxmlformats.org/drawingml/2006/main" flipH="0" flipV="0">
-            <a:off x="2322187" y="1885950"/>
-            <a:ext cx="7547626" cy="4248150"/>
-          </a:xfrm>
-          <a:prstGeom xmlns:a="http://schemas.openxmlformats.org/drawingml/2006/main" prst="roundRect">
-            <a:avLst/>
-          </a:prstGeom>
-        </p:spPr>
-      </p:pic>
-    </p:spTree>
-    <p:extLst>
-      <p:ext uri="{BB962C8B-B14F-4D97-AF65-F5344CB8AC3E}">
-        <p14:creationId xmlns:p14="http://schemas.microsoft.com/office/powerpoint/2010/main" val="1742728663"/>
-      </p:ext>
-    </p:extLst>
-  </p:cSld>
-</p:sld>
-</file>
-
-<file path=ppt/slides/slide12.xml><?xml version="1.0" encoding="utf-8"?>
-<p:sld xmlns:p="http://schemas.openxmlformats.org/presentationml/2006/main">
-  <p:cSld>
-    <p:spTree>
-      <p:nvGrpSpPr>
-        <p:cNvPr id="1" name=""/>
-        <p:cNvGrpSpPr/>
-        <p:nvPr/>
-      </p:nvGrpSpPr>
-      <p:grpSpPr>
-        <a:xfrm xmlns:a="http://schemas.openxmlformats.org/drawingml/2006/main"/>
-      </p:grpSpPr>
-      <p:sp>
-        <p:nvSpPr>
-          <p:cNvPr id="2" name="Title 1">
-            <a:extLst xmlns:a="http://schemas.openxmlformats.org/drawingml/2006/main">
-              <a:ext uri="{FF2B5EF4-FFF2-40B4-BE49-F238E27FC236}">
-                <a16:creationId xmlns:a16="http://schemas.microsoft.com/office/drawing/2014/main" id="{F64C2A24-546D-C55C-2C52-97A4957F67E0}"/>
-              </a:ext>
-            </a:extLst>
-          </p:cNvPr>
-          <p:cNvSpPr>
-            <a:spLocks xmlns:a="http://schemas.openxmlformats.org/drawingml/2006/main" noGrp="1"/>
-          </p:cNvSpPr>
-          <p:nvPr>
-            <p:ph type="title" idx="0"/>
-          </p:nvPr>
-        </p:nvSpPr>
-        <p:spPr>
-          <a:xfrm xmlns:a="http://schemas.openxmlformats.org/drawingml/2006/main">
-            <a:off x="838200" y="365125"/>
-            <a:ext cx="10515600" cy="1325700"/>
-          </a:xfrm>
-        </p:spPr>
-        <p:txBody>
-          <a:bodyPr xmlns:a="http://schemas.openxmlformats.org/drawingml/2006/main">
-            <a:normAutofit fontScale="100000"/>
-          </a:bodyPr>
-          <a:lstStyle xmlns:a="http://schemas.openxmlformats.org/drawingml/2006/main"/>
-          <a:p xmlns:a="http://schemas.openxmlformats.org/drawingml/2006/main">
-            <a:r>
-              <a:t>The ongoing maintainer workflow fits normal GitHub practice</a:t>
-            </a:r>
-          </a:p>
-        </p:txBody>
-      </p:sp>
-      <p:sp>
-        <p:nvSpPr>
-          <p:cNvPr id="7" name="TextBox 6">
-            <a:extLst xmlns:a="http://schemas.openxmlformats.org/drawingml/2006/main">
-              <a:ext uri="{FF2B5EF4-FFF2-40B4-BE49-F238E27FC236}">
-                <a16:creationId xmlns:a16="http://schemas.microsoft.com/office/drawing/2014/main" id="{E2E6F043-0F84-54F7-A567-6E5851801779}"/>
-              </a:ext>
-            </a:extLst>
-          </p:cNvPr>
-          <p:cNvSpPr>
-            <a:spLocks xmlns:a="http://schemas.openxmlformats.org/drawingml/2006/main" noGrp="1"/>
-          </p:cNvSpPr>
-          <p:nvPr/>
-        </p:nvSpPr>
-        <p:spPr>
-          <a:xfrm xmlns:a="http://schemas.openxmlformats.org/drawingml/2006/main">
-            <a:off x="696174" y="6338986"/>
-            <a:ext cx="284052" cy="307777"/>
-          </a:xfrm>
-          <a:prstGeom xmlns:a="http://schemas.openxmlformats.org/drawingml/2006/main" prst="rect">
-            <a:avLst/>
-          </a:prstGeom>
-          <a:noFill xmlns:a="http://schemas.openxmlformats.org/drawingml/2006/main"/>
-        </p:spPr>
-        <p:txBody>
-          <a:bodyPr xmlns:a="http://schemas.openxmlformats.org/drawingml/2006/main" wrap="none">
-            <a:spAutoFit/>
-          </a:bodyPr>
-          <a:lstStyle xmlns:a="http://schemas.openxmlformats.org/drawingml/2006/main"/>
-          <a:p xmlns:a="http://schemas.openxmlformats.org/drawingml/2006/main">
-            <a:r>
-              <a:t>12</a:t>
             </a:r>
           </a:p>
         </p:txBody>
@@ -31453,6 +31085,243 @@
 </p:sld>
 </file>
 
+<file path=ppt/slides/slide12.xml><?xml version="1.0" encoding="utf-8"?>
+<p:sld xmlns:p="http://schemas.openxmlformats.org/presentationml/2006/main">
+  <p:cSld>
+    <p:spTree>
+      <p:nvGrpSpPr>
+        <p:cNvPr id="1" name=""/>
+        <p:cNvGrpSpPr/>
+        <p:nvPr/>
+      </p:nvGrpSpPr>
+      <p:grpSpPr>
+        <a:xfrm xmlns:a="http://schemas.openxmlformats.org/drawingml/2006/main"/>
+      </p:grpSpPr>
+      <p:sp>
+        <p:nvSpPr>
+          <p:cNvPr id="2" name="Title 1">
+            <a:extLst xmlns:a="http://schemas.openxmlformats.org/drawingml/2006/main">
+              <a:ext uri="{FF2B5EF4-FFF2-40B4-BE49-F238E27FC236}">
+                <a16:creationId xmlns:a16="http://schemas.microsoft.com/office/drawing/2014/main" id="{F64C2A24-546D-C55C-2C52-97A4957F67E0}"/>
+              </a:ext>
+            </a:extLst>
+          </p:cNvPr>
+          <p:cNvSpPr>
+            <a:spLocks xmlns:a="http://schemas.openxmlformats.org/drawingml/2006/main" noGrp="1"/>
+          </p:cNvSpPr>
+          <p:nvPr>
+            <p:ph type="title" idx="0"/>
+          </p:nvPr>
+        </p:nvSpPr>
+        <p:spPr>
+          <a:xfrm xmlns:a="http://schemas.openxmlformats.org/drawingml/2006/main">
+            <a:off x="838200" y="365125"/>
+            <a:ext cx="10515600" cy="1325700"/>
+          </a:xfrm>
+        </p:spPr>
+        <p:txBody>
+          <a:bodyPr xmlns:a="http://schemas.openxmlformats.org/drawingml/2006/main">
+            <a:normAutofit fontScale="100000"/>
+          </a:bodyPr>
+          <a:lstStyle xmlns:a="http://schemas.openxmlformats.org/drawingml/2006/main"/>
+          <a:p xmlns:a="http://schemas.openxmlformats.org/drawingml/2006/main">
+            <a:r>
+              <a:t>Ownership is intentionally split</a:t>
+            </a:r>
+          </a:p>
+        </p:txBody>
+      </p:sp>
+      <p:sp>
+        <p:nvSpPr>
+          <p:cNvPr id="3" name="Content Placeholder 2">
+            <a:extLst xmlns:a="http://schemas.openxmlformats.org/drawingml/2006/main">
+              <a:ext uri="{FF2B5EF4-FFF2-40B4-BE49-F238E27FC236}">
+                <a16:creationId xmlns:a16="http://schemas.microsoft.com/office/drawing/2014/main" id="{ECF5C9F1-2691-0BC9-F1E1-01CECB857FE3}"/>
+              </a:ext>
+            </a:extLst>
+          </p:cNvPr>
+          <p:cNvSpPr>
+            <a:spLocks xmlns:a="http://schemas.openxmlformats.org/drawingml/2006/main" noGrp="1"/>
+          </p:cNvSpPr>
+          <p:nvPr>
+            <p:ph type="body" idx="1"/>
+          </p:nvPr>
+        </p:nvSpPr>
+        <p:spPr>
+          <a:xfrm xmlns:a="http://schemas.openxmlformats.org/drawingml/2006/main">
+            <a:off x="838200" y="1825625"/>
+            <a:ext cx="10515600" cy="4351200"/>
+          </a:xfrm>
+        </p:spPr>
+        <p:txBody>
+          <a:bodyPr xmlns:a="http://schemas.openxmlformats.org/drawingml/2006/main" wrap="square" anchor="t">
+            <a:normAutofit fontScale="100000"/>
+          </a:bodyPr>
+          <a:lstStyle xmlns:a="http://schemas.openxmlformats.org/drawingml/2006/main"/>
+          <a:p xmlns:a="http://schemas.openxmlformats.org/drawingml/2006/main">
+            <a:pPr marL="30" indent="-18">
+              <a:spcAft>
+                <a:spcPts val="10"/>
+              </a:spcAft>
+              <a:buChar char="•"/>
+              <a:defRPr sz="1913">
+                <a:solidFill>
+                  <a:srgbClr val="000000"/>
+                </a:solidFill>
+              </a:defRPr>
+            </a:pPr>
+            <a:r>
+              <a:rPr sz="1913" b="1">
+                <a:solidFill>
+                  <a:srgbClr val="000000"/>
+                </a:solidFill>
+              </a:rPr>
+              <a:t> Project maintainers own</a:t>
+            </a:r>
+            <a:r>
+              <a:rPr sz="1913">
+                <a:solidFill>
+                  <a:srgbClr val="000000"/>
+                </a:solidFill>
+              </a:rPr>
+              <a:t> — Triggers, technical guidance, official sources, limitations, and whether task scenarios are authentic.</a:t>
+            </a:r>
+          </a:p>
+          <a:p xmlns:a="http://schemas.openxmlformats.org/drawingml/2006/main">
+            <a:pPr marL="30" indent="-18">
+              <a:spcAft>
+                <a:spcPts val="10"/>
+              </a:spcAft>
+              <a:buChar char="•"/>
+              <a:defRPr sz="1913">
+                <a:solidFill>
+                  <a:srgbClr val="000000"/>
+                </a:solidFill>
+              </a:defRPr>
+            </a:pPr>
+            <a:r>
+              <a:rPr sz="1913" b="1">
+                <a:solidFill>
+                  <a:srgbClr val="000000"/>
+                </a:solidFill>
+              </a:rPr>
+              <a:t> UXL shared infrastructure owns</a:t>
+            </a:r>
+            <a:r>
+              <a:rPr sz="1913">
+                <a:solidFill>
+                  <a:srgbClr val="000000"/>
+                </a:solidFill>
+              </a:rPr>
+              <a:t> — Catalog validation, Harbor harnesses, comparison policy, dashboards, hosted CI, and runner contracts.</a:t>
+            </a:r>
+          </a:p>
+          <a:p xmlns:a="http://schemas.openxmlformats.org/drawingml/2006/main">
+            <a:pPr marL="30" indent="-18">
+              <a:spcAft>
+                <a:spcPts val="10"/>
+              </a:spcAft>
+              <a:buChar char="•"/>
+              <a:defRPr sz="1913">
+                <a:solidFill>
+                  <a:srgbClr val="000000"/>
+                </a:solidFill>
+              </a:defRPr>
+            </a:pPr>
+            <a:r>
+              <a:rPr sz="1913" b="1">
+                <a:solidFill>
+                  <a:srgbClr val="000000"/>
+                </a:solidFill>
+              </a:rPr>
+              <a:t> Hardware owners opt in</a:t>
+            </a:r>
+            <a:r>
+              <a:rPr sz="1913">
+                <a:solidFill>
+                  <a:srgbClr val="000000"/>
+                </a:solidFill>
+              </a:rPr>
+              <a:t> — They qualify a declared environment, run only reviewed immutable evaluator revisions, and return evidence artifacts.</a:t>
+            </a:r>
+          </a:p>
+          <a:p xmlns:a="http://schemas.openxmlformats.org/drawingml/2006/main">
+            <a:pPr marL="30" indent="-18">
+              <a:spcAft>
+                <a:spcPts val="10"/>
+              </a:spcAft>
+              <a:buChar char="•"/>
+              <a:defRPr sz="1913">
+                <a:solidFill>
+                  <a:srgbClr val="000000"/>
+                </a:solidFill>
+              </a:defRPr>
+            </a:pPr>
+            <a:r>
+              <a:rPr sz="1913" b="1">
+                <a:solidFill>
+                  <a:srgbClr val="000000"/>
+                </a:solidFill>
+              </a:rPr>
+              <a:t> No silent promotion</a:t>
+            </a:r>
+            <a:r>
+              <a:rPr sz="1913">
+                <a:solidFill>
+                  <a:srgbClr val="000000"/>
+                </a:solidFill>
+              </a:rPr>
+              <a:t> — Project approval, source verification, realistic eval prompts, matched trials when feasible, and explicit limitations remain gates.</a:t>
+            </a:r>
+          </a:p>
+        </p:txBody>
+      </p:sp>
+      <p:sp>
+        <p:nvSpPr>
+          <p:cNvPr id="7" name="TextBox 6">
+            <a:extLst xmlns:a="http://schemas.openxmlformats.org/drawingml/2006/main">
+              <a:ext uri="{FF2B5EF4-FFF2-40B4-BE49-F238E27FC236}">
+                <a16:creationId xmlns:a16="http://schemas.microsoft.com/office/drawing/2014/main" id="{E2E6F043-0F84-54F7-A567-6E5851801779}"/>
+              </a:ext>
+            </a:extLst>
+          </p:cNvPr>
+          <p:cNvSpPr>
+            <a:spLocks xmlns:a="http://schemas.openxmlformats.org/drawingml/2006/main" noGrp="1"/>
+          </p:cNvSpPr>
+          <p:nvPr/>
+        </p:nvSpPr>
+        <p:spPr>
+          <a:xfrm xmlns:a="http://schemas.openxmlformats.org/drawingml/2006/main">
+            <a:off x="696174" y="6338986"/>
+            <a:ext cx="284052" cy="307777"/>
+          </a:xfrm>
+          <a:prstGeom xmlns:a="http://schemas.openxmlformats.org/drawingml/2006/main" prst="rect">
+            <a:avLst/>
+          </a:prstGeom>
+          <a:noFill xmlns:a="http://schemas.openxmlformats.org/drawingml/2006/main"/>
+        </p:spPr>
+        <p:txBody>
+          <a:bodyPr xmlns:a="http://schemas.openxmlformats.org/drawingml/2006/main" wrap="none">
+            <a:spAutoFit/>
+          </a:bodyPr>
+          <a:lstStyle xmlns:a="http://schemas.openxmlformats.org/drawingml/2006/main"/>
+          <a:p xmlns:a="http://schemas.openxmlformats.org/drawingml/2006/main">
+            <a:r>
+              <a:t>12</a:t>
+            </a:r>
+          </a:p>
+        </p:txBody>
+      </p:sp>
+    </p:spTree>
+    <p:extLst>
+      <p:ext uri="{BB962C8B-B14F-4D97-AF65-F5344CB8AC3E}">
+        <p14:creationId xmlns:p14="http://schemas.microsoft.com/office/powerpoint/2010/main" val="1742728663"/>
+      </p:ext>
+    </p:extLst>
+  </p:cSld>
+</p:sld>
+</file>
+
 <file path=ppt/slides/slide13.xml><?xml version="1.0" encoding="utf-8"?>
 <p:sld xmlns:p="http://schemas.openxmlformats.org/presentationml/2006/main">
   <p:cSld>
@@ -31494,7 +31363,7 @@
           <a:lstStyle xmlns:a="http://schemas.openxmlformats.org/drawingml/2006/main"/>
           <a:p xmlns:a="http://schemas.openxmlformats.org/drawingml/2006/main">
             <a:r>
-              <a:t>Ownership is intentionally split</a:t>
+              <a:t>The decision we need from each project</a:t>
             </a:r>
           </a:p>
         </p:txBody>
@@ -31544,7 +31413,7 @@
                   <a:srgbClr val="000000"/>
                 </a:solidFill>
               </a:rPr>
-              <a:t> Project maintainers own</a:t>
+              <a:t> Name one owner</a:t>
             </a:r>
             <a:r>
               <a:rPr sz="1913">
@@ -31552,7 +31421,7 @@
                   <a:srgbClr val="000000"/>
                 </a:solidFill>
               </a:rPr>
-              <a:t> — Triggers, technical guidance, official sources, limitations, and whether task scenarios are authentic.</a:t>
+              <a:t> — A maintainer or small reviewer group for scope and source freshness.</a:t>
             </a:r>
           </a:p>
           <a:p xmlns:a="http://schemas.openxmlformats.org/drawingml/2006/main">
@@ -31573,7 +31442,7 @@
                   <a:srgbClr val="000000"/>
                 </a:solidFill>
               </a:rPr>
-              <a:t> UXL shared infrastructure owns</a:t>
+              <a:t> Approve or correct the first-pass guidance</a:t>
             </a:r>
             <a:r>
               <a:rPr sz="1913">
@@ -31581,7 +31450,7 @@
                   <a:srgbClr val="000000"/>
                 </a:solidFill>
               </a:rPr>
-              <a:t> — Catalog validation, Harbor harnesses, comparison policy, dashboards, hosted CI, and runner contracts.</a:t>
+              <a:t> — Especially triggers, gotchas, unsupported paths, and terminology.</a:t>
             </a:r>
           </a:p>
           <a:p xmlns:a="http://schemas.openxmlformats.org/drawingml/2006/main">
@@ -31602,7 +31471,7 @@
                   <a:srgbClr val="000000"/>
                 </a:solidFill>
               </a:rPr>
-              <a:t> Hardware owners opt in</a:t>
+              <a:t> Validate the task inventory</a:t>
             </a:r>
             <a:r>
               <a:rPr sz="1913">
@@ -31610,7 +31479,7 @@
                   <a:srgbClr val="000000"/>
                 </a:solidFill>
               </a:rPr>
-              <a:t> — They qualify a declared environment, run only reviewed immutable evaluator revisions, and return evidence artifacts.</a:t>
+              <a:t> — Keep, rewrite, or delete scenarios; nominate one real support issue or regression.</a:t>
             </a:r>
           </a:p>
           <a:p xmlns:a="http://schemas.openxmlformats.org/drawingml/2006/main">
@@ -31631,7 +31500,7 @@
                   <a:srgbClr val="000000"/>
                 </a:solidFill>
               </a:rPr>
-              <a:t> No silent promotion</a:t>
+              <a:t> Adopt a light cadence</a:t>
             </a:r>
             <a:r>
               <a:rPr sz="1913">
@@ -31639,7 +31508,36 @@
                   <a:srgbClr val="000000"/>
                 </a:solidFill>
               </a:rPr>
-              <a:t> — Project approval, source verification, realistic eval prompts, matched trials when feasible, and explicit limitations remain gates.</a:t>
+              <a:t> — Review skill-affecting PRs and recheck sources at releases or quarterly.</a:t>
+            </a:r>
+          </a:p>
+          <a:p xmlns:a="http://schemas.openxmlformats.org/drawingml/2006/main">
+            <a:pPr marL="30" indent="-18">
+              <a:spcAft>
+                <a:spcPts val="10"/>
+              </a:spcAft>
+              <a:buChar char="•"/>
+              <a:defRPr sz="1913">
+                <a:solidFill>
+                  <a:srgbClr val="000000"/>
+                </a:solidFill>
+              </a:defRPr>
+            </a:pPr>
+            <a:r>
+              <a:rPr sz="1913" b="1">
+                <a:solidFill>
+                  <a:srgbClr val="000000"/>
+                </a:solidFill>
+              </a:rPr>
+              <a:t> Start small</a:t>
+            </a:r>
+            <a:r>
+              <a:rPr sz="1913">
+                <a:solidFill>
+                  <a:srgbClr val="000000"/>
+                </a:solidFill>
+              </a:rPr>
+              <a:t> — A 30-minute review is enough to turn this from UXL-authored draft into project-backed guidance.</a:t>
             </a:r>
           </a:p>
         </p:txBody>
@@ -31676,272 +31574,6 @@
           <a:p xmlns:a="http://schemas.openxmlformats.org/drawingml/2006/main">
             <a:r>
               <a:t>13</a:t>
-            </a:r>
-          </a:p>
-        </p:txBody>
-      </p:sp>
-    </p:spTree>
-    <p:extLst>
-      <p:ext uri="{BB962C8B-B14F-4D97-AF65-F5344CB8AC3E}">
-        <p14:creationId xmlns:p14="http://schemas.microsoft.com/office/powerpoint/2010/main" val="1742728663"/>
-      </p:ext>
-    </p:extLst>
-  </p:cSld>
-</p:sld>
-</file>
-
-<file path=ppt/slides/slide14.xml><?xml version="1.0" encoding="utf-8"?>
-<p:sld xmlns:p="http://schemas.openxmlformats.org/presentationml/2006/main">
-  <p:cSld>
-    <p:spTree>
-      <p:nvGrpSpPr>
-        <p:cNvPr id="1" name=""/>
-        <p:cNvGrpSpPr/>
-        <p:nvPr/>
-      </p:nvGrpSpPr>
-      <p:grpSpPr>
-        <a:xfrm xmlns:a="http://schemas.openxmlformats.org/drawingml/2006/main"/>
-      </p:grpSpPr>
-      <p:sp>
-        <p:nvSpPr>
-          <p:cNvPr id="2" name="Title 1">
-            <a:extLst xmlns:a="http://schemas.openxmlformats.org/drawingml/2006/main">
-              <a:ext uri="{FF2B5EF4-FFF2-40B4-BE49-F238E27FC236}">
-                <a16:creationId xmlns:a16="http://schemas.microsoft.com/office/drawing/2014/main" id="{F64C2A24-546D-C55C-2C52-97A4957F67E0}"/>
-              </a:ext>
-            </a:extLst>
-          </p:cNvPr>
-          <p:cNvSpPr>
-            <a:spLocks xmlns:a="http://schemas.openxmlformats.org/drawingml/2006/main" noGrp="1"/>
-          </p:cNvSpPr>
-          <p:nvPr>
-            <p:ph type="title" idx="0"/>
-          </p:nvPr>
-        </p:nvSpPr>
-        <p:spPr>
-          <a:xfrm xmlns:a="http://schemas.openxmlformats.org/drawingml/2006/main">
-            <a:off x="838200" y="365125"/>
-            <a:ext cx="10515600" cy="1325700"/>
-          </a:xfrm>
-        </p:spPr>
-        <p:txBody>
-          <a:bodyPr xmlns:a="http://schemas.openxmlformats.org/drawingml/2006/main">
-            <a:normAutofit fontScale="100000"/>
-          </a:bodyPr>
-          <a:lstStyle xmlns:a="http://schemas.openxmlformats.org/drawingml/2006/main"/>
-          <a:p xmlns:a="http://schemas.openxmlformats.org/drawingml/2006/main">
-            <a:r>
-              <a:t>The decision we need from each project</a:t>
-            </a:r>
-          </a:p>
-        </p:txBody>
-      </p:sp>
-      <p:sp>
-        <p:nvSpPr>
-          <p:cNvPr id="3" name="Content Placeholder 2">
-            <a:extLst xmlns:a="http://schemas.openxmlformats.org/drawingml/2006/main">
-              <a:ext uri="{FF2B5EF4-FFF2-40B4-BE49-F238E27FC236}">
-                <a16:creationId xmlns:a16="http://schemas.microsoft.com/office/drawing/2014/main" id="{ECF5C9F1-2691-0BC9-F1E1-01CECB857FE3}"/>
-              </a:ext>
-            </a:extLst>
-          </p:cNvPr>
-          <p:cNvSpPr>
-            <a:spLocks xmlns:a="http://schemas.openxmlformats.org/drawingml/2006/main" noGrp="1"/>
-          </p:cNvSpPr>
-          <p:nvPr>
-            <p:ph type="body" idx="1"/>
-          </p:nvPr>
-        </p:nvSpPr>
-        <p:spPr>
-          <a:xfrm xmlns:a="http://schemas.openxmlformats.org/drawingml/2006/main">
-            <a:off x="838200" y="1825625"/>
-            <a:ext cx="10515600" cy="4351200"/>
-          </a:xfrm>
-        </p:spPr>
-        <p:txBody>
-          <a:bodyPr xmlns:a="http://schemas.openxmlformats.org/drawingml/2006/main" wrap="square" anchor="t">
-            <a:normAutofit fontScale="100000"/>
-          </a:bodyPr>
-          <a:lstStyle xmlns:a="http://schemas.openxmlformats.org/drawingml/2006/main"/>
-          <a:p xmlns:a="http://schemas.openxmlformats.org/drawingml/2006/main">
-            <a:pPr marL="30" indent="-18">
-              <a:spcAft>
-                <a:spcPts val="10"/>
-              </a:spcAft>
-              <a:buChar char="•"/>
-              <a:defRPr sz="1913">
-                <a:solidFill>
-                  <a:srgbClr val="000000"/>
-                </a:solidFill>
-              </a:defRPr>
-            </a:pPr>
-            <a:r>
-              <a:rPr sz="1913" b="1">
-                <a:solidFill>
-                  <a:srgbClr val="000000"/>
-                </a:solidFill>
-              </a:rPr>
-              <a:t> Name one owner</a:t>
-            </a:r>
-            <a:r>
-              <a:rPr sz="1913">
-                <a:solidFill>
-                  <a:srgbClr val="000000"/>
-                </a:solidFill>
-              </a:rPr>
-              <a:t> — A maintainer or small reviewer group for scope and source freshness.</a:t>
-            </a:r>
-          </a:p>
-          <a:p xmlns:a="http://schemas.openxmlformats.org/drawingml/2006/main">
-            <a:pPr marL="30" indent="-18">
-              <a:spcAft>
-                <a:spcPts val="10"/>
-              </a:spcAft>
-              <a:buChar char="•"/>
-              <a:defRPr sz="1913">
-                <a:solidFill>
-                  <a:srgbClr val="000000"/>
-                </a:solidFill>
-              </a:defRPr>
-            </a:pPr>
-            <a:r>
-              <a:rPr sz="1913" b="1">
-                <a:solidFill>
-                  <a:srgbClr val="000000"/>
-                </a:solidFill>
-              </a:rPr>
-              <a:t> Approve or correct the first-pass guidance</a:t>
-            </a:r>
-            <a:r>
-              <a:rPr sz="1913">
-                <a:solidFill>
-                  <a:srgbClr val="000000"/>
-                </a:solidFill>
-              </a:rPr>
-              <a:t> — Especially triggers, gotchas, unsupported paths, and terminology.</a:t>
-            </a:r>
-          </a:p>
-          <a:p xmlns:a="http://schemas.openxmlformats.org/drawingml/2006/main">
-            <a:pPr marL="30" indent="-18">
-              <a:spcAft>
-                <a:spcPts val="10"/>
-              </a:spcAft>
-              <a:buChar char="•"/>
-              <a:defRPr sz="1913">
-                <a:solidFill>
-                  <a:srgbClr val="000000"/>
-                </a:solidFill>
-              </a:defRPr>
-            </a:pPr>
-            <a:r>
-              <a:rPr sz="1913" b="1">
-                <a:solidFill>
-                  <a:srgbClr val="000000"/>
-                </a:solidFill>
-              </a:rPr>
-              <a:t> Validate the task inventory</a:t>
-            </a:r>
-            <a:r>
-              <a:rPr sz="1913">
-                <a:solidFill>
-                  <a:srgbClr val="000000"/>
-                </a:solidFill>
-              </a:rPr>
-              <a:t> — Keep, rewrite, or delete scenarios; nominate one real support issue or regression.</a:t>
-            </a:r>
-          </a:p>
-          <a:p xmlns:a="http://schemas.openxmlformats.org/drawingml/2006/main">
-            <a:pPr marL="30" indent="-18">
-              <a:spcAft>
-                <a:spcPts val="10"/>
-              </a:spcAft>
-              <a:buChar char="•"/>
-              <a:defRPr sz="1913">
-                <a:solidFill>
-                  <a:srgbClr val="000000"/>
-                </a:solidFill>
-              </a:defRPr>
-            </a:pPr>
-            <a:r>
-              <a:rPr sz="1913" b="1">
-                <a:solidFill>
-                  <a:srgbClr val="000000"/>
-                </a:solidFill>
-              </a:rPr>
-              <a:t> Adopt a light cadence</a:t>
-            </a:r>
-            <a:r>
-              <a:rPr sz="1913">
-                <a:solidFill>
-                  <a:srgbClr val="000000"/>
-                </a:solidFill>
-              </a:rPr>
-              <a:t> — Review skill-affecting PRs and recheck sources at releases or quarterly.</a:t>
-            </a:r>
-          </a:p>
-          <a:p xmlns:a="http://schemas.openxmlformats.org/drawingml/2006/main">
-            <a:pPr marL="30" indent="-18">
-              <a:spcAft>
-                <a:spcPts val="10"/>
-              </a:spcAft>
-              <a:buChar char="•"/>
-              <a:defRPr sz="1913">
-                <a:solidFill>
-                  <a:srgbClr val="000000"/>
-                </a:solidFill>
-              </a:defRPr>
-            </a:pPr>
-            <a:r>
-              <a:rPr sz="1913" b="1">
-                <a:solidFill>
-                  <a:srgbClr val="000000"/>
-                </a:solidFill>
-              </a:rPr>
-              <a:t> Start small</a:t>
-            </a:r>
-            <a:r>
-              <a:rPr sz="1913">
-                <a:solidFill>
-                  <a:srgbClr val="000000"/>
-                </a:solidFill>
-              </a:rPr>
-              <a:t> — A 30-minute review is enough to turn this from UXL-authored draft into project-backed guidance.</a:t>
-            </a:r>
-          </a:p>
-        </p:txBody>
-      </p:sp>
-      <p:sp>
-        <p:nvSpPr>
-          <p:cNvPr id="7" name="TextBox 6">
-            <a:extLst xmlns:a="http://schemas.openxmlformats.org/drawingml/2006/main">
-              <a:ext uri="{FF2B5EF4-FFF2-40B4-BE49-F238E27FC236}">
-                <a16:creationId xmlns:a16="http://schemas.microsoft.com/office/drawing/2014/main" id="{E2E6F043-0F84-54F7-A567-6E5851801779}"/>
-              </a:ext>
-            </a:extLst>
-          </p:cNvPr>
-          <p:cNvSpPr>
-            <a:spLocks xmlns:a="http://schemas.openxmlformats.org/drawingml/2006/main" noGrp="1"/>
-          </p:cNvSpPr>
-          <p:nvPr/>
-        </p:nvSpPr>
-        <p:spPr>
-          <a:xfrm xmlns:a="http://schemas.openxmlformats.org/drawingml/2006/main">
-            <a:off x="696174" y="6338986"/>
-            <a:ext cx="284052" cy="307777"/>
-          </a:xfrm>
-          <a:prstGeom xmlns:a="http://schemas.openxmlformats.org/drawingml/2006/main" prst="rect">
-            <a:avLst/>
-          </a:prstGeom>
-          <a:noFill xmlns:a="http://schemas.openxmlformats.org/drawingml/2006/main"/>
-        </p:spPr>
-        <p:txBody>
-          <a:bodyPr xmlns:a="http://schemas.openxmlformats.org/drawingml/2006/main" wrap="none">
-            <a:spAutoFit/>
-          </a:bodyPr>
-          <a:lstStyle xmlns:a="http://schemas.openxmlformats.org/drawingml/2006/main"/>
-          <a:p xmlns:a="http://schemas.openxmlformats.org/drawingml/2006/main">
-            <a:r>
-              <a:t>14</a:t>
             </a:r>
           </a:p>
         </p:txBody>
@@ -31997,7 +31629,7 @@
           <a:lstStyle xmlns:a="http://schemas.openxmlformats.org/drawingml/2006/main"/>
           <a:p xmlns:a="http://schemas.openxmlformats.org/drawingml/2006/main">
             <a:r>
-              <a:t>Why project maintainers should care</a:t>
+              <a:t>What exists today</a:t>
             </a:r>
           </a:p>
         </p:txBody>
@@ -32047,7 +31679,7 @@
                   <a:srgbClr val="000000"/>
                 </a:solidFill>
               </a:rPr>
-              <a:t> Fewer repeat explanations</a:t>
+              <a:t> 8 skills</a:t>
             </a:r>
             <a:r>
               <a:rPr sz="1913">
@@ -32055,7 +31687,7 @@
                   <a:srgbClr val="000000"/>
                 </a:solidFill>
               </a:rPr>
-              <a:t> — Capture the review comments, setup choices, and failure triage your team repeats today.</a:t>
+              <a:t> — Six library portfolios plus shared SYCL build/debug and performance-validation guidance.</a:t>
             </a:r>
           </a:p>
           <a:p xmlns:a="http://schemas.openxmlformats.org/drawingml/2006/main">
@@ -32076,7 +31708,7 @@
                   <a:srgbClr val="000000"/>
                 </a:solidFill>
               </a:rPr>
-              <a:t> Safer agent contributions</a:t>
+              <a:t> 52 scoped evaluation tasks</a:t>
             </a:r>
             <a:r>
               <a:rPr sz="1913">
@@ -32084,7 +31716,7 @@
                   <a:srgbClr val="000000"/>
                 </a:solidFill>
               </a:rPr>
-              <a:t> — Guide agents toward project-owned APIs, tests, evidence, and honest limitations before they open a PR.</a:t>
+              <a:t> — 41 implemented and 11 left visible as planned gaps; this is inventory, not a pass-rate claim.</a:t>
             </a:r>
           </a:p>
           <a:p xmlns:a="http://schemas.openxmlformats.org/drawingml/2006/main">
@@ -32105,7 +31737,7 @@
                   <a:srgbClr val="000000"/>
                 </a:solidFill>
               </a:rPr>
-              <a:t> Reviewable change control</a:t>
+              <a:t> A public control room</a:t>
             </a:r>
             <a:r>
               <a:rPr sz="1913">
@@ -32113,7 +31745,7 @@
                   <a:srgbClr val="000000"/>
                 </a:solidFill>
               </a:rPr>
-              <a:t> — Skills are small repository files; guidance changes arrive through normal GitHub review.</a:t>
+              <a:t> — Skills, evaluations, platforms, methodology, maturity, source freshness, and ownership status.</a:t>
             </a:r>
           </a:p>
           <a:p xmlns:a="http://schemas.openxmlformats.org/drawingml/2006/main">
@@ -32134,7 +31766,7 @@
                   <a:srgbClr val="000000"/>
                 </a:solidFill>
               </a:rPr>
-              <a:t> Measured usefulness</a:t>
+              <a:t> A portable execution model</a:t>
             </a:r>
             <a:r>
               <a:rPr sz="1913">
@@ -32142,7 +31774,7 @@
                   <a:srgbClr val="000000"/>
                 </a:solidFill>
               </a:rPr>
-              <a:t> — Executable evaluations check whether the guidance improves verified outcomes — not just whether it sounds plausible.</a:t>
+              <a:t> — GitHub-hosted checks by default; opt-in specialized machines only when a task contract requires them.</a:t>
             </a:r>
           </a:p>
         </p:txBody>
@@ -32234,7 +31866,7 @@
           <a:lstStyle xmlns:a="http://schemas.openxmlformats.org/drawingml/2006/main"/>
           <a:p xmlns:a="http://schemas.openxmlformats.org/drawingml/2006/main">
             <a:r>
-              <a:t>What exists today</a:t>
+              <a:t>The current skill catalog — at a glance</a:t>
             </a:r>
           </a:p>
         </p:txBody>
@@ -32284,7 +31916,7 @@
                   <a:srgbClr val="000000"/>
                 </a:solidFill>
               </a:rPr>
-              <a:t> 8 skills</a:t>
+              <a:t> oneDNN</a:t>
             </a:r>
             <a:r>
               <a:rPr sz="1913">
@@ -32292,7 +31924,7 @@
                   <a:srgbClr val="000000"/>
                 </a:solidFill>
               </a:rPr>
-              <a:t> — Six library portfolios plus shared SYCL build/debug and performance-validation guidance.</a:t>
+              <a:t> — Primitives, layouts/reorders, fusion, numerics, benchdnn.</a:t>
             </a:r>
           </a:p>
           <a:p xmlns:a="http://schemas.openxmlformats.org/drawingml/2006/main">
@@ -32313,7 +31945,7 @@
                   <a:srgbClr val="000000"/>
                 </a:solidFill>
               </a:rPr>
-              <a:t> 52 scoped evaluation tasks</a:t>
+              <a:t> oneMath</a:t>
             </a:r>
             <a:r>
               <a:rPr sz="1913">
@@ -32321,7 +31953,7 @@
                   <a:srgbClr val="000000"/>
                 </a:solidFill>
               </a:rPr>
-              <a:t> — 41 implemented and 11 left visible as planned gaps; this is inventory, not a pass-rate claim.</a:t>
+              <a:t> — Domains, dispatch modes, queues, backends, linking.</a:t>
             </a:r>
           </a:p>
           <a:p xmlns:a="http://schemas.openxmlformats.org/drawingml/2006/main">
@@ -32342,7 +31974,7 @@
                   <a:srgbClr val="000000"/>
                 </a:solidFill>
               </a:rPr>
-              <a:t> A public control room</a:t>
+              <a:t> oneDAL</a:t>
             </a:r>
             <a:r>
               <a:rPr sz="1913">
@@ -32350,7 +31982,7 @@
                   <a:srgbClr val="000000"/>
                 </a:solidFill>
               </a:rPr>
-              <a:t> — Skills, evaluations, platforms, methodology, maturity, source freshness, and ownership status.</a:t>
+              <a:t> — Python/native paths, modes, tables, metric parity, conversion cost.</a:t>
             </a:r>
           </a:p>
           <a:p xmlns:a="http://schemas.openxmlformats.org/drawingml/2006/main">
@@ -32371,7 +32003,7 @@
                   <a:srgbClr val="000000"/>
                 </a:solidFill>
               </a:rPr>
-              <a:t> A portable execution model</a:t>
+              <a:t> oneTBB</a:t>
             </a:r>
             <a:r>
               <a:rPr sz="1913">
@@ -32379,7 +32011,94 @@
                   <a:srgbClr val="000000"/>
                 </a:solidFill>
               </a:rPr>
-              <a:t> — GitHub-hosted checks by default; opt-in specialized machines only when a task contract requires them.</a:t>
+              <a:t> — Patterns, shared state, flow graphs, arenas, grainsize/affinity.</a:t>
+            </a:r>
+          </a:p>
+          <a:p xmlns:a="http://schemas.openxmlformats.org/drawingml/2006/main">
+            <a:pPr marL="30" indent="-18">
+              <a:spcAft>
+                <a:spcPts val="10"/>
+              </a:spcAft>
+              <a:buChar char="•"/>
+              <a:defRPr sz="1913">
+                <a:solidFill>
+                  <a:srgbClr val="000000"/>
+                </a:solidFill>
+              </a:defRPr>
+            </a:pPr>
+            <a:r>
+              <a:rPr sz="1913" b="1">
+                <a:solidFill>
+                  <a:srgbClr val="000000"/>
+                </a:solidFill>
+              </a:rPr>
+              <a:t> oneDPL</a:t>
+            </a:r>
+            <a:r>
+              <a:rPr sz="1913">
+                <a:solidFill>
+                  <a:srgbClr val="000000"/>
+                </a:solidFill>
+              </a:rPr>
+              <a:t> — Host/device policies, iterators, lifetime, synchronization, ordering.</a:t>
+            </a:r>
+          </a:p>
+          <a:p xmlns:a="http://schemas.openxmlformats.org/drawingml/2006/main">
+            <a:pPr marL="30" indent="-18">
+              <a:spcAft>
+                <a:spcPts val="10"/>
+              </a:spcAft>
+              <a:buChar char="•"/>
+              <a:defRPr sz="1913">
+                <a:solidFill>
+                  <a:srgbClr val="000000"/>
+                </a:solidFill>
+              </a:defRPr>
+            </a:pPr>
+            <a:r>
+              <a:rPr sz="1913" b="1">
+                <a:solidFill>
+                  <a:srgbClr val="000000"/>
+                </a:solidFill>
+              </a:rPr>
+              <a:t> oneCCL</a:t>
+            </a:r>
+            <a:r>
+              <a:rPr sz="1913">
+                <a:solidFill>
+                  <a:srgbClr val="000000"/>
+                </a:solidFill>
+              </a:rPr>
+              <a:t> — Collectives, ranks, launch symmetry, waits, plugins, hangs.</a:t>
+            </a:r>
+          </a:p>
+          <a:p xmlns:a="http://schemas.openxmlformats.org/drawingml/2006/main">
+            <a:pPr marL="30" indent="-18">
+              <a:spcAft>
+                <a:spcPts val="10"/>
+              </a:spcAft>
+              <a:buChar char="•"/>
+              <a:defRPr sz="1913">
+                <a:solidFill>
+                  <a:srgbClr val="000000"/>
+                </a:solidFill>
+              </a:defRPr>
+            </a:pPr>
+            <a:r>
+              <a:rPr sz="1913" b="1">
+                <a:solidFill>
+                  <a:srgbClr val="000000"/>
+                </a:solidFill>
+              </a:rPr>
+              <a:t> Cross-project</a:t>
+            </a:r>
+            <a:r>
+              <a:rPr sz="1913">
+                <a:solidFill>
+                  <a:srgbClr val="000000"/>
+                </a:solidFill>
+              </a:rPr>
+              <a:t> — SYCL build/runtime triage and correctness-first performance evidence.</a:t>
             </a:r>
           </a:p>
         </p:txBody>
@@ -32471,239 +32190,7 @@
           <a:lstStyle xmlns:a="http://schemas.openxmlformats.org/drawingml/2006/main"/>
           <a:p xmlns:a="http://schemas.openxmlformats.org/drawingml/2006/main">
             <a:r>
-              <a:t>The current skill catalog — at a glance</a:t>
-            </a:r>
-          </a:p>
-        </p:txBody>
-      </p:sp>
-      <p:sp>
-        <p:nvSpPr>
-          <p:cNvPr id="3" name="Content Placeholder 2">
-            <a:extLst xmlns:a="http://schemas.openxmlformats.org/drawingml/2006/main">
-              <a:ext uri="{FF2B5EF4-FFF2-40B4-BE49-F238E27FC236}">
-                <a16:creationId xmlns:a16="http://schemas.microsoft.com/office/drawing/2014/main" id="{ECF5C9F1-2691-0BC9-F1E1-01CECB857FE3}"/>
-              </a:ext>
-            </a:extLst>
-          </p:cNvPr>
-          <p:cNvSpPr>
-            <a:spLocks xmlns:a="http://schemas.openxmlformats.org/drawingml/2006/main" noGrp="1"/>
-          </p:cNvSpPr>
-          <p:nvPr>
-            <p:ph type="body" idx="1"/>
-          </p:nvPr>
-        </p:nvSpPr>
-        <p:spPr>
-          <a:xfrm xmlns:a="http://schemas.openxmlformats.org/drawingml/2006/main">
-            <a:off x="838200" y="1825625"/>
-            <a:ext cx="10515600" cy="4351200"/>
-          </a:xfrm>
-        </p:spPr>
-        <p:txBody>
-          <a:bodyPr xmlns:a="http://schemas.openxmlformats.org/drawingml/2006/main" wrap="square" anchor="t">
-            <a:normAutofit fontScale="100000"/>
-          </a:bodyPr>
-          <a:lstStyle xmlns:a="http://schemas.openxmlformats.org/drawingml/2006/main"/>
-          <a:p xmlns:a="http://schemas.openxmlformats.org/drawingml/2006/main">
-            <a:pPr marL="30" indent="-18">
-              <a:spcAft>
-                <a:spcPts val="10"/>
-              </a:spcAft>
-              <a:buChar char="•"/>
-              <a:defRPr sz="1913">
-                <a:solidFill>
-                  <a:srgbClr val="000000"/>
-                </a:solidFill>
-              </a:defRPr>
-            </a:pPr>
-            <a:r>
-              <a:rPr sz="1913" b="1">
-                <a:solidFill>
-                  <a:srgbClr val="000000"/>
-                </a:solidFill>
-              </a:rPr>
-              <a:t> oneDNN</a:t>
-            </a:r>
-            <a:r>
-              <a:rPr sz="1913">
-                <a:solidFill>
-                  <a:srgbClr val="000000"/>
-                </a:solidFill>
-              </a:rPr>
-              <a:t> — Primitives, layouts/reorders, fusion, numerics, benchdnn.</a:t>
-            </a:r>
-          </a:p>
-          <a:p xmlns:a="http://schemas.openxmlformats.org/drawingml/2006/main">
-            <a:pPr marL="30" indent="-18">
-              <a:spcAft>
-                <a:spcPts val="10"/>
-              </a:spcAft>
-              <a:buChar char="•"/>
-              <a:defRPr sz="1913">
-                <a:solidFill>
-                  <a:srgbClr val="000000"/>
-                </a:solidFill>
-              </a:defRPr>
-            </a:pPr>
-            <a:r>
-              <a:rPr sz="1913" b="1">
-                <a:solidFill>
-                  <a:srgbClr val="000000"/>
-                </a:solidFill>
-              </a:rPr>
-              <a:t> oneMath</a:t>
-            </a:r>
-            <a:r>
-              <a:rPr sz="1913">
-                <a:solidFill>
-                  <a:srgbClr val="000000"/>
-                </a:solidFill>
-              </a:rPr>
-              <a:t> — Domains, dispatch modes, queues, backends, linking.</a:t>
-            </a:r>
-          </a:p>
-          <a:p xmlns:a="http://schemas.openxmlformats.org/drawingml/2006/main">
-            <a:pPr marL="30" indent="-18">
-              <a:spcAft>
-                <a:spcPts val="10"/>
-              </a:spcAft>
-              <a:buChar char="•"/>
-              <a:defRPr sz="1913">
-                <a:solidFill>
-                  <a:srgbClr val="000000"/>
-                </a:solidFill>
-              </a:defRPr>
-            </a:pPr>
-            <a:r>
-              <a:rPr sz="1913" b="1">
-                <a:solidFill>
-                  <a:srgbClr val="000000"/>
-                </a:solidFill>
-              </a:rPr>
-              <a:t> oneDAL</a:t>
-            </a:r>
-            <a:r>
-              <a:rPr sz="1913">
-                <a:solidFill>
-                  <a:srgbClr val="000000"/>
-                </a:solidFill>
-              </a:rPr>
-              <a:t> — Python/native paths, modes, tables, metric parity, conversion cost.</a:t>
-            </a:r>
-          </a:p>
-          <a:p xmlns:a="http://schemas.openxmlformats.org/drawingml/2006/main">
-            <a:pPr marL="30" indent="-18">
-              <a:spcAft>
-                <a:spcPts val="10"/>
-              </a:spcAft>
-              <a:buChar char="•"/>
-              <a:defRPr sz="1913">
-                <a:solidFill>
-                  <a:srgbClr val="000000"/>
-                </a:solidFill>
-              </a:defRPr>
-            </a:pPr>
-            <a:r>
-              <a:rPr sz="1913" b="1">
-                <a:solidFill>
-                  <a:srgbClr val="000000"/>
-                </a:solidFill>
-              </a:rPr>
-              <a:t> oneTBB</a:t>
-            </a:r>
-            <a:r>
-              <a:rPr sz="1913">
-                <a:solidFill>
-                  <a:srgbClr val="000000"/>
-                </a:solidFill>
-              </a:rPr>
-              <a:t> — Patterns, shared state, flow graphs, arenas, grainsize/affinity.</a:t>
-            </a:r>
-          </a:p>
-          <a:p xmlns:a="http://schemas.openxmlformats.org/drawingml/2006/main">
-            <a:pPr marL="30" indent="-18">
-              <a:spcAft>
-                <a:spcPts val="10"/>
-              </a:spcAft>
-              <a:buChar char="•"/>
-              <a:defRPr sz="1913">
-                <a:solidFill>
-                  <a:srgbClr val="000000"/>
-                </a:solidFill>
-              </a:defRPr>
-            </a:pPr>
-            <a:r>
-              <a:rPr sz="1913" b="1">
-                <a:solidFill>
-                  <a:srgbClr val="000000"/>
-                </a:solidFill>
-              </a:rPr>
-              <a:t> oneDPL</a:t>
-            </a:r>
-            <a:r>
-              <a:rPr sz="1913">
-                <a:solidFill>
-                  <a:srgbClr val="000000"/>
-                </a:solidFill>
-              </a:rPr>
-              <a:t> — Host/device policies, iterators, lifetime, synchronization, ordering.</a:t>
-            </a:r>
-          </a:p>
-          <a:p xmlns:a="http://schemas.openxmlformats.org/drawingml/2006/main">
-            <a:pPr marL="30" indent="-18">
-              <a:spcAft>
-                <a:spcPts val="10"/>
-              </a:spcAft>
-              <a:buChar char="•"/>
-              <a:defRPr sz="1913">
-                <a:solidFill>
-                  <a:srgbClr val="000000"/>
-                </a:solidFill>
-              </a:defRPr>
-            </a:pPr>
-            <a:r>
-              <a:rPr sz="1913" b="1">
-                <a:solidFill>
-                  <a:srgbClr val="000000"/>
-                </a:solidFill>
-              </a:rPr>
-              <a:t> oneCCL</a:t>
-            </a:r>
-            <a:r>
-              <a:rPr sz="1913">
-                <a:solidFill>
-                  <a:srgbClr val="000000"/>
-                </a:solidFill>
-              </a:rPr>
-              <a:t> — Collectives, ranks, launch symmetry, waits, plugins, hangs.</a:t>
-            </a:r>
-          </a:p>
-          <a:p xmlns:a="http://schemas.openxmlformats.org/drawingml/2006/main">
-            <a:pPr marL="30" indent="-18">
-              <a:spcAft>
-                <a:spcPts val="10"/>
-              </a:spcAft>
-              <a:buChar char="•"/>
-              <a:defRPr sz="1913">
-                <a:solidFill>
-                  <a:srgbClr val="000000"/>
-                </a:solidFill>
-              </a:defRPr>
-            </a:pPr>
-            <a:r>
-              <a:rPr sz="1913" b="1">
-                <a:solidFill>
-                  <a:srgbClr val="000000"/>
-                </a:solidFill>
-              </a:rPr>
-              <a:t> Cross-project</a:t>
-            </a:r>
-            <a:r>
-              <a:rPr sz="1913">
-                <a:solidFill>
-                  <a:srgbClr val="000000"/>
-                </a:solidFill>
-              </a:rPr>
-              <a:t> — SYCL build/runtime triage and correctness-first performance evidence.</a:t>
+              <a:t>Architecture: project knowledge becomes measured evidence</a:t>
             </a:r>
           </a:p>
         </p:txBody>
@@ -32740,98 +32227,6 @@
           <a:p xmlns:a="http://schemas.openxmlformats.org/drawingml/2006/main">
             <a:r>
               <a:t>4</a:t>
-            </a:r>
-          </a:p>
-        </p:txBody>
-      </p:sp>
-    </p:spTree>
-    <p:extLst>
-      <p:ext uri="{BB962C8B-B14F-4D97-AF65-F5344CB8AC3E}">
-        <p14:creationId xmlns:p14="http://schemas.microsoft.com/office/powerpoint/2010/main" val="1742728663"/>
-      </p:ext>
-    </p:extLst>
-  </p:cSld>
-</p:sld>
-</file>
-
-<file path=ppt/slides/slide5.xml><?xml version="1.0" encoding="utf-8"?>
-<p:sld xmlns:p="http://schemas.openxmlformats.org/presentationml/2006/main">
-  <p:cSld>
-    <p:spTree>
-      <p:nvGrpSpPr>
-        <p:cNvPr id="1" name=""/>
-        <p:cNvGrpSpPr/>
-        <p:nvPr/>
-      </p:nvGrpSpPr>
-      <p:grpSpPr>
-        <a:xfrm xmlns:a="http://schemas.openxmlformats.org/drawingml/2006/main"/>
-      </p:grpSpPr>
-      <p:sp>
-        <p:nvSpPr>
-          <p:cNvPr id="2" name="Title 1">
-            <a:extLst xmlns:a="http://schemas.openxmlformats.org/drawingml/2006/main">
-              <a:ext uri="{FF2B5EF4-FFF2-40B4-BE49-F238E27FC236}">
-                <a16:creationId xmlns:a16="http://schemas.microsoft.com/office/drawing/2014/main" id="{F64C2A24-546D-C55C-2C52-97A4957F67E0}"/>
-              </a:ext>
-            </a:extLst>
-          </p:cNvPr>
-          <p:cNvSpPr>
-            <a:spLocks xmlns:a="http://schemas.openxmlformats.org/drawingml/2006/main" noGrp="1"/>
-          </p:cNvSpPr>
-          <p:nvPr>
-            <p:ph type="title" idx="0"/>
-          </p:nvPr>
-        </p:nvSpPr>
-        <p:spPr>
-          <a:xfrm xmlns:a="http://schemas.openxmlformats.org/drawingml/2006/main">
-            <a:off x="838200" y="365125"/>
-            <a:ext cx="10515600" cy="1325700"/>
-          </a:xfrm>
-        </p:spPr>
-        <p:txBody>
-          <a:bodyPr xmlns:a="http://schemas.openxmlformats.org/drawingml/2006/main">
-            <a:normAutofit fontScale="100000"/>
-          </a:bodyPr>
-          <a:lstStyle xmlns:a="http://schemas.openxmlformats.org/drawingml/2006/main"/>
-          <a:p xmlns:a="http://schemas.openxmlformats.org/drawingml/2006/main">
-            <a:r>
-              <a:t>Architecture: project knowledge becomes measured evidence</a:t>
-            </a:r>
-          </a:p>
-        </p:txBody>
-      </p:sp>
-      <p:sp>
-        <p:nvSpPr>
-          <p:cNvPr id="7" name="TextBox 6">
-            <a:extLst xmlns:a="http://schemas.openxmlformats.org/drawingml/2006/main">
-              <a:ext uri="{FF2B5EF4-FFF2-40B4-BE49-F238E27FC236}">
-                <a16:creationId xmlns:a16="http://schemas.microsoft.com/office/drawing/2014/main" id="{E2E6F043-0F84-54F7-A567-6E5851801779}"/>
-              </a:ext>
-            </a:extLst>
-          </p:cNvPr>
-          <p:cNvSpPr>
-            <a:spLocks xmlns:a="http://schemas.openxmlformats.org/drawingml/2006/main" noGrp="1"/>
-          </p:cNvSpPr>
-          <p:nvPr/>
-        </p:nvSpPr>
-        <p:spPr>
-          <a:xfrm xmlns:a="http://schemas.openxmlformats.org/drawingml/2006/main">
-            <a:off x="696174" y="6338986"/>
-            <a:ext cx="284052" cy="307777"/>
-          </a:xfrm>
-          <a:prstGeom xmlns:a="http://schemas.openxmlformats.org/drawingml/2006/main" prst="rect">
-            <a:avLst/>
-          </a:prstGeom>
-          <a:noFill xmlns:a="http://schemas.openxmlformats.org/drawingml/2006/main"/>
-        </p:spPr>
-        <p:txBody>
-          <a:bodyPr xmlns:a="http://schemas.openxmlformats.org/drawingml/2006/main" wrap="none">
-            <a:spAutoFit/>
-          </a:bodyPr>
-          <a:lstStyle xmlns:a="http://schemas.openxmlformats.org/drawingml/2006/main"/>
-          <a:p xmlns:a="http://schemas.openxmlformats.org/drawingml/2006/main">
-            <a:r>
-              <a:t>5</a:t>
             </a:r>
           </a:p>
         </p:txBody>
@@ -33575,6 +32970,120 @@
 </p:sld>
 </file>
 
+<file path=ppt/slides/slide5.xml><?xml version="1.0" encoding="utf-8"?>
+<p:sld xmlns:p="http://schemas.openxmlformats.org/presentationml/2006/main">
+  <p:cSld>
+    <p:spTree>
+      <p:nvGrpSpPr>
+        <p:cNvPr id="1" name=""/>
+        <p:cNvGrpSpPr/>
+        <p:nvPr/>
+      </p:nvGrpSpPr>
+      <p:grpSpPr>
+        <a:xfrm xmlns:a="http://schemas.openxmlformats.org/drawingml/2006/main"/>
+      </p:grpSpPr>
+      <p:sp>
+        <p:nvSpPr>
+          <p:cNvPr id="2" name="Title 1">
+            <a:extLst xmlns:a="http://schemas.openxmlformats.org/drawingml/2006/main">
+              <a:ext uri="{FF2B5EF4-FFF2-40B4-BE49-F238E27FC236}">
+                <a16:creationId xmlns:a16="http://schemas.microsoft.com/office/drawing/2014/main" id="{F64C2A24-546D-C55C-2C52-97A4957F67E0}"/>
+              </a:ext>
+            </a:extLst>
+          </p:cNvPr>
+          <p:cNvSpPr>
+            <a:spLocks xmlns:a="http://schemas.openxmlformats.org/drawingml/2006/main" noGrp="1"/>
+          </p:cNvSpPr>
+          <p:nvPr>
+            <p:ph type="title" idx="0"/>
+          </p:nvPr>
+        </p:nvSpPr>
+        <p:spPr>
+          <a:xfrm xmlns:a="http://schemas.openxmlformats.org/drawingml/2006/main">
+            <a:off x="838200" y="365125"/>
+            <a:ext cx="10515600" cy="1325700"/>
+          </a:xfrm>
+        </p:spPr>
+        <p:txBody>
+          <a:bodyPr xmlns:a="http://schemas.openxmlformats.org/drawingml/2006/main">
+            <a:normAutofit fontScale="100000"/>
+          </a:bodyPr>
+          <a:lstStyle xmlns:a="http://schemas.openxmlformats.org/drawingml/2006/main"/>
+          <a:p xmlns:a="http://schemas.openxmlformats.org/drawingml/2006/main">
+            <a:r>
+              <a:t>The public control room answers: are the skills healthy?</a:t>
+            </a:r>
+          </a:p>
+        </p:txBody>
+      </p:sp>
+      <p:sp>
+        <p:nvSpPr>
+          <p:cNvPr id="7" name="TextBox 6">
+            <a:extLst xmlns:a="http://schemas.openxmlformats.org/drawingml/2006/main">
+              <a:ext uri="{FF2B5EF4-FFF2-40B4-BE49-F238E27FC236}">
+                <a16:creationId xmlns:a16="http://schemas.microsoft.com/office/drawing/2014/main" id="{E2E6F043-0F84-54F7-A567-6E5851801779}"/>
+              </a:ext>
+            </a:extLst>
+          </p:cNvPr>
+          <p:cNvSpPr>
+            <a:spLocks xmlns:a="http://schemas.openxmlformats.org/drawingml/2006/main" noGrp="1"/>
+          </p:cNvSpPr>
+          <p:nvPr/>
+        </p:nvSpPr>
+        <p:spPr>
+          <a:xfrm xmlns:a="http://schemas.openxmlformats.org/drawingml/2006/main">
+            <a:off x="696174" y="6338986"/>
+            <a:ext cx="284052" cy="307777"/>
+          </a:xfrm>
+          <a:prstGeom xmlns:a="http://schemas.openxmlformats.org/drawingml/2006/main" prst="rect">
+            <a:avLst/>
+          </a:prstGeom>
+          <a:noFill xmlns:a="http://schemas.openxmlformats.org/drawingml/2006/main"/>
+        </p:spPr>
+        <p:txBody>
+          <a:bodyPr xmlns:a="http://schemas.openxmlformats.org/drawingml/2006/main" wrap="none">
+            <a:spAutoFit/>
+          </a:bodyPr>
+          <a:lstStyle xmlns:a="http://schemas.openxmlformats.org/drawingml/2006/main"/>
+          <a:p xmlns:a="http://schemas.openxmlformats.org/drawingml/2006/main">
+            <a:r>
+              <a:t>5</a:t>
+            </a:r>
+          </a:p>
+        </p:txBody>
+      </p:sp>
+      <p:pic>
+        <p:nvPicPr>
+          <p:cNvPr id="11" name=""/>
+          <p:cNvPicPr>
+            <a:picLocks xmlns:a="http://schemas.openxmlformats.org/drawingml/2006/main" noChangeAspect="1"/>
+          </p:cNvPicPr>
+          <p:nvPr/>
+        </p:nvPicPr>
+        <p:blipFill>
+          <a:blip xmlns:r="http://schemas.openxmlformats.org/officeDocument/2006/relationships" xmlns:a="http://schemas.openxmlformats.org/drawingml/2006/main" r:embed="R568997c70bd74330"/>
+          <a:stretch xmlns:a="http://schemas.openxmlformats.org/drawingml/2006/main"/>
+        </p:blipFill>
+        <p:spPr>
+          <a:xfrm xmlns:a="http://schemas.openxmlformats.org/drawingml/2006/main" flipH="0" flipV="0">
+            <a:off x="2322187" y="1885950"/>
+            <a:ext cx="7547626" cy="4248150"/>
+          </a:xfrm>
+          <a:prstGeom xmlns:a="http://schemas.openxmlformats.org/drawingml/2006/main" prst="roundRect">
+            <a:avLst/>
+          </a:prstGeom>
+        </p:spPr>
+      </p:pic>
+    </p:spTree>
+    <p:extLst>
+      <p:ext uri="{BB962C8B-B14F-4D97-AF65-F5344CB8AC3E}">
+        <p14:creationId xmlns:p14="http://schemas.microsoft.com/office/powerpoint/2010/main" val="1742728663"/>
+      </p:ext>
+    </p:extLst>
+  </p:cSld>
+</p:sld>
+</file>
+
 <file path=ppt/slides/slide6.xml><?xml version="1.0" encoding="utf-8"?>
 <p:sld xmlns:p="http://schemas.openxmlformats.org/presentationml/2006/main">
   <p:cSld>
@@ -33616,7 +33125,7 @@
           <a:lstStyle xmlns:a="http://schemas.openxmlformats.org/drawingml/2006/main"/>
           <a:p xmlns:a="http://schemas.openxmlformats.org/drawingml/2006/main">
             <a:r>
-              <a:t>The public control room answers: are the skills healthy?</a:t>
+              <a:t>Maintainers can drill from portfolio to exact task contracts</a:t>
             </a:r>
           </a:p>
         </p:txBody>
@@ -33659,120 +33168,6 @@
       </p:sp>
       <p:pic>
         <p:nvPicPr>
-          <p:cNvPr id="11" name=""/>
-          <p:cNvPicPr>
-            <a:picLocks xmlns:a="http://schemas.openxmlformats.org/drawingml/2006/main" noChangeAspect="1"/>
-          </p:cNvPicPr>
-          <p:nvPr/>
-        </p:nvPicPr>
-        <p:blipFill>
-          <a:blip xmlns:r="http://schemas.openxmlformats.org/officeDocument/2006/relationships" xmlns:a="http://schemas.openxmlformats.org/drawingml/2006/main" r:embed="R775010cb1fee4e0e"/>
-          <a:stretch xmlns:a="http://schemas.openxmlformats.org/drawingml/2006/main"/>
-        </p:blipFill>
-        <p:spPr>
-          <a:xfrm xmlns:a="http://schemas.openxmlformats.org/drawingml/2006/main" flipH="0" flipV="0">
-            <a:off x="2322187" y="1885950"/>
-            <a:ext cx="7547626" cy="4248150"/>
-          </a:xfrm>
-          <a:prstGeom xmlns:a="http://schemas.openxmlformats.org/drawingml/2006/main" prst="roundRect">
-            <a:avLst/>
-          </a:prstGeom>
-        </p:spPr>
-      </p:pic>
-    </p:spTree>
-    <p:extLst>
-      <p:ext uri="{BB962C8B-B14F-4D97-AF65-F5344CB8AC3E}">
-        <p14:creationId xmlns:p14="http://schemas.microsoft.com/office/powerpoint/2010/main" val="1742728663"/>
-      </p:ext>
-    </p:extLst>
-  </p:cSld>
-</p:sld>
-</file>
-
-<file path=ppt/slides/slide7.xml><?xml version="1.0" encoding="utf-8"?>
-<p:sld xmlns:p="http://schemas.openxmlformats.org/presentationml/2006/main">
-  <p:cSld>
-    <p:spTree>
-      <p:nvGrpSpPr>
-        <p:cNvPr id="1" name=""/>
-        <p:cNvGrpSpPr/>
-        <p:nvPr/>
-      </p:nvGrpSpPr>
-      <p:grpSpPr>
-        <a:xfrm xmlns:a="http://schemas.openxmlformats.org/drawingml/2006/main"/>
-      </p:grpSpPr>
-      <p:sp>
-        <p:nvSpPr>
-          <p:cNvPr id="2" name="Title 1">
-            <a:extLst xmlns:a="http://schemas.openxmlformats.org/drawingml/2006/main">
-              <a:ext uri="{FF2B5EF4-FFF2-40B4-BE49-F238E27FC236}">
-                <a16:creationId xmlns:a16="http://schemas.microsoft.com/office/drawing/2014/main" id="{F64C2A24-546D-C55C-2C52-97A4957F67E0}"/>
-              </a:ext>
-            </a:extLst>
-          </p:cNvPr>
-          <p:cNvSpPr>
-            <a:spLocks xmlns:a="http://schemas.openxmlformats.org/drawingml/2006/main" noGrp="1"/>
-          </p:cNvSpPr>
-          <p:nvPr>
-            <p:ph type="title" idx="0"/>
-          </p:nvPr>
-        </p:nvSpPr>
-        <p:spPr>
-          <a:xfrm xmlns:a="http://schemas.openxmlformats.org/drawingml/2006/main">
-            <a:off x="838200" y="365125"/>
-            <a:ext cx="10515600" cy="1325700"/>
-          </a:xfrm>
-        </p:spPr>
-        <p:txBody>
-          <a:bodyPr xmlns:a="http://schemas.openxmlformats.org/drawingml/2006/main">
-            <a:normAutofit fontScale="100000"/>
-          </a:bodyPr>
-          <a:lstStyle xmlns:a="http://schemas.openxmlformats.org/drawingml/2006/main"/>
-          <a:p xmlns:a="http://schemas.openxmlformats.org/drawingml/2006/main">
-            <a:r>
-              <a:t>Maintainers can drill from portfolio to exact task contracts</a:t>
-            </a:r>
-          </a:p>
-        </p:txBody>
-      </p:sp>
-      <p:sp>
-        <p:nvSpPr>
-          <p:cNvPr id="7" name="TextBox 6">
-            <a:extLst xmlns:a="http://schemas.openxmlformats.org/drawingml/2006/main">
-              <a:ext uri="{FF2B5EF4-FFF2-40B4-BE49-F238E27FC236}">
-                <a16:creationId xmlns:a16="http://schemas.microsoft.com/office/drawing/2014/main" id="{E2E6F043-0F84-54F7-A567-6E5851801779}"/>
-              </a:ext>
-            </a:extLst>
-          </p:cNvPr>
-          <p:cNvSpPr>
-            <a:spLocks xmlns:a="http://schemas.openxmlformats.org/drawingml/2006/main" noGrp="1"/>
-          </p:cNvSpPr>
-          <p:nvPr/>
-        </p:nvSpPr>
-        <p:spPr>
-          <a:xfrm xmlns:a="http://schemas.openxmlformats.org/drawingml/2006/main">
-            <a:off x="696174" y="6338986"/>
-            <a:ext cx="284052" cy="307777"/>
-          </a:xfrm>
-          <a:prstGeom xmlns:a="http://schemas.openxmlformats.org/drawingml/2006/main" prst="rect">
-            <a:avLst/>
-          </a:prstGeom>
-          <a:noFill xmlns:a="http://schemas.openxmlformats.org/drawingml/2006/main"/>
-        </p:spPr>
-        <p:txBody>
-          <a:bodyPr xmlns:a="http://schemas.openxmlformats.org/drawingml/2006/main" wrap="none">
-            <a:spAutoFit/>
-          </a:bodyPr>
-          <a:lstStyle xmlns:a="http://schemas.openxmlformats.org/drawingml/2006/main"/>
-          <a:p xmlns:a="http://schemas.openxmlformats.org/drawingml/2006/main">
-            <a:r>
-              <a:t>7</a:t>
-            </a:r>
-          </a:p>
-        </p:txBody>
-      </p:sp>
-      <p:pic>
-        <p:nvPicPr>
           <p:cNvPr id="16" name=""/>
           <p:cNvPicPr>
             <a:picLocks xmlns:a="http://schemas.openxmlformats.org/drawingml/2006/main" noChangeAspect="1"/>
@@ -33780,7 +33175,7 @@
           <p:nvPr/>
         </p:nvPicPr>
         <p:blipFill>
-          <a:blip xmlns:r="http://schemas.openxmlformats.org/officeDocument/2006/relationships" xmlns:a="http://schemas.openxmlformats.org/drawingml/2006/main" r:embed="R36104cc265634f38"/>
+          <a:blip xmlns:r="http://schemas.openxmlformats.org/officeDocument/2006/relationships" xmlns:a="http://schemas.openxmlformats.org/drawingml/2006/main" r:embed="Re9971616fcb647c2"/>
           <a:stretch xmlns:a="http://schemas.openxmlformats.org/drawingml/2006/main"/>
         </p:blipFill>
         <p:spPr>
@@ -33802,7 +33197,7 @@
           <p:nvPr/>
         </p:nvPicPr>
         <p:blipFill>
-          <a:blip xmlns:r="http://schemas.openxmlformats.org/officeDocument/2006/relationships" xmlns:a="http://schemas.openxmlformats.org/drawingml/2006/main" r:embed="Rb73ee2a552ee4990"/>
+          <a:blip xmlns:r="http://schemas.openxmlformats.org/officeDocument/2006/relationships" xmlns:a="http://schemas.openxmlformats.org/drawingml/2006/main" r:embed="R1ee3559e1c064f44"/>
           <a:stretch xmlns:a="http://schemas.openxmlformats.org/drawingml/2006/main"/>
         </p:blipFill>
         <p:spPr>
@@ -33947,6 +33342,120 @@
 </p:sld>
 </file>
 
+<file path=ppt/slides/slide7.xml><?xml version="1.0" encoding="utf-8"?>
+<p:sld xmlns:p="http://schemas.openxmlformats.org/presentationml/2006/main">
+  <p:cSld>
+    <p:spTree>
+      <p:nvGrpSpPr>
+        <p:cNvPr id="1" name=""/>
+        <p:cNvGrpSpPr/>
+        <p:nvPr/>
+      </p:nvGrpSpPr>
+      <p:grpSpPr>
+        <a:xfrm xmlns:a="http://schemas.openxmlformats.org/drawingml/2006/main"/>
+      </p:grpSpPr>
+      <p:sp>
+        <p:nvSpPr>
+          <p:cNvPr id="2" name="Title 1">
+            <a:extLst xmlns:a="http://schemas.openxmlformats.org/drawingml/2006/main">
+              <a:ext uri="{FF2B5EF4-FFF2-40B4-BE49-F238E27FC236}">
+                <a16:creationId xmlns:a16="http://schemas.microsoft.com/office/drawing/2014/main" id="{F64C2A24-546D-C55C-2C52-97A4957F67E0}"/>
+              </a:ext>
+            </a:extLst>
+          </p:cNvPr>
+          <p:cNvSpPr>
+            <a:spLocks xmlns:a="http://schemas.openxmlformats.org/drawingml/2006/main" noGrp="1"/>
+          </p:cNvSpPr>
+          <p:nvPr>
+            <p:ph type="title" idx="0"/>
+          </p:nvPr>
+        </p:nvSpPr>
+        <p:spPr>
+          <a:xfrm xmlns:a="http://schemas.openxmlformats.org/drawingml/2006/main">
+            <a:off x="838200" y="365125"/>
+            <a:ext cx="10515600" cy="1325700"/>
+          </a:xfrm>
+        </p:spPr>
+        <p:txBody>
+          <a:bodyPr xmlns:a="http://schemas.openxmlformats.org/drawingml/2006/main">
+            <a:normAutofit fontScale="100000"/>
+          </a:bodyPr>
+          <a:lstStyle xmlns:a="http://schemas.openxmlformats.org/drawingml/2006/main"/>
+          <a:p xmlns:a="http://schemas.openxmlformats.org/drawingml/2006/main">
+            <a:r>
+              <a:t>The methodology is deliberately claim-resistant</a:t>
+            </a:r>
+          </a:p>
+        </p:txBody>
+      </p:sp>
+      <p:sp>
+        <p:nvSpPr>
+          <p:cNvPr id="7" name="TextBox 6">
+            <a:extLst xmlns:a="http://schemas.openxmlformats.org/drawingml/2006/main">
+              <a:ext uri="{FF2B5EF4-FFF2-40B4-BE49-F238E27FC236}">
+                <a16:creationId xmlns:a16="http://schemas.microsoft.com/office/drawing/2014/main" id="{E2E6F043-0F84-54F7-A567-6E5851801779}"/>
+              </a:ext>
+            </a:extLst>
+          </p:cNvPr>
+          <p:cNvSpPr>
+            <a:spLocks xmlns:a="http://schemas.openxmlformats.org/drawingml/2006/main" noGrp="1"/>
+          </p:cNvSpPr>
+          <p:nvPr/>
+        </p:nvSpPr>
+        <p:spPr>
+          <a:xfrm xmlns:a="http://schemas.openxmlformats.org/drawingml/2006/main">
+            <a:off x="696174" y="6338986"/>
+            <a:ext cx="284052" cy="307777"/>
+          </a:xfrm>
+          <a:prstGeom xmlns:a="http://schemas.openxmlformats.org/drawingml/2006/main" prst="rect">
+            <a:avLst/>
+          </a:prstGeom>
+          <a:noFill xmlns:a="http://schemas.openxmlformats.org/drawingml/2006/main"/>
+        </p:spPr>
+        <p:txBody>
+          <a:bodyPr xmlns:a="http://schemas.openxmlformats.org/drawingml/2006/main" wrap="none">
+            <a:spAutoFit/>
+          </a:bodyPr>
+          <a:lstStyle xmlns:a="http://schemas.openxmlformats.org/drawingml/2006/main"/>
+          <a:p xmlns:a="http://schemas.openxmlformats.org/drawingml/2006/main">
+            <a:r>
+              <a:t>7</a:t>
+            </a:r>
+          </a:p>
+        </p:txBody>
+      </p:sp>
+      <p:pic>
+        <p:nvPicPr>
+          <p:cNvPr id="11" name=""/>
+          <p:cNvPicPr>
+            <a:picLocks xmlns:a="http://schemas.openxmlformats.org/drawingml/2006/main" noChangeAspect="1"/>
+          </p:cNvPicPr>
+          <p:nvPr/>
+        </p:nvPicPr>
+        <p:blipFill>
+          <a:blip xmlns:r="http://schemas.openxmlformats.org/officeDocument/2006/relationships" xmlns:a="http://schemas.openxmlformats.org/drawingml/2006/main" r:embed="R5281d3996e034655"/>
+          <a:stretch xmlns:a="http://schemas.openxmlformats.org/drawingml/2006/main"/>
+        </p:blipFill>
+        <p:spPr>
+          <a:xfrm xmlns:a="http://schemas.openxmlformats.org/drawingml/2006/main" flipH="0" flipV="0">
+            <a:off x="2322187" y="1885950"/>
+            <a:ext cx="7547626" cy="4248150"/>
+          </a:xfrm>
+          <a:prstGeom xmlns:a="http://schemas.openxmlformats.org/drawingml/2006/main" prst="roundRect">
+            <a:avLst/>
+          </a:prstGeom>
+        </p:spPr>
+      </p:pic>
+    </p:spTree>
+    <p:extLst>
+      <p:ext uri="{BB962C8B-B14F-4D97-AF65-F5344CB8AC3E}">
+        <p14:creationId xmlns:p14="http://schemas.microsoft.com/office/powerpoint/2010/main" val="1742728663"/>
+      </p:ext>
+    </p:extLst>
+  </p:cSld>
+</p:sld>
+</file>
+
 <file path=ppt/slides/slide8.xml><?xml version="1.0" encoding="utf-8"?>
 <p:sld xmlns:p="http://schemas.openxmlformats.org/presentationml/2006/main">
   <p:cSld>
@@ -33988,7 +33497,7 @@
           <a:lstStyle xmlns:a="http://schemas.openxmlformats.org/drawingml/2006/main"/>
           <a:p xmlns:a="http://schemas.openxmlformats.org/drawingml/2006/main">
             <a:r>
-              <a:t>The methodology is deliberately claim-resistant</a:t>
+              <a:t>Every claim lives inside a matched evaluation cell</a:t>
             </a:r>
           </a:p>
         </p:txBody>
@@ -34025,120 +33534,6 @@
           <a:p xmlns:a="http://schemas.openxmlformats.org/drawingml/2006/main">
             <a:r>
               <a:t>8</a:t>
-            </a:r>
-          </a:p>
-        </p:txBody>
-      </p:sp>
-      <p:pic>
-        <p:nvPicPr>
-          <p:cNvPr id="11" name=""/>
-          <p:cNvPicPr>
-            <a:picLocks xmlns:a="http://schemas.openxmlformats.org/drawingml/2006/main" noChangeAspect="1"/>
-          </p:cNvPicPr>
-          <p:nvPr/>
-        </p:nvPicPr>
-        <p:blipFill>
-          <a:blip xmlns:r="http://schemas.openxmlformats.org/officeDocument/2006/relationships" xmlns:a="http://schemas.openxmlformats.org/drawingml/2006/main" r:embed="R60df57cf7cc444a8"/>
-          <a:stretch xmlns:a="http://schemas.openxmlformats.org/drawingml/2006/main"/>
-        </p:blipFill>
-        <p:spPr>
-          <a:xfrm xmlns:a="http://schemas.openxmlformats.org/drawingml/2006/main" flipH="0" flipV="0">
-            <a:off x="2322187" y="1885950"/>
-            <a:ext cx="7547626" cy="4248150"/>
-          </a:xfrm>
-          <a:prstGeom xmlns:a="http://schemas.openxmlformats.org/drawingml/2006/main" prst="roundRect">
-            <a:avLst/>
-          </a:prstGeom>
-        </p:spPr>
-      </p:pic>
-    </p:spTree>
-    <p:extLst>
-      <p:ext uri="{BB962C8B-B14F-4D97-AF65-F5344CB8AC3E}">
-        <p14:creationId xmlns:p14="http://schemas.microsoft.com/office/powerpoint/2010/main" val="1742728663"/>
-      </p:ext>
-    </p:extLst>
-  </p:cSld>
-</p:sld>
-</file>
-
-<file path=ppt/slides/slide9.xml><?xml version="1.0" encoding="utf-8"?>
-<p:sld xmlns:p="http://schemas.openxmlformats.org/presentationml/2006/main">
-  <p:cSld>
-    <p:spTree>
-      <p:nvGrpSpPr>
-        <p:cNvPr id="1" name=""/>
-        <p:cNvGrpSpPr/>
-        <p:nvPr/>
-      </p:nvGrpSpPr>
-      <p:grpSpPr>
-        <a:xfrm xmlns:a="http://schemas.openxmlformats.org/drawingml/2006/main"/>
-      </p:grpSpPr>
-      <p:sp>
-        <p:nvSpPr>
-          <p:cNvPr id="2" name="Title 1">
-            <a:extLst xmlns:a="http://schemas.openxmlformats.org/drawingml/2006/main">
-              <a:ext uri="{FF2B5EF4-FFF2-40B4-BE49-F238E27FC236}">
-                <a16:creationId xmlns:a16="http://schemas.microsoft.com/office/drawing/2014/main" id="{F64C2A24-546D-C55C-2C52-97A4957F67E0}"/>
-              </a:ext>
-            </a:extLst>
-          </p:cNvPr>
-          <p:cNvSpPr>
-            <a:spLocks xmlns:a="http://schemas.openxmlformats.org/drawingml/2006/main" noGrp="1"/>
-          </p:cNvSpPr>
-          <p:nvPr>
-            <p:ph type="title" idx="0"/>
-          </p:nvPr>
-        </p:nvSpPr>
-        <p:spPr>
-          <a:xfrm xmlns:a="http://schemas.openxmlformats.org/drawingml/2006/main">
-            <a:off x="838200" y="365125"/>
-            <a:ext cx="10515600" cy="1325700"/>
-          </a:xfrm>
-        </p:spPr>
-        <p:txBody>
-          <a:bodyPr xmlns:a="http://schemas.openxmlformats.org/drawingml/2006/main">
-            <a:normAutofit fontScale="100000"/>
-          </a:bodyPr>
-          <a:lstStyle xmlns:a="http://schemas.openxmlformats.org/drawingml/2006/main"/>
-          <a:p xmlns:a="http://schemas.openxmlformats.org/drawingml/2006/main">
-            <a:r>
-              <a:t>Every claim lives inside a matched evaluation cell</a:t>
-            </a:r>
-          </a:p>
-        </p:txBody>
-      </p:sp>
-      <p:sp>
-        <p:nvSpPr>
-          <p:cNvPr id="7" name="TextBox 6">
-            <a:extLst xmlns:a="http://schemas.openxmlformats.org/drawingml/2006/main">
-              <a:ext uri="{FF2B5EF4-FFF2-40B4-BE49-F238E27FC236}">
-                <a16:creationId xmlns:a16="http://schemas.microsoft.com/office/drawing/2014/main" id="{E2E6F043-0F84-54F7-A567-6E5851801779}"/>
-              </a:ext>
-            </a:extLst>
-          </p:cNvPr>
-          <p:cNvSpPr>
-            <a:spLocks xmlns:a="http://schemas.openxmlformats.org/drawingml/2006/main" noGrp="1"/>
-          </p:cNvSpPr>
-          <p:nvPr/>
-        </p:nvSpPr>
-        <p:spPr>
-          <a:xfrm xmlns:a="http://schemas.openxmlformats.org/drawingml/2006/main">
-            <a:off x="696174" y="6338986"/>
-            <a:ext cx="284052" cy="307777"/>
-          </a:xfrm>
-          <a:prstGeom xmlns:a="http://schemas.openxmlformats.org/drawingml/2006/main" prst="rect">
-            <a:avLst/>
-          </a:prstGeom>
-          <a:noFill xmlns:a="http://schemas.openxmlformats.org/drawingml/2006/main"/>
-        </p:spPr>
-        <p:txBody>
-          <a:bodyPr xmlns:a="http://schemas.openxmlformats.org/drawingml/2006/main" wrap="none">
-            <a:spAutoFit/>
-          </a:bodyPr>
-          <a:lstStyle xmlns:a="http://schemas.openxmlformats.org/drawingml/2006/main"/>
-          <a:p xmlns:a="http://schemas.openxmlformats.org/drawingml/2006/main">
-            <a:r>
-              <a:t>9</a:t>
             </a:r>
           </a:p>
         </p:txBody>
@@ -34796,6 +34191,253 @@
                 </a:solidFill>
               </a:rPr>
               <a:t>Repeat across representative cells; report differences. Never average incompatible contexts into a universal score.</a:t>
+            </a:r>
+          </a:p>
+        </p:txBody>
+      </p:sp>
+    </p:spTree>
+    <p:extLst>
+      <p:ext uri="{BB962C8B-B14F-4D97-AF65-F5344CB8AC3E}">
+        <p14:creationId xmlns:p14="http://schemas.microsoft.com/office/powerpoint/2010/main" val="1742728663"/>
+      </p:ext>
+    </p:extLst>
+  </p:cSld>
+</p:sld>
+</file>
+
+<file path=ppt/slides/slide9.xml><?xml version="1.0" encoding="utf-8"?>
+<p:sld xmlns:p="http://schemas.openxmlformats.org/presentationml/2006/main">
+  <p:cSld>
+    <p:spTree>
+      <p:nvGrpSpPr>
+        <p:cNvPr id="1" name=""/>
+        <p:cNvGrpSpPr/>
+        <p:nvPr/>
+      </p:nvGrpSpPr>
+      <p:grpSpPr>
+        <a:xfrm xmlns:a="http://schemas.openxmlformats.org/drawingml/2006/main"/>
+      </p:grpSpPr>
+      <p:sp>
+        <p:nvSpPr>
+          <p:cNvPr id="2" name="Title 1">
+            <a:extLst xmlns:a="http://schemas.openxmlformats.org/drawingml/2006/main">
+              <a:ext uri="{FF2B5EF4-FFF2-40B4-BE49-F238E27FC236}">
+                <a16:creationId xmlns:a16="http://schemas.microsoft.com/office/drawing/2014/main" id="{F64C2A24-546D-C55C-2C52-97A4957F67E0}"/>
+              </a:ext>
+            </a:extLst>
+          </p:cNvPr>
+          <p:cNvSpPr>
+            <a:spLocks xmlns:a="http://schemas.openxmlformats.org/drawingml/2006/main" noGrp="1"/>
+          </p:cNvSpPr>
+          <p:nvPr>
+            <p:ph type="title" idx="0"/>
+          </p:nvPr>
+        </p:nvSpPr>
+        <p:spPr>
+          <a:xfrm xmlns:a="http://schemas.openxmlformats.org/drawingml/2006/main">
+            <a:off x="838200" y="365125"/>
+            <a:ext cx="10515600" cy="1325700"/>
+          </a:xfrm>
+        </p:spPr>
+        <p:txBody>
+          <a:bodyPr xmlns:a="http://schemas.openxmlformats.org/drawingml/2006/main">
+            <a:normAutofit fontScale="100000"/>
+          </a:bodyPr>
+          <a:lstStyle xmlns:a="http://schemas.openxmlformats.org/drawingml/2006/main"/>
+          <a:p xmlns:a="http://schemas.openxmlformats.org/drawingml/2006/main">
+            <a:r>
+              <a:t>Maintainer pushback is expected — and the answer is scoped evidence</a:t>
+            </a:r>
+          </a:p>
+        </p:txBody>
+      </p:sp>
+      <p:sp>
+        <p:nvSpPr>
+          <p:cNvPr id="3" name="Content Placeholder 2">
+            <a:extLst xmlns:a="http://schemas.openxmlformats.org/drawingml/2006/main">
+              <a:ext uri="{FF2B5EF4-FFF2-40B4-BE49-F238E27FC236}">
+                <a16:creationId xmlns:a16="http://schemas.microsoft.com/office/drawing/2014/main" id="{ECF5C9F1-2691-0BC9-F1E1-01CECB857FE3}"/>
+              </a:ext>
+            </a:extLst>
+          </p:cNvPr>
+          <p:cNvSpPr>
+            <a:spLocks xmlns:a="http://schemas.openxmlformats.org/drawingml/2006/main" noGrp="1"/>
+          </p:cNvSpPr>
+          <p:nvPr>
+            <p:ph type="body" idx="1"/>
+          </p:nvPr>
+        </p:nvSpPr>
+        <p:spPr>
+          <a:xfrm xmlns:a="http://schemas.openxmlformats.org/drawingml/2006/main">
+            <a:off x="838200" y="1825625"/>
+            <a:ext cx="10515600" cy="4351200"/>
+          </a:xfrm>
+        </p:spPr>
+        <p:txBody>
+          <a:bodyPr xmlns:a="http://schemas.openxmlformats.org/drawingml/2006/main" wrap="square" anchor="t">
+            <a:normAutofit fontScale="100000"/>
+          </a:bodyPr>
+          <a:lstStyle xmlns:a="http://schemas.openxmlformats.org/drawingml/2006/main"/>
+          <a:p xmlns:a="http://schemas.openxmlformats.org/drawingml/2006/main">
+            <a:pPr marL="30" indent="-18">
+              <a:spcAft>
+                <a:spcPts val="10"/>
+              </a:spcAft>
+              <a:buChar char="•"/>
+              <a:defRPr sz="1913">
+                <a:solidFill>
+                  <a:srgbClr val="000000"/>
+                </a:solidFill>
+              </a:defRPr>
+            </a:pPr>
+            <a:r>
+              <a:rPr sz="1913" b="1">
+                <a:solidFill>
+                  <a:srgbClr val="000000"/>
+                </a:solidFill>
+              </a:rPr>
+              <a:t> Do you test every combination? — No. We publish representative, risk-based cells and the gaps.</a:t>
+            </a:r>
+          </a:p>
+          <a:p xmlns:a="http://schemas.openxmlformats.org/drawingml/2006/main">
+            <a:pPr marL="30" indent="-18">
+              <a:spcAft>
+                <a:spcPts val="10"/>
+              </a:spcAft>
+              <a:buChar char="•"/>
+              <a:defRPr sz="1913">
+                <a:solidFill>
+                  <a:srgbClr val="000000"/>
+                </a:solidFill>
+              </a:defRPr>
+            </a:pPr>
+            <a:r>
+              <a:rPr sz="1913" b="1">
+                <a:solidFill>
+                  <a:srgbClr val="000000"/>
+                </a:solidFill>
+              </a:rPr>
+              <a:t> What changes invalidate evidence? — Re-run affected cells; older results remain history, not current proof.</a:t>
+            </a:r>
+          </a:p>
+          <a:p xmlns:a="http://schemas.openxmlformats.org/drawingml/2006/main">
+            <a:pPr marL="30" indent="-18">
+              <a:spcAft>
+                <a:spcPts val="10"/>
+              </a:spcAft>
+              <a:buChar char="•"/>
+              <a:defRPr sz="1913">
+                <a:solidFill>
+                  <a:srgbClr val="000000"/>
+                </a:solidFill>
+              </a:defRPr>
+            </a:pPr>
+            <a:r>
+              <a:rPr sz="1913" b="1">
+                <a:solidFill>
+                  <a:srgbClr val="000000"/>
+                </a:solidFill>
+              </a:rPr>
+              <a:t> How do you limit overfitting? — Maintainer incidents, hidden checks, negative controls, multiple tasks, and trajectory review.</a:t>
+            </a:r>
+          </a:p>
+          <a:p xmlns:a="http://schemas.openxmlformats.org/drawingml/2006/main">
+            <a:pPr marL="30" indent="-18">
+              <a:spcAft>
+                <a:spcPts val="10"/>
+              </a:spcAft>
+              <a:buChar char="•"/>
+              <a:defRPr sz="1913">
+                <a:solidFill>
+                  <a:srgbClr val="000000"/>
+                </a:solidFill>
+              </a:defRPr>
+            </a:pPr>
+            <a:r>
+              <a:rPr sz="1913" b="1">
+                <a:solidFill>
+                  <a:srgbClr val="000000"/>
+                </a:solidFill>
+              </a:rPr>
+              <a:t> What if every arm passes? — Keep it as smoke coverage; claim no lift and seek a harder task.</a:t>
+            </a:r>
+          </a:p>
+          <a:p xmlns:a="http://schemas.openxmlformats.org/drawingml/2006/main">
+            <a:pPr marL="30" indent="-18">
+              <a:spcAft>
+                <a:spcPts val="10"/>
+              </a:spcAft>
+              <a:buChar char="•"/>
+              <a:defRPr sz="1913">
+                <a:solidFill>
+                  <a:srgbClr val="000000"/>
+                </a:solidFill>
+              </a:defRPr>
+            </a:pPr>
+            <a:r>
+              <a:rPr sz="1913" b="1">
+                <a:solidFill>
+                  <a:srgbClr val="000000"/>
+                </a:solidFill>
+              </a:rPr>
+              <a:t> Does hardware qualification prove skill value? — No. Qualification and matched skill trials are separate gates.</a:t>
+            </a:r>
+          </a:p>
+          <a:p xmlns:a="http://schemas.openxmlformats.org/drawingml/2006/main">
+            <a:pPr marL="30" indent="-18">
+              <a:spcAft>
+                <a:spcPts val="10"/>
+              </a:spcAft>
+              <a:buChar char="•"/>
+              <a:defRPr sz="1913">
+                <a:solidFill>
+                  <a:srgbClr val="000000"/>
+                </a:solidFill>
+              </a:defRPr>
+            </a:pPr>
+            <a:r>
+              <a:rPr sz="1913" b="1">
+                <a:solidFill>
+                  <a:srgbClr val="000000"/>
+                </a:solidFill>
+              </a:rPr>
+              <a:t> Can scores be pooled? — No universal score; report conclusions within each model, harness, software, and environment cell.</a:t>
+            </a:r>
+          </a:p>
+        </p:txBody>
+      </p:sp>
+      <p:sp>
+        <p:nvSpPr>
+          <p:cNvPr id="7" name="TextBox 6">
+            <a:extLst xmlns:a="http://schemas.openxmlformats.org/drawingml/2006/main">
+              <a:ext uri="{FF2B5EF4-FFF2-40B4-BE49-F238E27FC236}">
+                <a16:creationId xmlns:a16="http://schemas.microsoft.com/office/drawing/2014/main" id="{E2E6F043-0F84-54F7-A567-6E5851801779}"/>
+              </a:ext>
+            </a:extLst>
+          </p:cNvPr>
+          <p:cNvSpPr>
+            <a:spLocks xmlns:a="http://schemas.openxmlformats.org/drawingml/2006/main" noGrp="1"/>
+          </p:cNvSpPr>
+          <p:nvPr/>
+        </p:nvSpPr>
+        <p:spPr>
+          <a:xfrm xmlns:a="http://schemas.openxmlformats.org/drawingml/2006/main">
+            <a:off x="696174" y="6338986"/>
+            <a:ext cx="284052" cy="307777"/>
+          </a:xfrm>
+          <a:prstGeom xmlns:a="http://schemas.openxmlformats.org/drawingml/2006/main" prst="rect">
+            <a:avLst/>
+          </a:prstGeom>
+          <a:noFill xmlns:a="http://schemas.openxmlformats.org/drawingml/2006/main"/>
+        </p:spPr>
+        <p:txBody>
+          <a:bodyPr xmlns:a="http://schemas.openxmlformats.org/drawingml/2006/main" wrap="none">
+            <a:spAutoFit/>
+          </a:bodyPr>
+          <a:lstStyle xmlns:a="http://schemas.openxmlformats.org/drawingml/2006/main"/>
+          <a:p xmlns:a="http://schemas.openxmlformats.org/drawingml/2006/main">
+            <a:r>
+              <a:t>9</a:t>
             </a:r>
           </a:p>
         </p:txBody>

</xml_diff>